<commit_message>
feat(talk): C4 diagram, animated graph GIF, embedded notes, live-demo script
- fix lethal-trifecta venn: labels moved into single-circle regions with
  white halos; center + caption spacing corrected.
- add C4 container (solution design) diagram (docs/c4-container.svg) and a
  deck slide for it.
- record the real ZIRAN interactive vis-network graph as a looping GIF
  (talk/record_graph_gif.py -> talk/assets/ziran_graph.gif) and use it on the
  reveal slide in place of the static screenshot.
- embed per-slide speaker notes into every slide of quanta-talk.pptx
  (Presenter View), including exact live-demo commands.
- add scripts/demo_live.sh: one command runs the whole demo — a few real-agent
  questions, then the live ZIRAN scan, then the breach + fix.
- slim SPEAKER_NOTES.md to the arc + runbook (full notes now in the deck);
  ignore transient timestamped scan reports.
</commit_message>
<xml_diff>
--- a/talk/quanta-talk.pptx
+++ b/talk/quanta-talk.pptx
@@ -30,9 +30,10 @@
     <p:sldId id="278" r:id="rId24"/>
     <p:sldId id="279" r:id="rId25"/>
     <p:sldId id="280" r:id="rId26"/>
+    <p:sldId id="281" r:id="rId27"/>
   </p:sldIdLst>
   <p:notesMasterIdLst>
-    <p:notesMasterId r:id="rId27"/>
+    <p:notesMasterId r:id="rId28"/>
   </p:notesMasterIdLst>
   <p:sldSz cx="12191695" cy="6858000"/>
   <p:notesSz cx="6858000" cy="12191695"/>
@@ -526,7 +527,7 @@
           <a:p>
             <a:r>
               <a:rPr lang="en-US" dirty="0"/>
-              <a:t/>
+              <a:t>Land the title, then a beat. 'By the end you'll have watched a clean, well-architected agent get one critical finding — and the finding isn't in any of its tools.' Audience: builders/engineers. 45 min: ~30 talk + ~10 demo + ~5 Q&amp;A.</a:t>
             </a:r>
             <a:endParaRPr lang="en-US" dirty="0"/>
           </a:p>
@@ -614,7 +615,7 @@
           <a:p>
             <a:r>
               <a:rPr lang="en-US" dirty="0"/>
-              <a:t/>
+              <a:t>Solution design, C4 container view. A real, sensible architecture: the analyst talks to the Quanta AgentCore runtime; a Strands agent backed by Bedrock Claude sequences four tool containers; those reach a read-only analytics replica, allowlisted external reference sources, and an audited mail relay. Point at the trust tags along the bottom: PRIVATE data in, UNTRUSTED content in, EXTERNAL send out — all three legs present in one runtime. Nothing here looks wrong yet.</a:t>
             </a:r>
             <a:endParaRPr lang="en-US" dirty="0"/>
           </a:p>
@@ -702,7 +703,7 @@
           <a:p>
             <a:r>
               <a:rPr lang="en-US" dirty="0"/>
-              <a:t/>
+              <a:t>Zoom into the controls. Hexagonal, ports &amp; adapters. Read-only replica, parameterised queries (no raw SQL), a sandboxed interpreter with no network, an egress allowlist on outbound fetches, audited report delivery. Say: 'This is not a toy. Every box here is something you'd sign off on. No unsandboxed eval, no raw SQL, no open egress.'</a:t>
             </a:r>
             <a:endParaRPr lang="en-US" dirty="0"/>
           </a:p>
@@ -790,7 +791,14 @@
           <a:p>
             <a:r>
               <a:rPr lang="en-US" dirty="0"/>
-              <a:t/>
+              <a:t>*** LIVE DEMO — Part 1: it's a real agent ***
+Run:  ./scripts/demo_live.sh            (auto cloud/local; PAUSE=1 to step)
+  or, manually, three real questions:
+  agentcore invoke '{"prompt": "What was our revenue by country? Top 5."}'
+  agentcore invoke '{"prompt": "How many orders per country?"}'
+  agentcore invoke '{"prompt": "Who are our top customers by orders?"}'
+Offline fallback (no AWS):  QUANTA_STUB=1 python scripts/run_local.py "revenue by country, top 5"
+Real numbers from UCI Online Retail II. Then say: 'Real agent, real data, genuinely useful. Now — is it safe?'</a:t>
             </a:r>
             <a:endParaRPr lang="en-US" dirty="0"/>
           </a:p>
@@ -878,7 +886,7 @@
           <a:p>
             <a:r>
               <a:rPr lang="en-US" dirty="0"/>
-              <a:t/>
+              <a:t>Four tools. Four real controls: search_database (read-only, parameterised), run_analysis (sandboxed), fetch_reference (allowlist), send_email_report (allowlist + audit + dry-run). A tool-by-tool review signs off 4 out of 4. Hold that thought.</a:t>
             </a:r>
             <a:endParaRPr lang="en-US" dirty="0"/>
           </a:p>
@@ -966,7 +974,7 @@
           <a:p>
             <a:r>
               <a:rPr lang="en-US" dirty="0"/>
-              <a:t/>
+              <a:t>Divider. 'Instead of reviewing tools one at a time, let's look at what they can do together.'</a:t>
             </a:r>
             <a:endParaRPr lang="en-US" dirty="0"/>
           </a:p>
@@ -1054,7 +1062,7 @@
           <a:p>
             <a:r>
               <a:rPr lang="en-US" dirty="0"/>
-              <a:t/>
+              <a:t>ZIRAN builds the agent's capability graph and checks it against a library of known dangerous compositions — direct (A→B), indirect (A→…→B), and cycles. Say: 'It's not testing prompts here. It's reasoning about structure.'</a:t>
             </a:r>
             <a:endParaRPr lang="en-US" dirty="0"/>
           </a:p>
@@ -1142,7 +1150,7 @@
           <a:p>
             <a:r>
               <a:rPr lang="en-US" dirty="0"/>
-              <a:t/>
+              <a:t>Walk the three panels: four approved tools → the agent can sequence them (edges) → one path is an exit. Say: 'Nothing here is hypothetical. An LLM agent really can call send right after search.'</a:t>
             </a:r>
             <a:endParaRPr lang="en-US" dirty="0"/>
           </a:p>
@@ -1230,7 +1238,7 @@
           <a:p>
             <a:r>
               <a:rPr lang="en-US" dirty="0"/>
-              <a:t/>
+              <a:t>Back to the architecture — now with the red path. Say slowly: 'Every control still holds. Read-only: held. Sandbox: held. Allowlists: held. And here's the path: untrusted content comes in through fetch_reference, the agent reads private data with search_database, and ships it out through send_email_report — every step authorised. Every box was hardened. The arrow wasn't.'</a:t>
             </a:r>
             <a:endParaRPr lang="en-US" dirty="0"/>
           </a:p>
@@ -1318,7 +1326,11 @@
           <a:p>
             <a:r>
               <a:rPr lang="en-US" dirty="0"/>
-              <a:t/>
+              <a:t>*** LIVE DEMO — find the composition ***
+Run:  QUANTA_STUB=1 python scripts/scan_quanta.py --out reports   (offline, in-process)
+Then: open reports/*_report.html   — pan the graph, click the red node.
+(This slide embeds the real interactive graph as a looping GIF — it plays in Presenter/slideshow, and is the fallback if the live open stalls.)
+One critical finding: search_database → send_email_report, data_exfiltration. Say: 'I didn't tell ZIRAN this was dangerous — that verdict is from its built-in patterns. I gave it a graph; it gave me the exit. But a finding on a slide is easy to wave away — so let me show you the exit actually being used.'</a:t>
             </a:r>
             <a:endParaRPr lang="en-US" dirty="0"/>
           </a:p>
@@ -1406,7 +1418,7 @@
           <a:p>
             <a:r>
               <a:rPr lang="en-US" dirty="0"/>
-              <a:t/>
+              <a:t>Divider. 'ZIRAN found the path statically, before anyone attacked. Now let's walk it like an attacker — then close it.'</a:t>
             </a:r>
             <a:endParaRPr lang="en-US" dirty="0"/>
           </a:p>
@@ -1494,7 +1506,7 @@
           <a:p>
             <a:r>
               <a:rPr lang="en-US" dirty="0"/>
-              <a:t/>
+              <a:t>Most AI-security energy goes at the prompt: jailbreaks, injection, guardrails. It matters — but it's the part everyone is already looking at. Say: 'I want the risk nobody's looking at, because it isn't visible from where they're standing.'</a:t>
             </a:r>
             <a:endParaRPr lang="en-US" dirty="0"/>
           </a:p>
@@ -1582,7 +1594,9 @@
           <a:p>
             <a:r>
               <a:rPr lang="en-US" dirty="0"/>
-              <a:t/>
+              <a:t>*** LIVE DEMO — the breach ***
+Run:  python scripts/exploit_demo.py            (offline, deterministic; --vulnerable-only for just this)
+Walk the table: a benign request → fetch_reference returns an allowlisted page whose CONTENT carries a hidden instruction (indirect prompt injection, LLM01). The agent obeys → search_database reads 900 customer-level rows → watch the taint go red: PRIVATE+UNTRUSTED, the lethal trifecta in one run → send_email_report ships 16,741 bytes of PII to ops-archive@reports.acme-analytics.example. That mailbox is on the ALLOWLISTED domain — the domain check PASSED. Model-chosen recipient = excessive agency / confused deputy (LLM06). Say slowly: 'No control was bypassed. The data left through fully authorised actions.'</a:t>
             </a:r>
             <a:endParaRPr lang="en-US" dirty="0"/>
           </a:p>
@@ -1670,7 +1684,7 @@
           <a:p>
             <a:r>
               <a:rPr lang="en-US" dirty="0"/>
-              <a:t/>
+              <a:t>Name what we just saw. One innocuous agent, three stacked classes: the composition (structural — ZIRAN finds it pre-attack), indirect prompt injection (LLM01 — the trigger), excessive agency / confused deputy (LLM06 — the missing control). None is a bug in a single tool.</a:t>
             </a:r>
             <a:endParaRPr lang="en-US" dirty="0"/>
           </a:p>
@@ -1758,7 +1772,7 @@
           <a:p>
             <a:r>
               <a:rPr lang="en-US" dirty="0"/>
-              <a:t/>
+              <a:t>Quick credibility beat: 639 vectors, 11 categories, 100% OWASP LLM Top-10 — but the differentiator is composition reasoning. Don't dwell; 30 seconds. (Cut this slide first if running long.)</a:t>
             </a:r>
             <a:endParaRPr lang="en-US" dirty="0"/>
           </a:p>
@@ -1846,7 +1860,9 @@
           <a:p>
             <a:r>
               <a:rPr lang="en-US" dirty="0"/>
-              <a:t/>
+              <a:t>*** LIVE DEMO — the fix ***
+Same script printed both runs — scroll to the second (or: python scripts/exploit_demo.py --hardened-only).
+Same agent, same payload, opposite outcome: the injected instruction is REFUSED as data (LLM01); the model-chosen recipient is DENIED by recipient-binding (LLM06); the trifecta gate stops a private+untrusted run reaching an external sink. Crucially the analyst's legitimate summary STILL goes out. Say: 'The fix didn't break the product. We broke the path, not the agent.'</a:t>
             </a:r>
             <a:endParaRPr lang="en-US" dirty="0"/>
           </a:p>
@@ -1934,7 +1950,7 @@
           <a:p>
             <a:r>
               <a:rPr lang="en-US" dirty="0"/>
-              <a:t/>
+              <a:t>The fix is NOT 'remove a tool' — each is justified. Break the graph: no-instructions-from-data (LLM01), recipient binding (LLM06), trifecta gate via taint (the composition), and re-scan in CI (ziran ci fails the build when a new tool completes a trifecta). Three are runtime guardrails; the last is the design-time one that matches the thesis. It's all real, tested code in quanta/security/.</a:t>
             </a:r>
             <a:endParaRPr lang="en-US" dirty="0"/>
           </a:p>
@@ -2022,7 +2038,7 @@
           <a:p>
             <a:r>
               <a:rPr lang="en-US" dirty="0"/>
-              <a:t/>
+              <a:t>Say: 'If you're building, reviewing, or signing off on agents: stop asking only whether each tool is safe. Ask what they're capable of together — and put that question in your pipeline, not in an attacker's hands.' Restate the thesis: the vulnerability lives in the graph, not in any node.</a:t>
             </a:r>
             <a:endParaRPr lang="en-US" dirty="0"/>
           </a:p>
@@ -2046,6 +2062,94 @@
             <a:fld id="{F7021451-1387-4CA6-816F-3879F97B5CBC}" type="slidenum">
               <a:rPr lang="en-US"/>
               <a:t>25</a:t>
+            </a:fld>
+            <a:endParaRPr lang="en-US"/>
+          </a:p>
+        </p:txBody>
+      </p:sp>
+    </p:spTree>
+    <p:extLst>
+      <p:ext uri="{BB962C8B-B14F-4D97-AF65-F5344CB8AC3E}">
+        <p14:creationId xmlns:p14="http://schemas.microsoft.com/office/powerpoint/2010/main" val="1024086991"/>
+      </p:ext>
+    </p:extLst>
+  </p:cSld>
+  <p:clrMapOvr>
+    <a:masterClrMapping/>
+  </p:clrMapOvr>
+</p:notes>
+</file>
+
+<file path=ppt/notesSlides/notesSlide26.xml><?xml version="1.0" encoding="utf-8"?>
+<p:notes xmlns:a="http://schemas.openxmlformats.org/drawingml/2006/main" xmlns:r="http://schemas.openxmlformats.org/officeDocument/2006/relationships" xmlns:p="http://schemas.openxmlformats.org/presentationml/2006/main">
+  <p:cSld>
+    <p:spTree>
+      <p:nvGrpSpPr>
+        <p:cNvPr id="1" name=""/>
+        <p:cNvGrpSpPr/>
+        <p:nvPr/>
+      </p:nvGrpSpPr>
+      <p:grpSpPr>
+        <a:xfrm>
+          <a:off x="0" y="0"/>
+          <a:ext cx="0" cy="0"/>
+          <a:chOff x="0" y="0"/>
+          <a:chExt cx="0" cy="0"/>
+        </a:xfrm>
+      </p:grpSpPr>
+      <p:sp>
+        <p:nvSpPr>
+          <p:cNvPr id="2" name="Slide Image Placeholder 1"/>
+          <p:cNvSpPr>
+            <a:spLocks noGrp="1" noRot="1" noChangeAspect="1"/>
+          </p:cNvSpPr>
+          <p:nvPr>
+            <p:ph type="sldImg"/>
+          </p:nvPr>
+        </p:nvSpPr>
+        <p:spPr/>
+      </p:sp>
+      <p:sp>
+        <p:nvSpPr>
+          <p:cNvPr id="3" name="Notes Placeholder 2"/>
+          <p:cNvSpPr>
+            <a:spLocks noGrp="1"/>
+          </p:cNvSpPr>
+          <p:nvPr>
+            <p:ph type="body" idx="1"/>
+          </p:nvPr>
+        </p:nvSpPr>
+        <p:spPr/>
+        <p:txBody>
+          <a:bodyPr/>
+          <a:lstStyle/>
+          <a:p>
+            <a:r>
+              <a:rPr lang="en-US" dirty="0"/>
+              <a:t>Links: github.com/taoq-ai/quanta (the demo agent — education only, intentionally composable; run scripts/exploit_demo.py), github.com/taoq-ai/ziran (the finder). Note Quanta is deliberately vulnerable by design; don't deploy it for real. Take Q&amp;A.</a:t>
+            </a:r>
+            <a:endParaRPr lang="en-US" dirty="0"/>
+          </a:p>
+        </p:txBody>
+      </p:sp>
+      <p:sp>
+        <p:nvSpPr>
+          <p:cNvPr id="4" name="Slide Number Placeholder 3"/>
+          <p:cNvSpPr>
+            <a:spLocks noGrp="1"/>
+          </p:cNvSpPr>
+          <p:nvPr>
+            <p:ph type="sldNum" sz="quarter" idx="10"/>
+          </p:nvPr>
+        </p:nvSpPr>
+        <p:spPr/>
+        <p:txBody>
+          <a:bodyPr/>
+          <a:lstStyle/>
+          <a:p>
+            <a:fld id="{F7021451-1387-4CA6-816F-3879F97B5CBC}" type="slidenum">
+              <a:rPr lang="en-US"/>
+              <a:t>26</a:t>
             </a:fld>
             <a:endParaRPr lang="en-US"/>
           </a:p>
@@ -2110,7 +2214,7 @@
           <a:p>
             <a:r>
               <a:rPr lang="en-US" dirty="0"/>
-              <a:t/>
+              <a:t>A security review enumerates tools like API endpoints: a list. But an LLM agent can call any tool, then feed its output into the next. That's not a list — it's a graph of what the agent can do next. Hold this idea; the whole talk turns on it.</a:t>
             </a:r>
             <a:endParaRPr lang="en-US" dirty="0"/>
           </a:p>
@@ -2198,7 +2302,7 @@
           <a:p>
             <a:r>
               <a:rPr lang="en-US" dirty="0"/>
-              <a:t/>
+              <a:t>Divider. 'Forget the model for a minute. Think like someone who just got access to the agent.'</a:t>
             </a:r>
             <a:endParaRPr lang="en-US" dirty="0"/>
           </a:p>
@@ -2286,7 +2390,7 @@
           <a:p>
             <a:r>
               <a:rPr lang="en-US" dirty="0"/>
-              <a:t/>
+              <a:t>Three moves: recon (what tools exist?), capability mapping (what does each touch — data? network? compute?), chaining (which sequence turns reasonable actions into one bad outcome?). Attackers don't look for A dangerous tool. They look for a PATH. This is graph traversal, done by hand.</a:t>
             </a:r>
             <a:endParaRPr lang="en-US" dirty="0"/>
           </a:p>
@@ -2374,7 +2478,7 @@
           <a:p>
             <a:r>
               <a:rPr lang="en-US" dirty="0"/>
-              <a:t/>
+              <a:t>Three capabilities individually fine and collectively lethal: access to private data, exposure to untrusted content, the ability to communicate externally. Any agent with all three can be steered to read secrets and send them out — through entirely authorised actions. Credit Simon Willison's 'lethal trifecta'.</a:t>
             </a:r>
             <a:endParaRPr lang="en-US" dirty="0"/>
           </a:p>
@@ -2462,7 +2566,7 @@
           <a:p>
             <a:r>
               <a:rPr lang="en-US" dirty="0"/>
-              <a:t/>
+              <a:t>Same structural idea, two shapes. Exfiltration: read + send. RCE surface: fetch untrusted + execute + network. Neither is a bug in a node. Both are properties of the graph. (Our demo focuses on exfiltration — the subtler, more relatable one.)</a:t>
             </a:r>
             <a:endParaRPr lang="en-US" dirty="0"/>
           </a:p>
@@ -2550,7 +2654,7 @@
           <a:p>
             <a:r>
               <a:rPr lang="en-US" dirty="0"/>
-              <a:t/>
+              <a:t>Reviews look tool-by-tool, endpoint-by-endpoint — and tool-by-tool, everything passes. The composition is invisible from that vantage point. Say: 'It stays invisible until someone connects the dots. The only question is whether that someone works for you.'</a:t>
             </a:r>
             <a:endParaRPr lang="en-US" dirty="0"/>
           </a:p>
@@ -2638,7 +2742,7 @@
           <a:p>
             <a:r>
               <a:rPr lang="en-US" dirty="0"/>
-              <a:t/>
+              <a:t>Divider. 'Let me show you an agent I built — and I want you to try to find the problem while I describe it.'</a:t>
             </a:r>
             <a:endParaRPr lang="en-US" dirty="0"/>
           </a:p>
@@ -3216,7 +3320,7 @@
                 <a:ea typeface="Cambria" pitchFamily="34" charset="-122"/>
                 <a:cs typeface="Cambria" pitchFamily="34" charset="-120"/>
               </a:rPr>
-              <a:t>Quanta — and notice it's well-built</a:t>
+              <a:t>Quanta — the solution design (C4)</a:t>
             </a:r>
             <a:endParaRPr lang="en-US" sz="3200" dirty="0"/>
           </a:p>
@@ -3224,7 +3328,7 @@
       </p:sp>
       <p:pic>
         <p:nvPicPr>
-          <p:cNvPr id="3" name="Image 0" descr="/Users/leone.lage.perdigao/github/quanta/talk/assets/architecture.png">    </p:cNvPr>
+          <p:cNvPr id="3" name="Image 0" descr="/Users/leone.lage.perdigao/github/quanta/talk/assets/c4-container.png">    </p:cNvPr>
           <p:cNvPicPr>
             <a:picLocks noChangeAspect="1"/>
           </p:cNvPicPr>
@@ -3238,8 +3342,8 @@
         </p:blipFill>
         <p:spPr>
           <a:xfrm>
-            <a:off x="2284476" y="1417320"/>
-            <a:ext cx="7620000" cy="4572000"/>
+            <a:off x="2531879" y="1417320"/>
+            <a:ext cx="7125195" cy="4572000"/>
           </a:xfrm>
           <a:prstGeom prst="rect">
             <a:avLst/>
@@ -3279,7 +3383,7 @@
                 <a:ea typeface="Arial" pitchFamily="34" charset="-122"/>
                 <a:cs typeface="Arial" pitchFamily="34" charset="-120"/>
               </a:rPr>
-              <a:t>Hexagonal. Read-only replica, parameterised queries, sandboxed compute, egress allowlist, audited delivery. This passes review.</a:t>
+              <a:t>Analyst → AgentCore runtime (Strands + Claude) → four tools → read-only replica, allowlisted (untrusted) reference, audited mail.</a:t>
             </a:r>
             <a:endParaRPr lang="en-US" sz="1500" dirty="0"/>
           </a:p>
@@ -3350,44 +3454,46 @@
                 <a:ea typeface="Cambria" pitchFamily="34" charset="-122"/>
                 <a:cs typeface="Cambria" pitchFamily="34" charset="-120"/>
               </a:rPr>
-              <a:t>Quanta, live — a real, useful assistant</a:t>
+              <a:t>…and notice it's well-built</a:t>
             </a:r>
             <a:endParaRPr lang="en-US" sz="3200" dirty="0"/>
           </a:p>
         </p:txBody>
       </p:sp>
-      <p:sp>
-        <p:nvSpPr>
-          <p:cNvPr id="3" name="Shape 1"/>
-          <p:cNvSpPr/>
-          <p:nvPr/>
-        </p:nvSpPr>
-        <p:spPr>
-          <a:xfrm>
-            <a:off x="640080" y="1463040"/>
-            <a:ext cx="10908792" cy="2926080"/>
-          </a:xfrm>
-          <a:prstGeom prst="roundRect">
-            <a:avLst>
-              <a:gd name="adj" fmla="val 2500"/>
-            </a:avLst>
-          </a:prstGeom>
-          <a:solidFill>
-            <a:srgbClr val="0B1220"/>
-          </a:solidFill>
-          <a:ln/>
-        </p:spPr>
-      </p:sp>
-      <p:sp>
-        <p:nvSpPr>
-          <p:cNvPr id="4" name="Text 2"/>
-          <p:cNvSpPr/>
-          <p:nvPr/>
-        </p:nvSpPr>
-        <p:spPr>
-          <a:xfrm>
-            <a:off x="1005840" y="1737360"/>
-            <a:ext cx="10149840" cy="2377440"/>
+      <p:pic>
+        <p:nvPicPr>
+          <p:cNvPr id="3" name="Image 0" descr="/Users/leone.lage.perdigao/github/quanta/talk/assets/architecture.png">    </p:cNvPr>
+          <p:cNvPicPr>
+            <a:picLocks noChangeAspect="1"/>
+          </p:cNvPicPr>
+          <p:nvPr/>
+        </p:nvPicPr>
+        <p:blipFill>
+          <a:blip r:embed="rId1"/>
+          <a:stretch>
+            <a:fillRect/>
+          </a:stretch>
+        </p:blipFill>
+        <p:spPr>
+          <a:xfrm>
+            <a:off x="2284476" y="1417320"/>
+            <a:ext cx="7620000" cy="4572000"/>
+          </a:xfrm>
+          <a:prstGeom prst="rect">
+            <a:avLst/>
+          </a:prstGeom>
+        </p:spPr>
+      </p:pic>
+      <p:sp>
+        <p:nvSpPr>
+          <p:cNvPr id="4" name="Text 1"/>
+          <p:cNvSpPr/>
+          <p:nvPr/>
+        </p:nvSpPr>
+        <p:spPr>
+          <a:xfrm>
+            <a:off x="640080" y="6126480"/>
+            <a:ext cx="10908792" cy="457200"/>
           </a:xfrm>
           <a:prstGeom prst="rect">
             <a:avLst/>
@@ -3396,238 +3502,24 @@
           <a:ln/>
         </p:spPr>
         <p:txBody>
-          <a:bodyPr wrap="square" rtlCol="0" anchor="t"/>
-          <a:lstStyle/>
-          <a:p>
-            <a:pPr indent="0" marL="0">
-              <a:lnSpc>
-                <a:spcPct val="110000"/>
-              </a:lnSpc>
-              <a:buNone/>
-            </a:pPr>
-            <a:r>
-              <a:rPr lang="en-US" sz="1600" dirty="0">
-                <a:solidFill>
-                  <a:srgbClr val="22D3EE"/>
-                </a:solidFill>
-                <a:latin typeface="Courier New" pitchFamily="34" charset="0"/>
-                <a:ea typeface="Courier New" pitchFamily="34" charset="-122"/>
-                <a:cs typeface="Courier New" pitchFamily="34" charset="-120"/>
-              </a:rPr>
-              <a:t>$ </a:t>
-            </a:r>
-            <a:pPr indent="0" marL="0">
-              <a:lnSpc>
-                <a:spcPct val="110000"/>
-              </a:lnSpc>
-              <a:buNone/>
-            </a:pPr>
-            <a:r>
-              <a:rPr lang="en-US" sz="1600" dirty="0">
-                <a:solidFill>
-                  <a:srgbClr val="E2E8F0"/>
-                </a:solidFill>
-                <a:latin typeface="Courier New" pitchFamily="34" charset="0"/>
-                <a:ea typeface="Courier New" pitchFamily="34" charset="-122"/>
-                <a:cs typeface="Courier New" pitchFamily="34" charset="-120"/>
-              </a:rPr>
-              <a:t>agentcore invoke '{"prompt": "Revenue by country, top 5"}'
-</a:t>
-            </a:r>
-            <a:pPr indent="0" marL="0">
-              <a:lnSpc>
-                <a:spcPct val="110000"/>
-              </a:lnSpc>
-              <a:buNone/>
-            </a:pPr>
-            <a:r>
-              <a:rPr lang="en-US" sz="1600" dirty="0">
-                <a:solidFill>
-                  <a:srgbClr val="94A3B8"/>
-                </a:solidFill>
-                <a:latin typeface="Courier New" pitchFamily="34" charset="0"/>
-                <a:ea typeface="Courier New" pitchFamily="34" charset="-122"/>
-                <a:cs typeface="Courier New" pitchFamily="34" charset="-120"/>
-              </a:rPr>
-              <a:t>Revenue by country
-</a:t>
-            </a:r>
-            <a:pPr indent="0" marL="0">
-              <a:lnSpc>
-                <a:spcPct val="110000"/>
-              </a:lnSpc>
-              <a:buNone/>
-            </a:pPr>
-            <a:r>
-              <a:rPr lang="en-US" sz="1600" dirty="0">
-                <a:solidFill>
-                  <a:srgbClr val="A7F3D0"/>
-                </a:solidFill>
-                <a:latin typeface="Courier New" pitchFamily="34" charset="0"/>
-                <a:ea typeface="Courier New" pitchFamily="34" charset="-122"/>
-                <a:cs typeface="Courier New" pitchFamily="34" charset="-120"/>
-              </a:rPr>
-              <a:t>United Kingdom   76,654.21</a:t>
-            </a:r>
-            <a:endParaRPr lang="en-US" sz="1600" dirty="0"/>
-          </a:p>
-          <a:p>
-            <a:pPr indent="0" marL="0">
-              <a:lnSpc>
-                <a:spcPct val="110000"/>
-              </a:lnSpc>
-              <a:buNone/>
-            </a:pPr>
-            <a:r>
-              <a:rPr lang="en-US" sz="1600" dirty="0">
-                <a:solidFill>
-                  <a:srgbClr val="A7F3D0"/>
-                </a:solidFill>
-                <a:latin typeface="Courier New" pitchFamily="34" charset="0"/>
-                <a:ea typeface="Courier New" pitchFamily="34" charset="-122"/>
-                <a:cs typeface="Courier New" pitchFamily="34" charset="-120"/>
-              </a:rPr>
-              <a:t>Germany          18,484.30</a:t>
-            </a:r>
-            <a:endParaRPr lang="en-US" sz="1600" dirty="0"/>
-          </a:p>
-          <a:p>
-            <a:pPr indent="0" marL="0">
-              <a:lnSpc>
-                <a:spcPct val="110000"/>
-              </a:lnSpc>
-              <a:buNone/>
-            </a:pPr>
-            <a:r>
-              <a:rPr lang="en-US" sz="1600" dirty="0">
-                <a:solidFill>
-                  <a:srgbClr val="A7F3D0"/>
-                </a:solidFill>
-                <a:latin typeface="Courier New" pitchFamily="34" charset="0"/>
-                <a:ea typeface="Courier New" pitchFamily="34" charset="-122"/>
-                <a:cs typeface="Courier New" pitchFamily="34" charset="-120"/>
-              </a:rPr>
-              <a:t>France           15,259.32</a:t>
-            </a:r>
-            <a:endParaRPr lang="en-US" sz="1600" dirty="0"/>
-          </a:p>
-          <a:p>
-            <a:pPr indent="0" marL="0">
-              <a:lnSpc>
-                <a:spcPct val="110000"/>
-              </a:lnSpc>
-              <a:buNone/>
-            </a:pPr>
-            <a:r>
-              <a:rPr lang="en-US" sz="1600" dirty="0">
-                <a:solidFill>
-                  <a:srgbClr val="A7F3D0"/>
-                </a:solidFill>
-                <a:latin typeface="Courier New" pitchFamily="34" charset="0"/>
-                <a:ea typeface="Courier New" pitchFamily="34" charset="-122"/>
-                <a:cs typeface="Courier New" pitchFamily="34" charset="-120"/>
-              </a:rPr>
-              <a:t>EIRE             12,108.35</a:t>
-            </a:r>
-            <a:endParaRPr lang="en-US" sz="1600" dirty="0"/>
-          </a:p>
-          <a:p>
-            <a:pPr indent="0" marL="0">
-              <a:lnSpc>
-                <a:spcPct val="110000"/>
-              </a:lnSpc>
-              <a:buNone/>
-            </a:pPr>
-            <a:r>
-              <a:rPr lang="en-US" sz="1600" dirty="0">
-                <a:solidFill>
-                  <a:srgbClr val="A7F3D0"/>
-                </a:solidFill>
-                <a:latin typeface="Courier New" pitchFamily="34" charset="0"/>
-                <a:ea typeface="Courier New" pitchFamily="34" charset="-122"/>
-                <a:cs typeface="Courier New" pitchFamily="34" charset="-120"/>
-              </a:rPr>
-              <a:t>Spain             7,784.88</a:t>
-            </a:r>
-            <a:endParaRPr lang="en-US" sz="1600" dirty="0"/>
-          </a:p>
-        </p:txBody>
-      </p:sp>
-      <p:sp>
-        <p:nvSpPr>
-          <p:cNvPr id="5" name="Text 3"/>
-          <p:cNvSpPr/>
-          <p:nvPr/>
-        </p:nvSpPr>
-        <p:spPr>
-          <a:xfrm>
-            <a:off x="640080" y="4663440"/>
-            <a:ext cx="10881360" cy="548640"/>
-          </a:xfrm>
-          <a:prstGeom prst="rect">
-            <a:avLst/>
-          </a:prstGeom>
-          <a:noFill/>
-          <a:ln/>
-        </p:spPr>
-        <p:txBody>
           <a:bodyPr wrap="square" rtlCol="0" anchor="ctr"/>
           <a:lstStyle/>
           <a:p>
-            <a:pPr indent="0" marL="0">
-              <a:buNone/>
-            </a:pPr>
-            <a:r>
-              <a:rPr lang="en-US" sz="1700" dirty="0">
-                <a:solidFill>
-                  <a:srgbClr val="334155"/>
+            <a:pPr algn="ctr" indent="0" marL="0">
+              <a:buNone/>
+            </a:pPr>
+            <a:r>
+              <a:rPr lang="en-US" sz="1500" i="1" dirty="0">
+                <a:solidFill>
+                  <a:srgbClr val="64748B"/>
                 </a:solidFill>
                 <a:latin typeface="Arial" pitchFamily="34" charset="0"/>
                 <a:ea typeface="Arial" pitchFamily="34" charset="-122"/>
                 <a:cs typeface="Arial" pitchFamily="34" charset="-120"/>
               </a:rPr>
-              <a:t>Deployed on Amazon Bedrock AgentCore. Real numbers from the public UCI Online Retail II dataset.</a:t>
-            </a:r>
-            <a:endParaRPr lang="en-US" sz="1700" dirty="0"/>
-          </a:p>
-        </p:txBody>
-      </p:sp>
-      <p:sp>
-        <p:nvSpPr>
-          <p:cNvPr id="6" name="Text 4"/>
-          <p:cNvSpPr/>
-          <p:nvPr/>
-        </p:nvSpPr>
-        <p:spPr>
-          <a:xfrm>
-            <a:off x="640080" y="5303520"/>
-            <a:ext cx="10881360" cy="640080"/>
-          </a:xfrm>
-          <a:prstGeom prst="rect">
-            <a:avLst/>
-          </a:prstGeom>
-          <a:noFill/>
-          <a:ln/>
-        </p:spPr>
-        <p:txBody>
-          <a:bodyPr wrap="square" rtlCol="0" anchor="ctr"/>
-          <a:lstStyle/>
-          <a:p>
-            <a:pPr indent="0" marL="0">
-              <a:buNone/>
-            </a:pPr>
-            <a:r>
-              <a:rPr lang="en-US" sz="2200" b="1" dirty="0">
-                <a:solidFill>
-                  <a:srgbClr val="0F172A"/>
-                </a:solidFill>
-                <a:latin typeface="Cambria" pitchFamily="34" charset="0"/>
-                <a:ea typeface="Cambria" pitchFamily="34" charset="-122"/>
-                <a:cs typeface="Cambria" pitchFamily="34" charset="-120"/>
-              </a:rPr>
-              <a:t>Real agent, real data, genuinely useful. Now — is it safe?</a:t>
-            </a:r>
-            <a:endParaRPr lang="en-US" sz="2200" dirty="0"/>
+              <a:t>Hexagonal. Read-only replica, parameterised queries, sandboxed compute, egress allowlist, audited delivery. This passes review.</a:t>
+            </a:r>
+            <a:endParaRPr lang="en-US" sz="1500" dirty="0"/>
           </a:p>
         </p:txBody>
       </p:sp>
@@ -3696,6 +3588,352 @@
                 <a:ea typeface="Cambria" pitchFamily="34" charset="-122"/>
                 <a:cs typeface="Cambria" pitchFamily="34" charset="-120"/>
               </a:rPr>
+              <a:t>Quanta, live — a real, useful assistant</a:t>
+            </a:r>
+            <a:endParaRPr lang="en-US" sz="3200" dirty="0"/>
+          </a:p>
+        </p:txBody>
+      </p:sp>
+      <p:sp>
+        <p:nvSpPr>
+          <p:cNvPr id="3" name="Shape 1"/>
+          <p:cNvSpPr/>
+          <p:nvPr/>
+        </p:nvSpPr>
+        <p:spPr>
+          <a:xfrm>
+            <a:off x="640080" y="1463040"/>
+            <a:ext cx="10908792" cy="2926080"/>
+          </a:xfrm>
+          <a:prstGeom prst="roundRect">
+            <a:avLst>
+              <a:gd name="adj" fmla="val 2500"/>
+            </a:avLst>
+          </a:prstGeom>
+          <a:solidFill>
+            <a:srgbClr val="0B1220"/>
+          </a:solidFill>
+          <a:ln/>
+        </p:spPr>
+      </p:sp>
+      <p:sp>
+        <p:nvSpPr>
+          <p:cNvPr id="4" name="Text 2"/>
+          <p:cNvSpPr/>
+          <p:nvPr/>
+        </p:nvSpPr>
+        <p:spPr>
+          <a:xfrm>
+            <a:off x="1005840" y="1737360"/>
+            <a:ext cx="10149840" cy="2377440"/>
+          </a:xfrm>
+          <a:prstGeom prst="rect">
+            <a:avLst/>
+          </a:prstGeom>
+          <a:noFill/>
+          <a:ln/>
+        </p:spPr>
+        <p:txBody>
+          <a:bodyPr wrap="square" rtlCol="0" anchor="t"/>
+          <a:lstStyle/>
+          <a:p>
+            <a:pPr indent="0" marL="0">
+              <a:lnSpc>
+                <a:spcPct val="110000"/>
+              </a:lnSpc>
+              <a:buNone/>
+            </a:pPr>
+            <a:r>
+              <a:rPr lang="en-US" sz="1600" dirty="0">
+                <a:solidFill>
+                  <a:srgbClr val="22D3EE"/>
+                </a:solidFill>
+                <a:latin typeface="Courier New" pitchFamily="34" charset="0"/>
+                <a:ea typeface="Courier New" pitchFamily="34" charset="-122"/>
+                <a:cs typeface="Courier New" pitchFamily="34" charset="-120"/>
+              </a:rPr>
+              <a:t>$ </a:t>
+            </a:r>
+            <a:pPr indent="0" marL="0">
+              <a:lnSpc>
+                <a:spcPct val="110000"/>
+              </a:lnSpc>
+              <a:buNone/>
+            </a:pPr>
+            <a:r>
+              <a:rPr lang="en-US" sz="1600" dirty="0">
+                <a:solidFill>
+                  <a:srgbClr val="E2E8F0"/>
+                </a:solidFill>
+                <a:latin typeface="Courier New" pitchFamily="34" charset="0"/>
+                <a:ea typeface="Courier New" pitchFamily="34" charset="-122"/>
+                <a:cs typeface="Courier New" pitchFamily="34" charset="-120"/>
+              </a:rPr>
+              <a:t>agentcore invoke '{"prompt": "Revenue by country, top 5"}'
+</a:t>
+            </a:r>
+            <a:pPr indent="0" marL="0">
+              <a:lnSpc>
+                <a:spcPct val="110000"/>
+              </a:lnSpc>
+              <a:buNone/>
+            </a:pPr>
+            <a:r>
+              <a:rPr lang="en-US" sz="1600" dirty="0">
+                <a:solidFill>
+                  <a:srgbClr val="94A3B8"/>
+                </a:solidFill>
+                <a:latin typeface="Courier New" pitchFamily="34" charset="0"/>
+                <a:ea typeface="Courier New" pitchFamily="34" charset="-122"/>
+                <a:cs typeface="Courier New" pitchFamily="34" charset="-120"/>
+              </a:rPr>
+              <a:t>Revenue by country
+</a:t>
+            </a:r>
+            <a:pPr indent="0" marL="0">
+              <a:lnSpc>
+                <a:spcPct val="110000"/>
+              </a:lnSpc>
+              <a:buNone/>
+            </a:pPr>
+            <a:r>
+              <a:rPr lang="en-US" sz="1600" dirty="0">
+                <a:solidFill>
+                  <a:srgbClr val="A7F3D0"/>
+                </a:solidFill>
+                <a:latin typeface="Courier New" pitchFamily="34" charset="0"/>
+                <a:ea typeface="Courier New" pitchFamily="34" charset="-122"/>
+                <a:cs typeface="Courier New" pitchFamily="34" charset="-120"/>
+              </a:rPr>
+              <a:t>United Kingdom   76,654.21</a:t>
+            </a:r>
+            <a:endParaRPr lang="en-US" sz="1600" dirty="0"/>
+          </a:p>
+          <a:p>
+            <a:pPr indent="0" marL="0">
+              <a:lnSpc>
+                <a:spcPct val="110000"/>
+              </a:lnSpc>
+              <a:buNone/>
+            </a:pPr>
+            <a:r>
+              <a:rPr lang="en-US" sz="1600" dirty="0">
+                <a:solidFill>
+                  <a:srgbClr val="A7F3D0"/>
+                </a:solidFill>
+                <a:latin typeface="Courier New" pitchFamily="34" charset="0"/>
+                <a:ea typeface="Courier New" pitchFamily="34" charset="-122"/>
+                <a:cs typeface="Courier New" pitchFamily="34" charset="-120"/>
+              </a:rPr>
+              <a:t>Germany          18,484.30</a:t>
+            </a:r>
+            <a:endParaRPr lang="en-US" sz="1600" dirty="0"/>
+          </a:p>
+          <a:p>
+            <a:pPr indent="0" marL="0">
+              <a:lnSpc>
+                <a:spcPct val="110000"/>
+              </a:lnSpc>
+              <a:buNone/>
+            </a:pPr>
+            <a:r>
+              <a:rPr lang="en-US" sz="1600" dirty="0">
+                <a:solidFill>
+                  <a:srgbClr val="A7F3D0"/>
+                </a:solidFill>
+                <a:latin typeface="Courier New" pitchFamily="34" charset="0"/>
+                <a:ea typeface="Courier New" pitchFamily="34" charset="-122"/>
+                <a:cs typeface="Courier New" pitchFamily="34" charset="-120"/>
+              </a:rPr>
+              <a:t>France           15,259.32</a:t>
+            </a:r>
+            <a:endParaRPr lang="en-US" sz="1600" dirty="0"/>
+          </a:p>
+          <a:p>
+            <a:pPr indent="0" marL="0">
+              <a:lnSpc>
+                <a:spcPct val="110000"/>
+              </a:lnSpc>
+              <a:buNone/>
+            </a:pPr>
+            <a:r>
+              <a:rPr lang="en-US" sz="1600" dirty="0">
+                <a:solidFill>
+                  <a:srgbClr val="A7F3D0"/>
+                </a:solidFill>
+                <a:latin typeface="Courier New" pitchFamily="34" charset="0"/>
+                <a:ea typeface="Courier New" pitchFamily="34" charset="-122"/>
+                <a:cs typeface="Courier New" pitchFamily="34" charset="-120"/>
+              </a:rPr>
+              <a:t>EIRE             12,108.35</a:t>
+            </a:r>
+            <a:endParaRPr lang="en-US" sz="1600" dirty="0"/>
+          </a:p>
+          <a:p>
+            <a:pPr indent="0" marL="0">
+              <a:lnSpc>
+                <a:spcPct val="110000"/>
+              </a:lnSpc>
+              <a:buNone/>
+            </a:pPr>
+            <a:r>
+              <a:rPr lang="en-US" sz="1600" dirty="0">
+                <a:solidFill>
+                  <a:srgbClr val="A7F3D0"/>
+                </a:solidFill>
+                <a:latin typeface="Courier New" pitchFamily="34" charset="0"/>
+                <a:ea typeface="Courier New" pitchFamily="34" charset="-122"/>
+                <a:cs typeface="Courier New" pitchFamily="34" charset="-120"/>
+              </a:rPr>
+              <a:t>Spain             7,784.88</a:t>
+            </a:r>
+            <a:endParaRPr lang="en-US" sz="1600" dirty="0"/>
+          </a:p>
+        </p:txBody>
+      </p:sp>
+      <p:sp>
+        <p:nvSpPr>
+          <p:cNvPr id="5" name="Text 3"/>
+          <p:cNvSpPr/>
+          <p:nvPr/>
+        </p:nvSpPr>
+        <p:spPr>
+          <a:xfrm>
+            <a:off x="640080" y="4663440"/>
+            <a:ext cx="10881360" cy="548640"/>
+          </a:xfrm>
+          <a:prstGeom prst="rect">
+            <a:avLst/>
+          </a:prstGeom>
+          <a:noFill/>
+          <a:ln/>
+        </p:spPr>
+        <p:txBody>
+          <a:bodyPr wrap="square" rtlCol="0" anchor="ctr"/>
+          <a:lstStyle/>
+          <a:p>
+            <a:pPr indent="0" marL="0">
+              <a:buNone/>
+            </a:pPr>
+            <a:r>
+              <a:rPr lang="en-US" sz="1700" dirty="0">
+                <a:solidFill>
+                  <a:srgbClr val="334155"/>
+                </a:solidFill>
+                <a:latin typeface="Arial" pitchFamily="34" charset="0"/>
+                <a:ea typeface="Arial" pitchFamily="34" charset="-122"/>
+                <a:cs typeface="Arial" pitchFamily="34" charset="-120"/>
+              </a:rPr>
+              <a:t>Deployed on Amazon Bedrock AgentCore. Real numbers from the public UCI Online Retail II dataset.</a:t>
+            </a:r>
+            <a:endParaRPr lang="en-US" sz="1700" dirty="0"/>
+          </a:p>
+        </p:txBody>
+      </p:sp>
+      <p:sp>
+        <p:nvSpPr>
+          <p:cNvPr id="6" name="Text 4"/>
+          <p:cNvSpPr/>
+          <p:nvPr/>
+        </p:nvSpPr>
+        <p:spPr>
+          <a:xfrm>
+            <a:off x="640080" y="5303520"/>
+            <a:ext cx="10881360" cy="640080"/>
+          </a:xfrm>
+          <a:prstGeom prst="rect">
+            <a:avLst/>
+          </a:prstGeom>
+          <a:noFill/>
+          <a:ln/>
+        </p:spPr>
+        <p:txBody>
+          <a:bodyPr wrap="square" rtlCol="0" anchor="ctr"/>
+          <a:lstStyle/>
+          <a:p>
+            <a:pPr indent="0" marL="0">
+              <a:buNone/>
+            </a:pPr>
+            <a:r>
+              <a:rPr lang="en-US" sz="2200" b="1" dirty="0">
+                <a:solidFill>
+                  <a:srgbClr val="0F172A"/>
+                </a:solidFill>
+                <a:latin typeface="Cambria" pitchFamily="34" charset="0"/>
+                <a:ea typeface="Cambria" pitchFamily="34" charset="-122"/>
+                <a:cs typeface="Cambria" pitchFamily="34" charset="-120"/>
+              </a:rPr>
+              <a:t>Real agent, real data, genuinely useful. Now — is it safe?</a:t>
+            </a:r>
+            <a:endParaRPr lang="en-US" sz="2200" dirty="0"/>
+          </a:p>
+        </p:txBody>
+      </p:sp>
+    </p:spTree>
+  </p:cSld>
+  <p:clrMapOvr>
+    <a:masterClrMapping/>
+  </p:clrMapOvr>
+</p:sld>
+</file>
+
+<file path=ppt/slides/slide13.xml><?xml version="1.0" encoding="utf-8"?>
+<p:sld xmlns:a="http://schemas.openxmlformats.org/drawingml/2006/main" xmlns:r="http://schemas.openxmlformats.org/officeDocument/2006/relationships" xmlns:p="http://schemas.openxmlformats.org/presentationml/2006/main">
+  <p:cSld name="Slide 13">
+    <p:bg>
+      <p:bgPr>
+        <a:solidFill>
+          <a:srgbClr val="F8FAFC"/>
+        </a:solidFill>
+      </p:bgPr>
+    </p:bg>
+    <p:spTree>
+      <p:nvGrpSpPr>
+        <p:cNvPr id="1" name=""/>
+        <p:cNvGrpSpPr/>
+        <p:nvPr/>
+      </p:nvGrpSpPr>
+      <p:grpSpPr>
+        <a:xfrm>
+          <a:off x="0" y="0"/>
+          <a:ext cx="0" cy="0"/>
+          <a:chOff x="0" y="0"/>
+          <a:chExt cx="0" cy="0"/>
+        </a:xfrm>
+      </p:grpSpPr>
+      <p:sp>
+        <p:nvSpPr>
+          <p:cNvPr id="2" name="Text 0"/>
+          <p:cNvSpPr/>
+          <p:nvPr/>
+        </p:nvSpPr>
+        <p:spPr>
+          <a:xfrm>
+            <a:off x="640080" y="457200"/>
+            <a:ext cx="10972800" cy="822960"/>
+          </a:xfrm>
+          <a:prstGeom prst="rect">
+            <a:avLst/>
+          </a:prstGeom>
+          <a:noFill/>
+          <a:ln/>
+        </p:spPr>
+        <p:txBody>
+          <a:bodyPr wrap="square" rtlCol="0" anchor="ctr"/>
+          <a:lstStyle/>
+          <a:p>
+            <a:pPr indent="0" marL="0">
+              <a:buNone/>
+            </a:pPr>
+            <a:r>
+              <a:rPr lang="en-US" sz="3200" b="1" dirty="0">
+                <a:solidFill>
+                  <a:srgbClr val="0F172A"/>
+                </a:solidFill>
+                <a:latin typeface="Cambria" pitchFamily="34" charset="0"/>
+                <a:ea typeface="Cambria" pitchFamily="34" charset="-122"/>
+                <a:cs typeface="Cambria" pitchFamily="34" charset="-120"/>
+              </a:rPr>
               <a:t>Four tools. Four real controls.</a:t>
             </a:r>
             <a:endParaRPr lang="en-US" sz="3200" dirty="0"/>
@@ -3704,7 +3942,7 @@
       </p:sp>
       <p:graphicFrame>
         <p:nvGraphicFramePr>
-          <p:cNvPr id="13" name="Table 0"/>
+          <p:cNvPr id="14" name="Table 0"/>
           <p:cNvGraphicFramePr>
             <a:graphicFrameLocks noGrp="1"/>
           </p:cNvGraphicFramePr>
@@ -4837,9 +5075,9 @@
 </p:sld>
 </file>
 
-<file path=ppt/slides/slide13.xml><?xml version="1.0" encoding="utf-8"?>
+<file path=ppt/slides/slide14.xml><?xml version="1.0" encoding="utf-8"?>
 <p:sld xmlns:a="http://schemas.openxmlformats.org/drawingml/2006/main" xmlns:r="http://schemas.openxmlformats.org/officeDocument/2006/relationships" xmlns:p="http://schemas.openxmlformats.org/presentationml/2006/main">
-  <p:cSld name="Slide 13">
+  <p:cSld name="Slide 14">
     <p:bg>
       <p:bgPr>
         <a:solidFill>
@@ -4993,509 +5231,6 @@
                 <a:cs typeface="Arial" pitchFamily="34" charset="-120"/>
               </a:rPr>
               <a:t>Stop reviewing tools one at a time. Look at what they do together.</a:t>
-            </a:r>
-            <a:endParaRPr lang="en-US" sz="1800" dirty="0"/>
-          </a:p>
-        </p:txBody>
-      </p:sp>
-    </p:spTree>
-  </p:cSld>
-  <p:clrMapOvr>
-    <a:masterClrMapping/>
-  </p:clrMapOvr>
-</p:sld>
-</file>
-
-<file path=ppt/slides/slide14.xml><?xml version="1.0" encoding="utf-8"?>
-<p:sld xmlns:a="http://schemas.openxmlformats.org/drawingml/2006/main" xmlns:r="http://schemas.openxmlformats.org/officeDocument/2006/relationships" xmlns:p="http://schemas.openxmlformats.org/presentationml/2006/main">
-  <p:cSld name="Slide 14">
-    <p:bg>
-      <p:bgPr>
-        <a:solidFill>
-          <a:srgbClr val="F8FAFC"/>
-        </a:solidFill>
-      </p:bgPr>
-    </p:bg>
-    <p:spTree>
-      <p:nvGrpSpPr>
-        <p:cNvPr id="1" name=""/>
-        <p:cNvGrpSpPr/>
-        <p:nvPr/>
-      </p:nvGrpSpPr>
-      <p:grpSpPr>
-        <a:xfrm>
-          <a:off x="0" y="0"/>
-          <a:ext cx="0" cy="0"/>
-          <a:chOff x="0" y="0"/>
-          <a:chExt cx="0" cy="0"/>
-        </a:xfrm>
-      </p:grpSpPr>
-      <p:sp>
-        <p:nvSpPr>
-          <p:cNvPr id="2" name="Text 0"/>
-          <p:cNvSpPr/>
-          <p:nvPr/>
-        </p:nvSpPr>
-        <p:spPr>
-          <a:xfrm>
-            <a:off x="640080" y="457200"/>
-            <a:ext cx="10972800" cy="822960"/>
-          </a:xfrm>
-          <a:prstGeom prst="rect">
-            <a:avLst/>
-          </a:prstGeom>
-          <a:noFill/>
-          <a:ln/>
-        </p:spPr>
-        <p:txBody>
-          <a:bodyPr wrap="square" rtlCol="0" anchor="ctr"/>
-          <a:lstStyle/>
-          <a:p>
-            <a:pPr indent="0" marL="0">
-              <a:buNone/>
-            </a:pPr>
-            <a:r>
-              <a:rPr lang="en-US" sz="3200" b="1" dirty="0">
-                <a:solidFill>
-                  <a:srgbClr val="0F172A"/>
-                </a:solidFill>
-                <a:latin typeface="Cambria" pitchFamily="34" charset="0"/>
-                <a:ea typeface="Cambria" pitchFamily="34" charset="-122"/>
-                <a:cs typeface="Cambria" pitchFamily="34" charset="-120"/>
-              </a:rPr>
-              <a:t>What ZIRAN does differently</a:t>
-            </a:r>
-            <a:endParaRPr lang="en-US" sz="3200" dirty="0"/>
-          </a:p>
-        </p:txBody>
-      </p:sp>
-      <p:sp>
-        <p:nvSpPr>
-          <p:cNvPr id="3" name="Text 1"/>
-          <p:cNvSpPr/>
-          <p:nvPr/>
-        </p:nvSpPr>
-        <p:spPr>
-          <a:xfrm>
-            <a:off x="640080" y="1554480"/>
-            <a:ext cx="10881360" cy="1828800"/>
-          </a:xfrm>
-          <a:prstGeom prst="rect">
-            <a:avLst/>
-          </a:prstGeom>
-          <a:noFill/>
-          <a:ln/>
-        </p:spPr>
-        <p:txBody>
-          <a:bodyPr wrap="square" rtlCol="0" anchor="t"/>
-          <a:lstStyle/>
-          <a:p>
-            <a:pPr indent="0" marL="0">
-              <a:lnSpc>
-                <a:spcPct val="120000"/>
-              </a:lnSpc>
-              <a:buNone/>
-            </a:pPr>
-            <a:r>
-              <a:rPr lang="en-US" sz="1900" b="1" dirty="0">
-                <a:solidFill>
-                  <a:srgbClr val="0F172A"/>
-                </a:solidFill>
-                <a:latin typeface="Arial" pitchFamily="34" charset="0"/>
-                <a:ea typeface="Arial" pitchFamily="34" charset="-122"/>
-                <a:cs typeface="Arial" pitchFamily="34" charset="-120"/>
-              </a:rPr>
-              <a:t>It builds the agent's capability graph</a:t>
-            </a:r>
-            <a:pPr indent="0" marL="0">
-              <a:lnSpc>
-                <a:spcPct val="120000"/>
-              </a:lnSpc>
-              <a:buNone/>
-            </a:pPr>
-            <a:r>
-              <a:rPr lang="en-US" sz="1700" dirty="0">
-                <a:solidFill>
-                  <a:srgbClr val="334155"/>
-                </a:solidFill>
-                <a:latin typeface="Arial" pitchFamily="34" charset="0"/>
-                <a:ea typeface="Arial" pitchFamily="34" charset="-122"/>
-                <a:cs typeface="Arial" pitchFamily="34" charset="-120"/>
-              </a:rPr>
-              <a:t>  — every tool, and every way one tool's output can flow into another.
-</a:t>
-            </a:r>
-            <a:pPr indent="0" marL="0">
-              <a:lnSpc>
-                <a:spcPct val="120000"/>
-              </a:lnSpc>
-              <a:buNone/>
-            </a:pPr>
-            <a:r>
-              <a:rPr lang="en-US" sz="1700" dirty="0">
-                <a:solidFill>
-                  <a:srgbClr val="334155"/>
-                </a:solidFill>
-                <a:latin typeface="Arial" pitchFamily="34" charset="0"/>
-                <a:ea typeface="Arial" pitchFamily="34" charset="-122"/>
-                <a:cs typeface="Arial" pitchFamily="34" charset="-120"/>
-              </a:rPr>
-              <a:t>Then it checks that graph against a library of known dangerous compositions:
-</a:t>
-            </a:r>
-            <a:endParaRPr lang="en-US" sz="1900" dirty="0"/>
-          </a:p>
-        </p:txBody>
-      </p:sp>
-      <p:sp>
-        <p:nvSpPr>
-          <p:cNvPr id="4" name="Shape 2"/>
-          <p:cNvSpPr/>
-          <p:nvPr/>
-        </p:nvSpPr>
-        <p:spPr>
-          <a:xfrm>
-            <a:off x="640080" y="3383280"/>
-            <a:ext cx="3383280" cy="1371600"/>
-          </a:xfrm>
-          <a:prstGeom prst="roundRect">
-            <a:avLst>
-              <a:gd name="adj" fmla="val 8000"/>
-            </a:avLst>
-          </a:prstGeom>
-          <a:solidFill>
-            <a:srgbClr val="EEF2FF"/>
-          </a:solidFill>
-          <a:ln w="15240">
-            <a:solidFill>
-              <a:srgbClr val="4338CA"/>
-            </a:solidFill>
-            <a:prstDash val="solid"/>
-          </a:ln>
-        </p:spPr>
-      </p:sp>
-      <p:sp>
-        <p:nvSpPr>
-          <p:cNvPr id="5" name="Text 3"/>
-          <p:cNvSpPr/>
-          <p:nvPr/>
-        </p:nvSpPr>
-        <p:spPr>
-          <a:xfrm>
-            <a:off x="640080" y="3566160"/>
-            <a:ext cx="3383280" cy="548640"/>
-          </a:xfrm>
-          <a:prstGeom prst="rect">
-            <a:avLst/>
-          </a:prstGeom>
-          <a:noFill/>
-          <a:ln/>
-        </p:spPr>
-        <p:txBody>
-          <a:bodyPr wrap="square" rtlCol="0" anchor="ctr"/>
-          <a:lstStyle/>
-          <a:p>
-            <a:pPr algn="ctr" indent="0" marL="0">
-              <a:buNone/>
-            </a:pPr>
-            <a:r>
-              <a:rPr lang="en-US" sz="2200" b="1" dirty="0">
-                <a:solidFill>
-                  <a:srgbClr val="4338CA"/>
-                </a:solidFill>
-                <a:latin typeface="Cambria" pitchFamily="34" charset="0"/>
-                <a:ea typeface="Cambria" pitchFamily="34" charset="-122"/>
-                <a:cs typeface="Cambria" pitchFamily="34" charset="-120"/>
-              </a:rPr>
-              <a:t>direct</a:t>
-            </a:r>
-            <a:endParaRPr lang="en-US" sz="2200" dirty="0"/>
-          </a:p>
-        </p:txBody>
-      </p:sp>
-      <p:sp>
-        <p:nvSpPr>
-          <p:cNvPr id="6" name="Text 4"/>
-          <p:cNvSpPr/>
-          <p:nvPr/>
-        </p:nvSpPr>
-        <p:spPr>
-          <a:xfrm>
-            <a:off x="640080" y="4114800"/>
-            <a:ext cx="3383280" cy="548640"/>
-          </a:xfrm>
-          <a:prstGeom prst="rect">
-            <a:avLst/>
-          </a:prstGeom>
-          <a:noFill/>
-          <a:ln/>
-        </p:spPr>
-        <p:txBody>
-          <a:bodyPr wrap="square" rtlCol="0" anchor="ctr"/>
-          <a:lstStyle/>
-          <a:p>
-            <a:pPr algn="ctr" indent="0" marL="0">
-              <a:buNone/>
-            </a:pPr>
-            <a:r>
-              <a:rPr lang="en-US" sz="1800" dirty="0">
-                <a:solidFill>
-                  <a:srgbClr val="334155"/>
-                </a:solidFill>
-                <a:latin typeface="Courier New" pitchFamily="34" charset="0"/>
-                <a:ea typeface="Courier New" pitchFamily="34" charset="-122"/>
-                <a:cs typeface="Courier New" pitchFamily="34" charset="-120"/>
-              </a:rPr>
-              <a:t>A → B</a:t>
-            </a:r>
-            <a:endParaRPr lang="en-US" sz="1800" dirty="0"/>
-          </a:p>
-        </p:txBody>
-      </p:sp>
-      <p:sp>
-        <p:nvSpPr>
-          <p:cNvPr id="7" name="Shape 5"/>
-          <p:cNvSpPr/>
-          <p:nvPr/>
-        </p:nvSpPr>
-        <p:spPr>
-          <a:xfrm>
-            <a:off x="4343400" y="3383280"/>
-            <a:ext cx="3383280" cy="1371600"/>
-          </a:xfrm>
-          <a:prstGeom prst="roundRect">
-            <a:avLst>
-              <a:gd name="adj" fmla="val 8000"/>
-            </a:avLst>
-          </a:prstGeom>
-          <a:solidFill>
-            <a:srgbClr val="EEF2FF"/>
-          </a:solidFill>
-          <a:ln w="15240">
-            <a:solidFill>
-              <a:srgbClr val="4338CA"/>
-            </a:solidFill>
-            <a:prstDash val="solid"/>
-          </a:ln>
-        </p:spPr>
-      </p:sp>
-      <p:sp>
-        <p:nvSpPr>
-          <p:cNvPr id="8" name="Text 6"/>
-          <p:cNvSpPr/>
-          <p:nvPr/>
-        </p:nvSpPr>
-        <p:spPr>
-          <a:xfrm>
-            <a:off x="4343400" y="3566160"/>
-            <a:ext cx="3383280" cy="548640"/>
-          </a:xfrm>
-          <a:prstGeom prst="rect">
-            <a:avLst/>
-          </a:prstGeom>
-          <a:noFill/>
-          <a:ln/>
-        </p:spPr>
-        <p:txBody>
-          <a:bodyPr wrap="square" rtlCol="0" anchor="ctr"/>
-          <a:lstStyle/>
-          <a:p>
-            <a:pPr algn="ctr" indent="0" marL="0">
-              <a:buNone/>
-            </a:pPr>
-            <a:r>
-              <a:rPr lang="en-US" sz="2200" b="1" dirty="0">
-                <a:solidFill>
-                  <a:srgbClr val="4338CA"/>
-                </a:solidFill>
-                <a:latin typeface="Cambria" pitchFamily="34" charset="0"/>
-                <a:ea typeface="Cambria" pitchFamily="34" charset="-122"/>
-                <a:cs typeface="Cambria" pitchFamily="34" charset="-120"/>
-              </a:rPr>
-              <a:t>indirect</a:t>
-            </a:r>
-            <a:endParaRPr lang="en-US" sz="2200" dirty="0"/>
-          </a:p>
-        </p:txBody>
-      </p:sp>
-      <p:sp>
-        <p:nvSpPr>
-          <p:cNvPr id="9" name="Text 7"/>
-          <p:cNvSpPr/>
-          <p:nvPr/>
-        </p:nvSpPr>
-        <p:spPr>
-          <a:xfrm>
-            <a:off x="4343400" y="4114800"/>
-            <a:ext cx="3383280" cy="548640"/>
-          </a:xfrm>
-          <a:prstGeom prst="rect">
-            <a:avLst/>
-          </a:prstGeom>
-          <a:noFill/>
-          <a:ln/>
-        </p:spPr>
-        <p:txBody>
-          <a:bodyPr wrap="square" rtlCol="0" anchor="ctr"/>
-          <a:lstStyle/>
-          <a:p>
-            <a:pPr algn="ctr" indent="0" marL="0">
-              <a:buNone/>
-            </a:pPr>
-            <a:r>
-              <a:rPr lang="en-US" sz="1800" dirty="0">
-                <a:solidFill>
-                  <a:srgbClr val="334155"/>
-                </a:solidFill>
-                <a:latin typeface="Courier New" pitchFamily="34" charset="0"/>
-                <a:ea typeface="Courier New" pitchFamily="34" charset="-122"/>
-                <a:cs typeface="Courier New" pitchFamily="34" charset="-120"/>
-              </a:rPr>
-              <a:t>A → … → B</a:t>
-            </a:r>
-            <a:endParaRPr lang="en-US" sz="1800" dirty="0"/>
-          </a:p>
-        </p:txBody>
-      </p:sp>
-      <p:sp>
-        <p:nvSpPr>
-          <p:cNvPr id="10" name="Shape 8"/>
-          <p:cNvSpPr/>
-          <p:nvPr/>
-        </p:nvSpPr>
-        <p:spPr>
-          <a:xfrm>
-            <a:off x="8046720" y="3383280"/>
-            <a:ext cx="3383280" cy="1371600"/>
-          </a:xfrm>
-          <a:prstGeom prst="roundRect">
-            <a:avLst>
-              <a:gd name="adj" fmla="val 8000"/>
-            </a:avLst>
-          </a:prstGeom>
-          <a:solidFill>
-            <a:srgbClr val="EEF2FF"/>
-          </a:solidFill>
-          <a:ln w="15240">
-            <a:solidFill>
-              <a:srgbClr val="4338CA"/>
-            </a:solidFill>
-            <a:prstDash val="solid"/>
-          </a:ln>
-        </p:spPr>
-      </p:sp>
-      <p:sp>
-        <p:nvSpPr>
-          <p:cNvPr id="11" name="Text 9"/>
-          <p:cNvSpPr/>
-          <p:nvPr/>
-        </p:nvSpPr>
-        <p:spPr>
-          <a:xfrm>
-            <a:off x="8046720" y="3566160"/>
-            <a:ext cx="3383280" cy="548640"/>
-          </a:xfrm>
-          <a:prstGeom prst="rect">
-            <a:avLst/>
-          </a:prstGeom>
-          <a:noFill/>
-          <a:ln/>
-        </p:spPr>
-        <p:txBody>
-          <a:bodyPr wrap="square" rtlCol="0" anchor="ctr"/>
-          <a:lstStyle/>
-          <a:p>
-            <a:pPr algn="ctr" indent="0" marL="0">
-              <a:buNone/>
-            </a:pPr>
-            <a:r>
-              <a:rPr lang="en-US" sz="2200" b="1" dirty="0">
-                <a:solidFill>
-                  <a:srgbClr val="4338CA"/>
-                </a:solidFill>
-                <a:latin typeface="Cambria" pitchFamily="34" charset="0"/>
-                <a:ea typeface="Cambria" pitchFamily="34" charset="-122"/>
-                <a:cs typeface="Cambria" pitchFamily="34" charset="-120"/>
-              </a:rPr>
-              <a:t>cycle</a:t>
-            </a:r>
-            <a:endParaRPr lang="en-US" sz="2200" dirty="0"/>
-          </a:p>
-        </p:txBody>
-      </p:sp>
-      <p:sp>
-        <p:nvSpPr>
-          <p:cNvPr id="12" name="Text 10"/>
-          <p:cNvSpPr/>
-          <p:nvPr/>
-        </p:nvSpPr>
-        <p:spPr>
-          <a:xfrm>
-            <a:off x="8046720" y="4114800"/>
-            <a:ext cx="3383280" cy="548640"/>
-          </a:xfrm>
-          <a:prstGeom prst="rect">
-            <a:avLst/>
-          </a:prstGeom>
-          <a:noFill/>
-          <a:ln/>
-        </p:spPr>
-        <p:txBody>
-          <a:bodyPr wrap="square" rtlCol="0" anchor="ctr"/>
-          <a:lstStyle/>
-          <a:p>
-            <a:pPr algn="ctr" indent="0" marL="0">
-              <a:buNone/>
-            </a:pPr>
-            <a:r>
-              <a:rPr lang="en-US" sz="1800" dirty="0">
-                <a:solidFill>
-                  <a:srgbClr val="334155"/>
-                </a:solidFill>
-                <a:latin typeface="Courier New" pitchFamily="34" charset="0"/>
-                <a:ea typeface="Courier New" pitchFamily="34" charset="-122"/>
-                <a:cs typeface="Courier New" pitchFamily="34" charset="-120"/>
-              </a:rPr>
-              <a:t>A → B → … → A</a:t>
-            </a:r>
-            <a:endParaRPr lang="en-US" sz="1800" dirty="0"/>
-          </a:p>
-        </p:txBody>
-      </p:sp>
-      <p:sp>
-        <p:nvSpPr>
-          <p:cNvPr id="13" name="Text 11"/>
-          <p:cNvSpPr/>
-          <p:nvPr/>
-        </p:nvSpPr>
-        <p:spPr>
-          <a:xfrm>
-            <a:off x="640080" y="5212080"/>
-            <a:ext cx="10881360" cy="548640"/>
-          </a:xfrm>
-          <a:prstGeom prst="rect">
-            <a:avLst/>
-          </a:prstGeom>
-          <a:noFill/>
-          <a:ln/>
-        </p:spPr>
-        <p:txBody>
-          <a:bodyPr wrap="square" rtlCol="0" anchor="ctr"/>
-          <a:lstStyle/>
-          <a:p>
-            <a:pPr indent="0" marL="0">
-              <a:buNone/>
-            </a:pPr>
-            <a:r>
-              <a:rPr lang="en-US" sz="1800" i="1" dirty="0">
-                <a:solidFill>
-                  <a:srgbClr val="64748B"/>
-                </a:solidFill>
-                <a:latin typeface="Arial" pitchFamily="34" charset="0"/>
-                <a:ea typeface="Arial" pitchFamily="34" charset="-122"/>
-                <a:cs typeface="Arial" pitchFamily="34" charset="-120"/>
-              </a:rPr>
-              <a:t>Here it isn't testing prompts. It's reasoning about structure.</a:t>
             </a:r>
             <a:endParaRPr lang="en-US" sz="1800" dirty="0"/>
           </a:p>
@@ -5566,46 +5301,22 @@
                 <a:ea typeface="Cambria" pitchFamily="34" charset="-122"/>
                 <a:cs typeface="Cambria" pitchFamily="34" charset="-120"/>
               </a:rPr>
-              <a:t>The graph, in three steps</a:t>
+              <a:t>What ZIRAN does differently</a:t>
             </a:r>
             <a:endParaRPr lang="en-US" sz="3200" dirty="0"/>
           </a:p>
         </p:txBody>
       </p:sp>
-      <p:pic>
-        <p:nvPicPr>
-          <p:cNvPr id="3" name="Image 0" descr="/Users/leone.lage.perdigao/github/quanta/talk/assets/graph-evolution.png">    </p:cNvPr>
-          <p:cNvPicPr>
-            <a:picLocks noChangeAspect="1"/>
-          </p:cNvPicPr>
-          <p:nvPr/>
-        </p:nvPicPr>
-        <p:blipFill>
-          <a:blip r:embed="rId1"/>
-          <a:stretch>
-            <a:fillRect/>
-          </a:stretch>
-        </p:blipFill>
-        <p:spPr>
-          <a:xfrm>
-            <a:off x="640080" y="1612468"/>
-            <a:ext cx="10908792" cy="4181704"/>
-          </a:xfrm>
-          <a:prstGeom prst="rect">
-            <a:avLst/>
-          </a:prstGeom>
-        </p:spPr>
-      </p:pic>
-      <p:sp>
-        <p:nvSpPr>
-          <p:cNvPr id="4" name="Text 1"/>
-          <p:cNvSpPr/>
-          <p:nvPr/>
-        </p:nvSpPr>
-        <p:spPr>
-          <a:xfrm>
-            <a:off x="640080" y="6126480"/>
-            <a:ext cx="10908792" cy="457200"/>
+      <p:sp>
+        <p:nvSpPr>
+          <p:cNvPr id="3" name="Text 1"/>
+          <p:cNvSpPr/>
+          <p:nvPr/>
+        </p:nvSpPr>
+        <p:spPr>
+          <a:xfrm>
+            <a:off x="640080" y="1554480"/>
+            <a:ext cx="10881360" cy="1828800"/>
           </a:xfrm>
           <a:prstGeom prst="rect">
             <a:avLst/>
@@ -5614,24 +5325,417 @@
           <a:ln/>
         </p:spPr>
         <p:txBody>
-          <a:bodyPr wrap="square" rtlCol="0" anchor="ctr"/>
-          <a:lstStyle/>
-          <a:p>
-            <a:pPr algn="ctr" indent="0" marL="0">
-              <a:buNone/>
-            </a:pPr>
-            <a:r>
-              <a:rPr lang="en-US" sz="1500" i="1" dirty="0">
-                <a:solidFill>
-                  <a:srgbClr val="64748B"/>
+          <a:bodyPr wrap="square" rtlCol="0" anchor="t"/>
+          <a:lstStyle/>
+          <a:p>
+            <a:pPr indent="0" marL="0">
+              <a:lnSpc>
+                <a:spcPct val="120000"/>
+              </a:lnSpc>
+              <a:buNone/>
+            </a:pPr>
+            <a:r>
+              <a:rPr lang="en-US" sz="1900" b="1" dirty="0">
+                <a:solidFill>
+                  <a:srgbClr val="0F172A"/>
                 </a:solidFill>
                 <a:latin typeface="Arial" pitchFamily="34" charset="0"/>
                 <a:ea typeface="Arial" pitchFamily="34" charset="-122"/>
                 <a:cs typeface="Arial" pitchFamily="34" charset="-120"/>
               </a:rPr>
-              <a:t>Four approved tools → the agent can sequence them → one path is an exit.</a:t>
-            </a:r>
-            <a:endParaRPr lang="en-US" sz="1500" dirty="0"/>
+              <a:t>It builds the agent's capability graph</a:t>
+            </a:r>
+            <a:pPr indent="0" marL="0">
+              <a:lnSpc>
+                <a:spcPct val="120000"/>
+              </a:lnSpc>
+              <a:buNone/>
+            </a:pPr>
+            <a:r>
+              <a:rPr lang="en-US" sz="1700" dirty="0">
+                <a:solidFill>
+                  <a:srgbClr val="334155"/>
+                </a:solidFill>
+                <a:latin typeface="Arial" pitchFamily="34" charset="0"/>
+                <a:ea typeface="Arial" pitchFamily="34" charset="-122"/>
+                <a:cs typeface="Arial" pitchFamily="34" charset="-120"/>
+              </a:rPr>
+              <a:t>  — every tool, and every way one tool's output can flow into another.
+</a:t>
+            </a:r>
+            <a:pPr indent="0" marL="0">
+              <a:lnSpc>
+                <a:spcPct val="120000"/>
+              </a:lnSpc>
+              <a:buNone/>
+            </a:pPr>
+            <a:r>
+              <a:rPr lang="en-US" sz="1700" dirty="0">
+                <a:solidFill>
+                  <a:srgbClr val="334155"/>
+                </a:solidFill>
+                <a:latin typeface="Arial" pitchFamily="34" charset="0"/>
+                <a:ea typeface="Arial" pitchFamily="34" charset="-122"/>
+                <a:cs typeface="Arial" pitchFamily="34" charset="-120"/>
+              </a:rPr>
+              <a:t>Then it checks that graph against a library of known dangerous compositions:
+</a:t>
+            </a:r>
+            <a:endParaRPr lang="en-US" sz="1900" dirty="0"/>
+          </a:p>
+        </p:txBody>
+      </p:sp>
+      <p:sp>
+        <p:nvSpPr>
+          <p:cNvPr id="4" name="Shape 2"/>
+          <p:cNvSpPr/>
+          <p:nvPr/>
+        </p:nvSpPr>
+        <p:spPr>
+          <a:xfrm>
+            <a:off x="640080" y="3383280"/>
+            <a:ext cx="3383280" cy="1371600"/>
+          </a:xfrm>
+          <a:prstGeom prst="roundRect">
+            <a:avLst>
+              <a:gd name="adj" fmla="val 8000"/>
+            </a:avLst>
+          </a:prstGeom>
+          <a:solidFill>
+            <a:srgbClr val="EEF2FF"/>
+          </a:solidFill>
+          <a:ln w="15240">
+            <a:solidFill>
+              <a:srgbClr val="4338CA"/>
+            </a:solidFill>
+            <a:prstDash val="solid"/>
+          </a:ln>
+        </p:spPr>
+      </p:sp>
+      <p:sp>
+        <p:nvSpPr>
+          <p:cNvPr id="5" name="Text 3"/>
+          <p:cNvSpPr/>
+          <p:nvPr/>
+        </p:nvSpPr>
+        <p:spPr>
+          <a:xfrm>
+            <a:off x="640080" y="3566160"/>
+            <a:ext cx="3383280" cy="548640"/>
+          </a:xfrm>
+          <a:prstGeom prst="rect">
+            <a:avLst/>
+          </a:prstGeom>
+          <a:noFill/>
+          <a:ln/>
+        </p:spPr>
+        <p:txBody>
+          <a:bodyPr wrap="square" rtlCol="0" anchor="ctr"/>
+          <a:lstStyle/>
+          <a:p>
+            <a:pPr algn="ctr" indent="0" marL="0">
+              <a:buNone/>
+            </a:pPr>
+            <a:r>
+              <a:rPr lang="en-US" sz="2200" b="1" dirty="0">
+                <a:solidFill>
+                  <a:srgbClr val="4338CA"/>
+                </a:solidFill>
+                <a:latin typeface="Cambria" pitchFamily="34" charset="0"/>
+                <a:ea typeface="Cambria" pitchFamily="34" charset="-122"/>
+                <a:cs typeface="Cambria" pitchFamily="34" charset="-120"/>
+              </a:rPr>
+              <a:t>direct</a:t>
+            </a:r>
+            <a:endParaRPr lang="en-US" sz="2200" dirty="0"/>
+          </a:p>
+        </p:txBody>
+      </p:sp>
+      <p:sp>
+        <p:nvSpPr>
+          <p:cNvPr id="6" name="Text 4"/>
+          <p:cNvSpPr/>
+          <p:nvPr/>
+        </p:nvSpPr>
+        <p:spPr>
+          <a:xfrm>
+            <a:off x="640080" y="4114800"/>
+            <a:ext cx="3383280" cy="548640"/>
+          </a:xfrm>
+          <a:prstGeom prst="rect">
+            <a:avLst/>
+          </a:prstGeom>
+          <a:noFill/>
+          <a:ln/>
+        </p:spPr>
+        <p:txBody>
+          <a:bodyPr wrap="square" rtlCol="0" anchor="ctr"/>
+          <a:lstStyle/>
+          <a:p>
+            <a:pPr algn="ctr" indent="0" marL="0">
+              <a:buNone/>
+            </a:pPr>
+            <a:r>
+              <a:rPr lang="en-US" sz="1800" dirty="0">
+                <a:solidFill>
+                  <a:srgbClr val="334155"/>
+                </a:solidFill>
+                <a:latin typeface="Courier New" pitchFamily="34" charset="0"/>
+                <a:ea typeface="Courier New" pitchFamily="34" charset="-122"/>
+                <a:cs typeface="Courier New" pitchFamily="34" charset="-120"/>
+              </a:rPr>
+              <a:t>A → B</a:t>
+            </a:r>
+            <a:endParaRPr lang="en-US" sz="1800" dirty="0"/>
+          </a:p>
+        </p:txBody>
+      </p:sp>
+      <p:sp>
+        <p:nvSpPr>
+          <p:cNvPr id="7" name="Shape 5"/>
+          <p:cNvSpPr/>
+          <p:nvPr/>
+        </p:nvSpPr>
+        <p:spPr>
+          <a:xfrm>
+            <a:off x="4343400" y="3383280"/>
+            <a:ext cx="3383280" cy="1371600"/>
+          </a:xfrm>
+          <a:prstGeom prst="roundRect">
+            <a:avLst>
+              <a:gd name="adj" fmla="val 8000"/>
+            </a:avLst>
+          </a:prstGeom>
+          <a:solidFill>
+            <a:srgbClr val="EEF2FF"/>
+          </a:solidFill>
+          <a:ln w="15240">
+            <a:solidFill>
+              <a:srgbClr val="4338CA"/>
+            </a:solidFill>
+            <a:prstDash val="solid"/>
+          </a:ln>
+        </p:spPr>
+      </p:sp>
+      <p:sp>
+        <p:nvSpPr>
+          <p:cNvPr id="8" name="Text 6"/>
+          <p:cNvSpPr/>
+          <p:nvPr/>
+        </p:nvSpPr>
+        <p:spPr>
+          <a:xfrm>
+            <a:off x="4343400" y="3566160"/>
+            <a:ext cx="3383280" cy="548640"/>
+          </a:xfrm>
+          <a:prstGeom prst="rect">
+            <a:avLst/>
+          </a:prstGeom>
+          <a:noFill/>
+          <a:ln/>
+        </p:spPr>
+        <p:txBody>
+          <a:bodyPr wrap="square" rtlCol="0" anchor="ctr"/>
+          <a:lstStyle/>
+          <a:p>
+            <a:pPr algn="ctr" indent="0" marL="0">
+              <a:buNone/>
+            </a:pPr>
+            <a:r>
+              <a:rPr lang="en-US" sz="2200" b="1" dirty="0">
+                <a:solidFill>
+                  <a:srgbClr val="4338CA"/>
+                </a:solidFill>
+                <a:latin typeface="Cambria" pitchFamily="34" charset="0"/>
+                <a:ea typeface="Cambria" pitchFamily="34" charset="-122"/>
+                <a:cs typeface="Cambria" pitchFamily="34" charset="-120"/>
+              </a:rPr>
+              <a:t>indirect</a:t>
+            </a:r>
+            <a:endParaRPr lang="en-US" sz="2200" dirty="0"/>
+          </a:p>
+        </p:txBody>
+      </p:sp>
+      <p:sp>
+        <p:nvSpPr>
+          <p:cNvPr id="9" name="Text 7"/>
+          <p:cNvSpPr/>
+          <p:nvPr/>
+        </p:nvSpPr>
+        <p:spPr>
+          <a:xfrm>
+            <a:off x="4343400" y="4114800"/>
+            <a:ext cx="3383280" cy="548640"/>
+          </a:xfrm>
+          <a:prstGeom prst="rect">
+            <a:avLst/>
+          </a:prstGeom>
+          <a:noFill/>
+          <a:ln/>
+        </p:spPr>
+        <p:txBody>
+          <a:bodyPr wrap="square" rtlCol="0" anchor="ctr"/>
+          <a:lstStyle/>
+          <a:p>
+            <a:pPr algn="ctr" indent="0" marL="0">
+              <a:buNone/>
+            </a:pPr>
+            <a:r>
+              <a:rPr lang="en-US" sz="1800" dirty="0">
+                <a:solidFill>
+                  <a:srgbClr val="334155"/>
+                </a:solidFill>
+                <a:latin typeface="Courier New" pitchFamily="34" charset="0"/>
+                <a:ea typeface="Courier New" pitchFamily="34" charset="-122"/>
+                <a:cs typeface="Courier New" pitchFamily="34" charset="-120"/>
+              </a:rPr>
+              <a:t>A → … → B</a:t>
+            </a:r>
+            <a:endParaRPr lang="en-US" sz="1800" dirty="0"/>
+          </a:p>
+        </p:txBody>
+      </p:sp>
+      <p:sp>
+        <p:nvSpPr>
+          <p:cNvPr id="10" name="Shape 8"/>
+          <p:cNvSpPr/>
+          <p:nvPr/>
+        </p:nvSpPr>
+        <p:spPr>
+          <a:xfrm>
+            <a:off x="8046720" y="3383280"/>
+            <a:ext cx="3383280" cy="1371600"/>
+          </a:xfrm>
+          <a:prstGeom prst="roundRect">
+            <a:avLst>
+              <a:gd name="adj" fmla="val 8000"/>
+            </a:avLst>
+          </a:prstGeom>
+          <a:solidFill>
+            <a:srgbClr val="EEF2FF"/>
+          </a:solidFill>
+          <a:ln w="15240">
+            <a:solidFill>
+              <a:srgbClr val="4338CA"/>
+            </a:solidFill>
+            <a:prstDash val="solid"/>
+          </a:ln>
+        </p:spPr>
+      </p:sp>
+      <p:sp>
+        <p:nvSpPr>
+          <p:cNvPr id="11" name="Text 9"/>
+          <p:cNvSpPr/>
+          <p:nvPr/>
+        </p:nvSpPr>
+        <p:spPr>
+          <a:xfrm>
+            <a:off x="8046720" y="3566160"/>
+            <a:ext cx="3383280" cy="548640"/>
+          </a:xfrm>
+          <a:prstGeom prst="rect">
+            <a:avLst/>
+          </a:prstGeom>
+          <a:noFill/>
+          <a:ln/>
+        </p:spPr>
+        <p:txBody>
+          <a:bodyPr wrap="square" rtlCol="0" anchor="ctr"/>
+          <a:lstStyle/>
+          <a:p>
+            <a:pPr algn="ctr" indent="0" marL="0">
+              <a:buNone/>
+            </a:pPr>
+            <a:r>
+              <a:rPr lang="en-US" sz="2200" b="1" dirty="0">
+                <a:solidFill>
+                  <a:srgbClr val="4338CA"/>
+                </a:solidFill>
+                <a:latin typeface="Cambria" pitchFamily="34" charset="0"/>
+                <a:ea typeface="Cambria" pitchFamily="34" charset="-122"/>
+                <a:cs typeface="Cambria" pitchFamily="34" charset="-120"/>
+              </a:rPr>
+              <a:t>cycle</a:t>
+            </a:r>
+            <a:endParaRPr lang="en-US" sz="2200" dirty="0"/>
+          </a:p>
+        </p:txBody>
+      </p:sp>
+      <p:sp>
+        <p:nvSpPr>
+          <p:cNvPr id="12" name="Text 10"/>
+          <p:cNvSpPr/>
+          <p:nvPr/>
+        </p:nvSpPr>
+        <p:spPr>
+          <a:xfrm>
+            <a:off x="8046720" y="4114800"/>
+            <a:ext cx="3383280" cy="548640"/>
+          </a:xfrm>
+          <a:prstGeom prst="rect">
+            <a:avLst/>
+          </a:prstGeom>
+          <a:noFill/>
+          <a:ln/>
+        </p:spPr>
+        <p:txBody>
+          <a:bodyPr wrap="square" rtlCol="0" anchor="ctr"/>
+          <a:lstStyle/>
+          <a:p>
+            <a:pPr algn="ctr" indent="0" marL="0">
+              <a:buNone/>
+            </a:pPr>
+            <a:r>
+              <a:rPr lang="en-US" sz="1800" dirty="0">
+                <a:solidFill>
+                  <a:srgbClr val="334155"/>
+                </a:solidFill>
+                <a:latin typeface="Courier New" pitchFamily="34" charset="0"/>
+                <a:ea typeface="Courier New" pitchFamily="34" charset="-122"/>
+                <a:cs typeface="Courier New" pitchFamily="34" charset="-120"/>
+              </a:rPr>
+              <a:t>A → B → … → A</a:t>
+            </a:r>
+            <a:endParaRPr lang="en-US" sz="1800" dirty="0"/>
+          </a:p>
+        </p:txBody>
+      </p:sp>
+      <p:sp>
+        <p:nvSpPr>
+          <p:cNvPr id="13" name="Text 11"/>
+          <p:cNvSpPr/>
+          <p:nvPr/>
+        </p:nvSpPr>
+        <p:spPr>
+          <a:xfrm>
+            <a:off x="640080" y="5212080"/>
+            <a:ext cx="10881360" cy="548640"/>
+          </a:xfrm>
+          <a:prstGeom prst="rect">
+            <a:avLst/>
+          </a:prstGeom>
+          <a:noFill/>
+          <a:ln/>
+        </p:spPr>
+        <p:txBody>
+          <a:bodyPr wrap="square" rtlCol="0" anchor="ctr"/>
+          <a:lstStyle/>
+          <a:p>
+            <a:pPr indent="0" marL="0">
+              <a:buNone/>
+            </a:pPr>
+            <a:r>
+              <a:rPr lang="en-US" sz="1800" i="1" dirty="0">
+                <a:solidFill>
+                  <a:srgbClr val="64748B"/>
+                </a:solidFill>
+                <a:latin typeface="Arial" pitchFamily="34" charset="0"/>
+                <a:ea typeface="Arial" pitchFamily="34" charset="-122"/>
+                <a:cs typeface="Arial" pitchFamily="34" charset="-120"/>
+              </a:rPr>
+              <a:t>Here it isn't testing prompts. It's reasoning about structure.</a:t>
+            </a:r>
+            <a:endParaRPr lang="en-US" sz="1800" dirty="0"/>
           </a:p>
         </p:txBody>
       </p:sp>
@@ -5700,7 +5804,7 @@
                 <a:ea typeface="Cambria" pitchFamily="34" charset="-122"/>
                 <a:cs typeface="Cambria" pitchFamily="34" charset="-120"/>
               </a:rPr>
-              <a:t>…and the composition is still critical</a:t>
+              <a:t>The graph, in three steps</a:t>
             </a:r>
             <a:endParaRPr lang="en-US" sz="3200" dirty="0"/>
           </a:p>
@@ -5708,7 +5812,7 @@
       </p:sp>
       <p:pic>
         <p:nvPicPr>
-          <p:cNvPr id="3" name="Image 0" descr="/Users/leone.lage.perdigao/github/quanta/talk/assets/architecture-overlay.png">    </p:cNvPr>
+          <p:cNvPr id="3" name="Image 0" descr="/Users/leone.lage.perdigao/github/quanta/talk/assets/graph-evolution.png">    </p:cNvPr>
           <p:cNvPicPr>
             <a:picLocks noChangeAspect="1"/>
           </p:cNvPicPr>
@@ -5722,8 +5826,8 @@
         </p:blipFill>
         <p:spPr>
           <a:xfrm>
-            <a:off x="2284476" y="1417320"/>
-            <a:ext cx="7620000" cy="4572000"/>
+            <a:off x="640080" y="1612468"/>
+            <a:ext cx="10908792" cy="4181704"/>
           </a:xfrm>
           <a:prstGeom prst="rect">
             <a:avLst/>
@@ -5763,7 +5867,7 @@
                 <a:ea typeface="Arial" pitchFamily="34" charset="-122"/>
                 <a:cs typeface="Arial" pitchFamily="34" charset="-120"/>
               </a:rPr>
-              <a:t>Every control held. The path between them did not — and the agent can walk it.</a:t>
+              <a:t>Four approved tools → the agent can sequence them → one path is an exit.</a:t>
             </a:r>
             <a:endParaRPr lang="en-US" sz="1500" dirty="0"/>
           </a:p>
@@ -5834,7 +5938,7 @@
                 <a:ea typeface="Cambria" pitchFamily="34" charset="-122"/>
                 <a:cs typeface="Cambria" pitchFamily="34" charset="-120"/>
               </a:rPr>
-              <a:t>This isn't a drawing — it's the scan</a:t>
+              <a:t>…and the composition is still critical</a:t>
             </a:r>
             <a:endParaRPr lang="en-US" sz="3200" dirty="0"/>
           </a:p>
@@ -5842,7 +5946,7 @@
       </p:sp>
       <p:pic>
         <p:nvPicPr>
-          <p:cNvPr id="3" name="Image 0" descr="/Users/leone.lage.perdigao/github/quanta/talk/assets/ziran_report_dashboard.png">    </p:cNvPr>
+          <p:cNvPr id="3" name="Image 0" descr="/Users/leone.lage.perdigao/github/quanta/talk/assets/architecture-overlay.png">    </p:cNvPr>
           <p:cNvPicPr>
             <a:picLocks noChangeAspect="1"/>
           </p:cNvPicPr>
@@ -5856,8 +5960,8 @@
         </p:blipFill>
         <p:spPr>
           <a:xfrm>
-            <a:off x="2879789" y="1417320"/>
-            <a:ext cx="6429375" cy="4572000"/>
+            <a:off x="2284476" y="1417320"/>
+            <a:ext cx="7620000" cy="4572000"/>
           </a:xfrm>
           <a:prstGeom prst="rect">
             <a:avLst/>
@@ -5897,7 +6001,7 @@
                 <a:ea typeface="Arial" pitchFamily="34" charset="-122"/>
                 <a:cs typeface="Arial" pitchFamily="34" charset="-120"/>
               </a:rPr>
-              <a:t>One critical finding: search_database → send_email_report, data_exfiltration. I never labelled it — ZIRAN's built-in patterns did.</a:t>
+              <a:t>Every control held. The path between them did not — and the agent can walk it.</a:t>
             </a:r>
             <a:endParaRPr lang="en-US" sz="1500" dirty="0"/>
           </a:p>
@@ -5914,6 +6018,140 @@
 <file path=ppt/slides/slide18.xml><?xml version="1.0" encoding="utf-8"?>
 <p:sld xmlns:a="http://schemas.openxmlformats.org/drawingml/2006/main" xmlns:r="http://schemas.openxmlformats.org/officeDocument/2006/relationships" xmlns:p="http://schemas.openxmlformats.org/presentationml/2006/main">
   <p:cSld name="Slide 18">
+    <p:bg>
+      <p:bgPr>
+        <a:solidFill>
+          <a:srgbClr val="F8FAFC"/>
+        </a:solidFill>
+      </p:bgPr>
+    </p:bg>
+    <p:spTree>
+      <p:nvGrpSpPr>
+        <p:cNvPr id="1" name=""/>
+        <p:cNvGrpSpPr/>
+        <p:nvPr/>
+      </p:nvGrpSpPr>
+      <p:grpSpPr>
+        <a:xfrm>
+          <a:off x="0" y="0"/>
+          <a:ext cx="0" cy="0"/>
+          <a:chOff x="0" y="0"/>
+          <a:chExt cx="0" cy="0"/>
+        </a:xfrm>
+      </p:grpSpPr>
+      <p:sp>
+        <p:nvSpPr>
+          <p:cNvPr id="2" name="Text 0"/>
+          <p:cNvSpPr/>
+          <p:nvPr/>
+        </p:nvSpPr>
+        <p:spPr>
+          <a:xfrm>
+            <a:off x="640080" y="457200"/>
+            <a:ext cx="10972800" cy="822960"/>
+          </a:xfrm>
+          <a:prstGeom prst="rect">
+            <a:avLst/>
+          </a:prstGeom>
+          <a:noFill/>
+          <a:ln/>
+        </p:spPr>
+        <p:txBody>
+          <a:bodyPr wrap="square" rtlCol="0" anchor="ctr"/>
+          <a:lstStyle/>
+          <a:p>
+            <a:pPr indent="0" marL="0">
+              <a:buNone/>
+            </a:pPr>
+            <a:r>
+              <a:rPr lang="en-US" sz="3200" b="1" dirty="0">
+                <a:solidFill>
+                  <a:srgbClr val="0F172A"/>
+                </a:solidFill>
+                <a:latin typeface="Cambria" pitchFamily="34" charset="0"/>
+                <a:ea typeface="Cambria" pitchFamily="34" charset="-122"/>
+                <a:cs typeface="Cambria" pitchFamily="34" charset="-120"/>
+              </a:rPr>
+              <a:t>This isn't a drawing — it's the scan</a:t>
+            </a:r>
+            <a:endParaRPr lang="en-US" sz="3200" dirty="0"/>
+          </a:p>
+        </p:txBody>
+      </p:sp>
+      <p:pic>
+        <p:nvPicPr>
+          <p:cNvPr id="3" name="Image 0" descr="/Users/leone.lage.perdigao/github/quanta/talk/assets/ziran_graph.gif">    </p:cNvPr>
+          <p:cNvPicPr>
+            <a:picLocks noChangeAspect="1"/>
+          </p:cNvPicPr>
+          <p:nvPr/>
+        </p:nvPicPr>
+        <p:blipFill>
+          <a:blip r:embed="rId1"/>
+          <a:stretch>
+            <a:fillRect/>
+          </a:stretch>
+        </p:blipFill>
+        <p:spPr>
+          <a:xfrm>
+            <a:off x="3490172" y="1417320"/>
+            <a:ext cx="5208608" cy="4572000"/>
+          </a:xfrm>
+          <a:prstGeom prst="rect">
+            <a:avLst/>
+          </a:prstGeom>
+        </p:spPr>
+      </p:pic>
+      <p:sp>
+        <p:nvSpPr>
+          <p:cNvPr id="4" name="Text 1"/>
+          <p:cNvSpPr/>
+          <p:nvPr/>
+        </p:nvSpPr>
+        <p:spPr>
+          <a:xfrm>
+            <a:off x="640080" y="6126480"/>
+            <a:ext cx="10908792" cy="457200"/>
+          </a:xfrm>
+          <a:prstGeom prst="rect">
+            <a:avLst/>
+          </a:prstGeom>
+          <a:noFill/>
+          <a:ln/>
+        </p:spPr>
+        <p:txBody>
+          <a:bodyPr wrap="square" rtlCol="0" anchor="ctr"/>
+          <a:lstStyle/>
+          <a:p>
+            <a:pPr algn="ctr" indent="0" marL="0">
+              <a:buNone/>
+            </a:pPr>
+            <a:r>
+              <a:rPr lang="en-US" sz="1500" i="1" dirty="0">
+                <a:solidFill>
+                  <a:srgbClr val="64748B"/>
+                </a:solidFill>
+                <a:latin typeface="Arial" pitchFamily="34" charset="0"/>
+                <a:ea typeface="Arial" pitchFamily="34" charset="-122"/>
+                <a:cs typeface="Arial" pitchFamily="34" charset="-120"/>
+              </a:rPr>
+              <a:t>The real ZIRAN interactive graph. One critical finding: search_database → send_email_report, data_exfiltration.</a:t>
+            </a:r>
+            <a:endParaRPr lang="en-US" sz="1500" dirty="0"/>
+          </a:p>
+        </p:txBody>
+      </p:sp>
+    </p:spTree>
+  </p:cSld>
+  <p:clrMapOvr>
+    <a:masterClrMapping/>
+  </p:clrMapOvr>
+</p:sld>
+</file>
+
+<file path=ppt/slides/slide19.xml><?xml version="1.0" encoding="utf-8"?>
+<p:sld xmlns:a="http://schemas.openxmlformats.org/drawingml/2006/main" xmlns:r="http://schemas.openxmlformats.org/officeDocument/2006/relationships" xmlns:p="http://schemas.openxmlformats.org/presentationml/2006/main">
+  <p:cSld name="Slide 19">
     <p:bg>
       <p:bgPr>
         <a:solidFill>
@@ -6069,140 +6307,6 @@
               <a:t>ZIRAN found the path. Now watch an attacker walk it — then watch us close it.</a:t>
             </a:r>
             <a:endParaRPr lang="en-US" sz="1800" dirty="0"/>
-          </a:p>
-        </p:txBody>
-      </p:sp>
-    </p:spTree>
-  </p:cSld>
-  <p:clrMapOvr>
-    <a:masterClrMapping/>
-  </p:clrMapOvr>
-</p:sld>
-</file>
-
-<file path=ppt/slides/slide19.xml><?xml version="1.0" encoding="utf-8"?>
-<p:sld xmlns:a="http://schemas.openxmlformats.org/drawingml/2006/main" xmlns:r="http://schemas.openxmlformats.org/officeDocument/2006/relationships" xmlns:p="http://schemas.openxmlformats.org/presentationml/2006/main">
-  <p:cSld name="Slide 19">
-    <p:bg>
-      <p:bgPr>
-        <a:solidFill>
-          <a:srgbClr val="F8FAFC"/>
-        </a:solidFill>
-      </p:bgPr>
-    </p:bg>
-    <p:spTree>
-      <p:nvGrpSpPr>
-        <p:cNvPr id="1" name=""/>
-        <p:cNvGrpSpPr/>
-        <p:nvPr/>
-      </p:nvGrpSpPr>
-      <p:grpSpPr>
-        <a:xfrm>
-          <a:off x="0" y="0"/>
-          <a:ext cx="0" cy="0"/>
-          <a:chOff x="0" y="0"/>
-          <a:chExt cx="0" cy="0"/>
-        </a:xfrm>
-      </p:grpSpPr>
-      <p:sp>
-        <p:nvSpPr>
-          <p:cNvPr id="2" name="Text 0"/>
-          <p:cNvSpPr/>
-          <p:nvPr/>
-        </p:nvSpPr>
-        <p:spPr>
-          <a:xfrm>
-            <a:off x="640080" y="457200"/>
-            <a:ext cx="10972800" cy="822960"/>
-          </a:xfrm>
-          <a:prstGeom prst="rect">
-            <a:avLst/>
-          </a:prstGeom>
-          <a:noFill/>
-          <a:ln/>
-        </p:spPr>
-        <p:txBody>
-          <a:bodyPr wrap="square" rtlCol="0" anchor="ctr"/>
-          <a:lstStyle/>
-          <a:p>
-            <a:pPr indent="0" marL="0">
-              <a:buNone/>
-            </a:pPr>
-            <a:r>
-              <a:rPr lang="en-US" sz="3200" b="1" dirty="0">
-                <a:solidFill>
-                  <a:srgbClr val="0F172A"/>
-                </a:solidFill>
-                <a:latin typeface="Cambria" pitchFamily="34" charset="0"/>
-                <a:ea typeface="Cambria" pitchFamily="34" charset="-122"/>
-                <a:cs typeface="Cambria" pitchFamily="34" charset="-120"/>
-              </a:rPr>
-              <a:t>Theoretical? Watch it happen — live, offline</a:t>
-            </a:r>
-            <a:endParaRPr lang="en-US" sz="3200" dirty="0"/>
-          </a:p>
-        </p:txBody>
-      </p:sp>
-      <p:pic>
-        <p:nvPicPr>
-          <p:cNvPr id="3" name="Image 0" descr="/Users/leone.lage.perdigao/github/quanta/talk/assets/exploit_vulnerable.png">    </p:cNvPr>
-          <p:cNvPicPr>
-            <a:picLocks noChangeAspect="1"/>
-          </p:cNvPicPr>
-          <p:nvPr/>
-        </p:nvPicPr>
-        <p:blipFill>
-          <a:blip r:embed="rId1"/>
-          <a:stretch>
-            <a:fillRect/>
-          </a:stretch>
-        </p:blipFill>
-        <p:spPr>
-          <a:xfrm>
-            <a:off x="640080" y="2143710"/>
-            <a:ext cx="10908792" cy="3119219"/>
-          </a:xfrm>
-          <a:prstGeom prst="rect">
-            <a:avLst/>
-          </a:prstGeom>
-        </p:spPr>
-      </p:pic>
-      <p:sp>
-        <p:nvSpPr>
-          <p:cNvPr id="4" name="Text 1"/>
-          <p:cNvSpPr/>
-          <p:nvPr/>
-        </p:nvSpPr>
-        <p:spPr>
-          <a:xfrm>
-            <a:off x="640080" y="6126480"/>
-            <a:ext cx="10908792" cy="457200"/>
-          </a:xfrm>
-          <a:prstGeom prst="rect">
-            <a:avLst/>
-          </a:prstGeom>
-          <a:noFill/>
-          <a:ln/>
-        </p:spPr>
-        <p:txBody>
-          <a:bodyPr wrap="square" rtlCol="0" anchor="ctr"/>
-          <a:lstStyle/>
-          <a:p>
-            <a:pPr algn="ctr" indent="0" marL="0">
-              <a:buNone/>
-            </a:pPr>
-            <a:r>
-              <a:rPr lang="en-US" sz="1500" i="1" dirty="0">
-                <a:solidFill>
-                  <a:srgbClr val="64748B"/>
-                </a:solidFill>
-                <a:latin typeface="Arial" pitchFamily="34" charset="0"/>
-                <a:ea typeface="Arial" pitchFamily="34" charset="-122"/>
-                <a:cs typeface="Arial" pitchFamily="34" charset="-120"/>
-              </a:rPr>
-              <a:t>Benign request + a poisoned reference → 16,741 bytes of customer PII to an attacker mailbox on the ALLOWLISTED domain. Every per-tool control held.</a:t>
-            </a:r>
-            <a:endParaRPr lang="en-US" sz="1500" dirty="0"/>
           </a:p>
         </p:txBody>
       </p:sp>
@@ -6423,6 +6527,140 @@
                 <a:ea typeface="Cambria" pitchFamily="34" charset="-122"/>
                 <a:cs typeface="Cambria" pitchFamily="34" charset="-120"/>
               </a:rPr>
+              <a:t>Theoretical? Watch it happen — live, offline</a:t>
+            </a:r>
+            <a:endParaRPr lang="en-US" sz="3200" dirty="0"/>
+          </a:p>
+        </p:txBody>
+      </p:sp>
+      <p:pic>
+        <p:nvPicPr>
+          <p:cNvPr id="3" name="Image 0" descr="/Users/leone.lage.perdigao/github/quanta/talk/assets/exploit_vulnerable.png">    </p:cNvPr>
+          <p:cNvPicPr>
+            <a:picLocks noChangeAspect="1"/>
+          </p:cNvPicPr>
+          <p:nvPr/>
+        </p:nvPicPr>
+        <p:blipFill>
+          <a:blip r:embed="rId1"/>
+          <a:stretch>
+            <a:fillRect/>
+          </a:stretch>
+        </p:blipFill>
+        <p:spPr>
+          <a:xfrm>
+            <a:off x="640080" y="2143710"/>
+            <a:ext cx="10908792" cy="3119219"/>
+          </a:xfrm>
+          <a:prstGeom prst="rect">
+            <a:avLst/>
+          </a:prstGeom>
+        </p:spPr>
+      </p:pic>
+      <p:sp>
+        <p:nvSpPr>
+          <p:cNvPr id="4" name="Text 1"/>
+          <p:cNvSpPr/>
+          <p:nvPr/>
+        </p:nvSpPr>
+        <p:spPr>
+          <a:xfrm>
+            <a:off x="640080" y="6126480"/>
+            <a:ext cx="10908792" cy="457200"/>
+          </a:xfrm>
+          <a:prstGeom prst="rect">
+            <a:avLst/>
+          </a:prstGeom>
+          <a:noFill/>
+          <a:ln/>
+        </p:spPr>
+        <p:txBody>
+          <a:bodyPr wrap="square" rtlCol="0" anchor="ctr"/>
+          <a:lstStyle/>
+          <a:p>
+            <a:pPr algn="ctr" indent="0" marL="0">
+              <a:buNone/>
+            </a:pPr>
+            <a:r>
+              <a:rPr lang="en-US" sz="1500" i="1" dirty="0">
+                <a:solidFill>
+                  <a:srgbClr val="64748B"/>
+                </a:solidFill>
+                <a:latin typeface="Arial" pitchFamily="34" charset="0"/>
+                <a:ea typeface="Arial" pitchFamily="34" charset="-122"/>
+                <a:cs typeface="Arial" pitchFamily="34" charset="-120"/>
+              </a:rPr>
+              <a:t>Benign request + a poisoned reference → 16,741 bytes of customer PII to an attacker mailbox on the ALLOWLISTED domain. Every per-tool control held.</a:t>
+            </a:r>
+            <a:endParaRPr lang="en-US" sz="1500" dirty="0"/>
+          </a:p>
+        </p:txBody>
+      </p:sp>
+    </p:spTree>
+  </p:cSld>
+  <p:clrMapOvr>
+    <a:masterClrMapping/>
+  </p:clrMapOvr>
+</p:sld>
+</file>
+
+<file path=ppt/slides/slide21.xml><?xml version="1.0" encoding="utf-8"?>
+<p:sld xmlns:a="http://schemas.openxmlformats.org/drawingml/2006/main" xmlns:r="http://schemas.openxmlformats.org/officeDocument/2006/relationships" xmlns:p="http://schemas.openxmlformats.org/presentationml/2006/main">
+  <p:cSld name="Slide 21">
+    <p:bg>
+      <p:bgPr>
+        <a:solidFill>
+          <a:srgbClr val="F8FAFC"/>
+        </a:solidFill>
+      </p:bgPr>
+    </p:bg>
+    <p:spTree>
+      <p:nvGrpSpPr>
+        <p:cNvPr id="1" name=""/>
+        <p:cNvGrpSpPr/>
+        <p:nvPr/>
+      </p:nvGrpSpPr>
+      <p:grpSpPr>
+        <a:xfrm>
+          <a:off x="0" y="0"/>
+          <a:ext cx="0" cy="0"/>
+          <a:chOff x="0" y="0"/>
+          <a:chExt cx="0" cy="0"/>
+        </a:xfrm>
+      </p:grpSpPr>
+      <p:sp>
+        <p:nvSpPr>
+          <p:cNvPr id="2" name="Text 0"/>
+          <p:cNvSpPr/>
+          <p:nvPr/>
+        </p:nvSpPr>
+        <p:spPr>
+          <a:xfrm>
+            <a:off x="640080" y="457200"/>
+            <a:ext cx="10972800" cy="822960"/>
+          </a:xfrm>
+          <a:prstGeom prst="rect">
+            <a:avLst/>
+          </a:prstGeom>
+          <a:noFill/>
+          <a:ln/>
+        </p:spPr>
+        <p:txBody>
+          <a:bodyPr wrap="square" rtlCol="0" anchor="ctr"/>
+          <a:lstStyle/>
+          <a:p>
+            <a:pPr indent="0" marL="0">
+              <a:buNone/>
+            </a:pPr>
+            <a:r>
+              <a:rPr lang="en-US" sz="3200" b="1" dirty="0">
+                <a:solidFill>
+                  <a:srgbClr val="0F172A"/>
+                </a:solidFill>
+                <a:latin typeface="Cambria" pitchFamily="34" charset="0"/>
+                <a:ea typeface="Cambria" pitchFamily="34" charset="-122"/>
+                <a:cs typeface="Cambria" pitchFamily="34" charset="-120"/>
+              </a:rPr>
               <a:t>Three vulnerabilities, one agent</a:t>
             </a:r>
             <a:endParaRPr lang="en-US" sz="3200" dirty="0"/>
@@ -6431,7 +6669,7 @@
       </p:sp>
       <p:graphicFrame>
         <p:nvGraphicFramePr>
-          <p:cNvPr id="21" name="Table 0"/>
+          <p:cNvPr id="22" name="Table 0"/>
           <p:cNvGraphicFramePr>
             <a:graphicFrameLocks noGrp="1"/>
           </p:cNvGraphicFramePr>
@@ -7634,101 +7872,6 @@
 </p:sld>
 </file>
 
-<file path=ppt/slides/slide21.xml><?xml version="1.0" encoding="utf-8"?>
-<p:sld xmlns:a="http://schemas.openxmlformats.org/drawingml/2006/main" xmlns:r="http://schemas.openxmlformats.org/officeDocument/2006/relationships" xmlns:p="http://schemas.openxmlformats.org/presentationml/2006/main">
-  <p:cSld name="Slide 21">
-    <p:bg>
-      <p:bgPr>
-        <a:solidFill>
-          <a:srgbClr val="F8FAFC"/>
-        </a:solidFill>
-      </p:bgPr>
-    </p:bg>
-    <p:spTree>
-      <p:nvGrpSpPr>
-        <p:cNvPr id="1" name=""/>
-        <p:cNvGrpSpPr/>
-        <p:nvPr/>
-      </p:nvGrpSpPr>
-      <p:grpSpPr>
-        <a:xfrm>
-          <a:off x="0" y="0"/>
-          <a:ext cx="0" cy="0"/>
-          <a:chOff x="0" y="0"/>
-          <a:chExt cx="0" cy="0"/>
-        </a:xfrm>
-      </p:grpSpPr>
-      <p:sp>
-        <p:nvSpPr>
-          <p:cNvPr id="2" name="Text 0"/>
-          <p:cNvSpPr/>
-          <p:nvPr/>
-        </p:nvSpPr>
-        <p:spPr>
-          <a:xfrm>
-            <a:off x="640080" y="457200"/>
-            <a:ext cx="10972800" cy="822960"/>
-          </a:xfrm>
-          <a:prstGeom prst="rect">
-            <a:avLst/>
-          </a:prstGeom>
-          <a:noFill/>
-          <a:ln/>
-        </p:spPr>
-        <p:txBody>
-          <a:bodyPr wrap="square" rtlCol="0" anchor="ctr"/>
-          <a:lstStyle/>
-          <a:p>
-            <a:pPr indent="0" marL="0">
-              <a:buNone/>
-            </a:pPr>
-            <a:r>
-              <a:rPr lang="en-US" sz="3200" b="1" dirty="0">
-                <a:solidFill>
-                  <a:srgbClr val="0F172A"/>
-                </a:solidFill>
-                <a:latin typeface="Cambria" pitchFamily="34" charset="0"/>
-                <a:ea typeface="Cambria" pitchFamily="34" charset="-122"/>
-                <a:cs typeface="Cambria" pitchFamily="34" charset="-120"/>
-              </a:rPr>
-              <a:t>What's behind the scan</a:t>
-            </a:r>
-            <a:endParaRPr lang="en-US" sz="3200" dirty="0"/>
-          </a:p>
-        </p:txBody>
-      </p:sp>
-      <p:pic>
-        <p:nvPicPr>
-          <p:cNvPr id="3" name="Image 0" descr="/Users/leone.lage.perdigao/github/quanta/talk/assets/credibility.png">    </p:cNvPr>
-          <p:cNvPicPr>
-            <a:picLocks noChangeAspect="1"/>
-          </p:cNvPicPr>
-          <p:nvPr/>
-        </p:nvPicPr>
-        <p:blipFill>
-          <a:blip r:embed="rId1"/>
-          <a:stretch>
-            <a:fillRect/>
-          </a:stretch>
-        </p:blipFill>
-        <p:spPr>
-          <a:xfrm>
-            <a:off x="1244890" y="1417320"/>
-            <a:ext cx="9699171" cy="4937760"/>
-          </a:xfrm>
-          <a:prstGeom prst="rect">
-            <a:avLst/>
-          </a:prstGeom>
-        </p:spPr>
-      </p:pic>
-    </p:spTree>
-  </p:cSld>
-  <p:clrMapOvr>
-    <a:masterClrMapping/>
-  </p:clrMapOvr>
-</p:sld>
-</file>
-
 <file path=ppt/slides/slide22.xml><?xml version="1.0" encoding="utf-8"?>
 <p:sld xmlns:a="http://schemas.openxmlformats.org/drawingml/2006/main" xmlns:r="http://schemas.openxmlformats.org/officeDocument/2006/relationships" xmlns:p="http://schemas.openxmlformats.org/presentationml/2006/main">
   <p:cSld name="Slide 22">
@@ -7786,7 +7929,7 @@
                 <a:ea typeface="Cambria" pitchFamily="34" charset="-122"/>
                 <a:cs typeface="Cambria" pitchFamily="34" charset="-120"/>
               </a:rPr>
-              <a:t>Break the graph: the same attack, blocked</a:t>
+              <a:t>What's behind the scan</a:t>
             </a:r>
             <a:endParaRPr lang="en-US" sz="3200" dirty="0"/>
           </a:p>
@@ -7794,7 +7937,7 @@
       </p:sp>
       <p:pic>
         <p:nvPicPr>
-          <p:cNvPr id="3" name="Image 0" descr="/Users/leone.lage.perdigao/github/quanta/talk/assets/exploit_hardened.png">    </p:cNvPr>
+          <p:cNvPr id="3" name="Image 0" descr="/Users/leone.lage.perdigao/github/quanta/talk/assets/credibility.png">    </p:cNvPr>
           <p:cNvPicPr>
             <a:picLocks noChangeAspect="1"/>
           </p:cNvPicPr>
@@ -7808,53 +7951,14 @@
         </p:blipFill>
         <p:spPr>
           <a:xfrm>
-            <a:off x="640080" y="2249662"/>
-            <a:ext cx="10908792" cy="2907316"/>
+            <a:off x="1244890" y="1417320"/>
+            <a:ext cx="9699171" cy="4937760"/>
           </a:xfrm>
           <a:prstGeom prst="rect">
             <a:avLst/>
           </a:prstGeom>
         </p:spPr>
       </p:pic>
-      <p:sp>
-        <p:nvSpPr>
-          <p:cNvPr id="4" name="Text 1"/>
-          <p:cNvSpPr/>
-          <p:nvPr/>
-        </p:nvSpPr>
-        <p:spPr>
-          <a:xfrm>
-            <a:off x="640080" y="6126480"/>
-            <a:ext cx="10908792" cy="457200"/>
-          </a:xfrm>
-          <a:prstGeom prst="rect">
-            <a:avLst/>
-          </a:prstGeom>
-          <a:noFill/>
-          <a:ln/>
-        </p:spPr>
-        <p:txBody>
-          <a:bodyPr wrap="square" rtlCol="0" anchor="ctr"/>
-          <a:lstStyle/>
-          <a:p>
-            <a:pPr algn="ctr" indent="0" marL="0">
-              <a:buNone/>
-            </a:pPr>
-            <a:r>
-              <a:rPr lang="en-US" sz="1500" i="1" dirty="0">
-                <a:solidFill>
-                  <a:srgbClr val="64748B"/>
-                </a:solidFill>
-                <a:latin typeface="Arial" pitchFamily="34" charset="0"/>
-                <a:ea typeface="Arial" pitchFamily="34" charset="-122"/>
-                <a:cs typeface="Arial" pitchFamily="34" charset="-120"/>
-              </a:rPr>
-              <a:t>One injected security policy. Injection refused as data; model-chosen recipient denied; the analyst's summary still goes out. Same agent, same payload.</a:t>
-            </a:r>
-            <a:endParaRPr lang="en-US" sz="1500" dirty="0"/>
-          </a:p>
-        </p:txBody>
-      </p:sp>
     </p:spTree>
   </p:cSld>
   <p:clrMapOvr>
@@ -7920,69 +8024,46 @@
                 <a:ea typeface="Cambria" pitchFamily="34" charset="-122"/>
                 <a:cs typeface="Cambria" pitchFamily="34" charset="-120"/>
               </a:rPr>
-              <a:t>The fix isn't 'remove a tool'. Break the graph.</a:t>
+              <a:t>Break the graph: the same attack, blocked</a:t>
             </a:r>
             <a:endParaRPr lang="en-US" sz="3200" dirty="0"/>
           </a:p>
         </p:txBody>
       </p:sp>
-      <p:sp>
-        <p:nvSpPr>
-          <p:cNvPr id="3" name="Shape 1"/>
-          <p:cNvSpPr/>
-          <p:nvPr/>
-        </p:nvSpPr>
-        <p:spPr>
-          <a:xfrm>
-            <a:off x="640080" y="1508760"/>
-            <a:ext cx="10908792" cy="1024128"/>
-          </a:xfrm>
-          <a:prstGeom prst="roundRect">
-            <a:avLst>
-              <a:gd name="adj" fmla="val 8929"/>
-            </a:avLst>
-          </a:prstGeom>
-          <a:solidFill>
-            <a:srgbClr val="FFFFFF"/>
-          </a:solidFill>
-          <a:ln w="12700">
-            <a:solidFill>
-              <a:srgbClr val="E2E8F0"/>
-            </a:solidFill>
-            <a:prstDash val="solid"/>
-          </a:ln>
-        </p:spPr>
-      </p:sp>
-      <p:sp>
-        <p:nvSpPr>
-          <p:cNvPr id="4" name="Shape 2"/>
-          <p:cNvSpPr/>
-          <p:nvPr/>
-        </p:nvSpPr>
-        <p:spPr>
-          <a:xfrm>
-            <a:off x="914400" y="1792224"/>
-            <a:ext cx="457200" cy="457200"/>
-          </a:xfrm>
-          <a:prstGeom prst="ellipse">
-            <a:avLst/>
-          </a:prstGeom>
-          <a:solidFill>
-            <a:srgbClr val="059669"/>
-          </a:solidFill>
-          <a:ln/>
-        </p:spPr>
-      </p:sp>
-      <p:sp>
-        <p:nvSpPr>
-          <p:cNvPr id="5" name="Text 3"/>
-          <p:cNvSpPr/>
-          <p:nvPr/>
-        </p:nvSpPr>
-        <p:spPr>
-          <a:xfrm>
-            <a:off x="914400" y="1792224"/>
-            <a:ext cx="457200" cy="457200"/>
+      <p:pic>
+        <p:nvPicPr>
+          <p:cNvPr id="3" name="Image 0" descr="/Users/leone.lage.perdigao/github/quanta/talk/assets/exploit_hardened.png">    </p:cNvPr>
+          <p:cNvPicPr>
+            <a:picLocks noChangeAspect="1"/>
+          </p:cNvPicPr>
+          <p:nvPr/>
+        </p:nvPicPr>
+        <p:blipFill>
+          <a:blip r:embed="rId1"/>
+          <a:stretch>
+            <a:fillRect/>
+          </a:stretch>
+        </p:blipFill>
+        <p:spPr>
+          <a:xfrm>
+            <a:off x="640080" y="2249662"/>
+            <a:ext cx="10908792" cy="2907316"/>
+          </a:xfrm>
+          <a:prstGeom prst="rect">
+            <a:avLst/>
+          </a:prstGeom>
+        </p:spPr>
+      </p:pic>
+      <p:sp>
+        <p:nvSpPr>
+          <p:cNvPr id="4" name="Text 1"/>
+          <p:cNvSpPr/>
+          <p:nvPr/>
+        </p:nvSpPr>
+        <p:spPr>
+          <a:xfrm>
+            <a:off x="640080" y="6126480"/>
+            <a:ext cx="10908792" cy="457200"/>
           </a:xfrm>
           <a:prstGeom prst="rect">
             <a:avLst/>
@@ -7998,587 +8079,17 @@
               <a:buNone/>
             </a:pPr>
             <a:r>
-              <a:rPr lang="en-US" sz="1800" b="1" dirty="0">
-                <a:solidFill>
-                  <a:srgbClr val="FFFFFF"/>
-                </a:solidFill>
-              </a:rPr>
-              <a:t>✓</a:t>
-            </a:r>
-            <a:endParaRPr lang="en-US" sz="1800" dirty="0"/>
-          </a:p>
-        </p:txBody>
-      </p:sp>
-      <p:sp>
-        <p:nvSpPr>
-          <p:cNvPr id="6" name="Text 4"/>
-          <p:cNvSpPr/>
-          <p:nvPr/>
-        </p:nvSpPr>
-        <p:spPr>
-          <a:xfrm>
-            <a:off x="1600200" y="1508760"/>
-            <a:ext cx="4023360" cy="1024128"/>
-          </a:xfrm>
-          <a:prstGeom prst="rect">
-            <a:avLst/>
-          </a:prstGeom>
-          <a:noFill/>
-          <a:ln/>
-        </p:spPr>
-        <p:txBody>
-          <a:bodyPr wrap="square" rtlCol="0" anchor="ctr"/>
-          <a:lstStyle/>
-          <a:p>
-            <a:pPr indent="0" marL="0">
-              <a:buNone/>
-            </a:pPr>
-            <a:r>
-              <a:rPr lang="en-US" sz="1600" b="1" dirty="0">
-                <a:solidFill>
-                  <a:srgbClr val="0F172A"/>
-                </a:solidFill>
-                <a:latin typeface="Cambria" pitchFamily="34" charset="0"/>
-                <a:ea typeface="Cambria" pitchFamily="34" charset="-122"/>
-                <a:cs typeface="Cambria" pitchFamily="34" charset="-120"/>
-              </a:rPr>
-              <a:t>No instructions from data  ·  LLM01</a:t>
-            </a:r>
-            <a:endParaRPr lang="en-US" sz="1600" dirty="0"/>
-          </a:p>
-        </p:txBody>
-      </p:sp>
-      <p:sp>
-        <p:nvSpPr>
-          <p:cNvPr id="7" name="Text 5"/>
-          <p:cNvSpPr/>
-          <p:nvPr/>
-        </p:nvSpPr>
-        <p:spPr>
-          <a:xfrm>
-            <a:off x="5669280" y="1508760"/>
-            <a:ext cx="5669280" cy="1024128"/>
-          </a:xfrm>
-          <a:prstGeom prst="rect">
-            <a:avLst/>
-          </a:prstGeom>
-          <a:noFill/>
-          <a:ln/>
-        </p:spPr>
-        <p:txBody>
-          <a:bodyPr wrap="square" rtlCol="0" anchor="ctr"/>
-          <a:lstStyle/>
-          <a:p>
-            <a:pPr indent="0" marL="0">
-              <a:lnSpc>
-                <a:spcPct val="105000"/>
-              </a:lnSpc>
-              <a:buNone/>
-            </a:pPr>
-            <a:r>
-              <a:rPr lang="en-US" sz="1400" dirty="0">
-                <a:solidFill>
-                  <a:srgbClr val="334155"/>
+              <a:rPr lang="en-US" sz="1500" i="1" dirty="0">
+                <a:solidFill>
+                  <a:srgbClr val="64748B"/>
                 </a:solidFill>
                 <a:latin typeface="Arial" pitchFamily="34" charset="0"/>
                 <a:ea typeface="Arial" pitchFamily="34" charset="-122"/>
                 <a:cs typeface="Arial" pitchFamily="34" charset="-120"/>
               </a:rPr>
-              <a:t>Content from fetch_reference is data, never commands — the injected step never runs.</a:t>
-            </a:r>
-            <a:endParaRPr lang="en-US" sz="1400" dirty="0"/>
-          </a:p>
-        </p:txBody>
-      </p:sp>
-      <p:sp>
-        <p:nvSpPr>
-          <p:cNvPr id="8" name="Shape 6"/>
-          <p:cNvSpPr/>
-          <p:nvPr/>
-        </p:nvSpPr>
-        <p:spPr>
-          <a:xfrm>
-            <a:off x="640080" y="2624328"/>
-            <a:ext cx="10908792" cy="1024128"/>
-          </a:xfrm>
-          <a:prstGeom prst="roundRect">
-            <a:avLst>
-              <a:gd name="adj" fmla="val 8929"/>
-            </a:avLst>
-          </a:prstGeom>
-          <a:solidFill>
-            <a:srgbClr val="FFFFFF"/>
-          </a:solidFill>
-          <a:ln w="12700">
-            <a:solidFill>
-              <a:srgbClr val="E2E8F0"/>
-            </a:solidFill>
-            <a:prstDash val="solid"/>
-          </a:ln>
-        </p:spPr>
-      </p:sp>
-      <p:sp>
-        <p:nvSpPr>
-          <p:cNvPr id="9" name="Shape 7"/>
-          <p:cNvSpPr/>
-          <p:nvPr/>
-        </p:nvSpPr>
-        <p:spPr>
-          <a:xfrm>
-            <a:off x="914400" y="2907792"/>
-            <a:ext cx="457200" cy="457200"/>
-          </a:xfrm>
-          <a:prstGeom prst="ellipse">
-            <a:avLst/>
-          </a:prstGeom>
-          <a:solidFill>
-            <a:srgbClr val="059669"/>
-          </a:solidFill>
-          <a:ln/>
-        </p:spPr>
-      </p:sp>
-      <p:sp>
-        <p:nvSpPr>
-          <p:cNvPr id="10" name="Text 8"/>
-          <p:cNvSpPr/>
-          <p:nvPr/>
-        </p:nvSpPr>
-        <p:spPr>
-          <a:xfrm>
-            <a:off x="914400" y="2907792"/>
-            <a:ext cx="457200" cy="457200"/>
-          </a:xfrm>
-          <a:prstGeom prst="rect">
-            <a:avLst/>
-          </a:prstGeom>
-          <a:noFill/>
-          <a:ln/>
-        </p:spPr>
-        <p:txBody>
-          <a:bodyPr wrap="square" rtlCol="0" anchor="ctr"/>
-          <a:lstStyle/>
-          <a:p>
-            <a:pPr algn="ctr" indent="0" marL="0">
-              <a:buNone/>
-            </a:pPr>
-            <a:r>
-              <a:rPr lang="en-US" sz="1800" b="1" dirty="0">
-                <a:solidFill>
-                  <a:srgbClr val="FFFFFF"/>
-                </a:solidFill>
-              </a:rPr>
-              <a:t>✓</a:t>
-            </a:r>
-            <a:endParaRPr lang="en-US" sz="1800" dirty="0"/>
-          </a:p>
-        </p:txBody>
-      </p:sp>
-      <p:sp>
-        <p:nvSpPr>
-          <p:cNvPr id="11" name="Text 9"/>
-          <p:cNvSpPr/>
-          <p:nvPr/>
-        </p:nvSpPr>
-        <p:spPr>
-          <a:xfrm>
-            <a:off x="1600200" y="2624328"/>
-            <a:ext cx="4023360" cy="1024128"/>
-          </a:xfrm>
-          <a:prstGeom prst="rect">
-            <a:avLst/>
-          </a:prstGeom>
-          <a:noFill/>
-          <a:ln/>
-        </p:spPr>
-        <p:txBody>
-          <a:bodyPr wrap="square" rtlCol="0" anchor="ctr"/>
-          <a:lstStyle/>
-          <a:p>
-            <a:pPr indent="0" marL="0">
-              <a:buNone/>
-            </a:pPr>
-            <a:r>
-              <a:rPr lang="en-US" sz="1600" b="1" dirty="0">
-                <a:solidFill>
-                  <a:srgbClr val="0F172A"/>
-                </a:solidFill>
-                <a:latin typeface="Cambria" pitchFamily="34" charset="0"/>
-                <a:ea typeface="Cambria" pitchFamily="34" charset="-122"/>
-                <a:cs typeface="Cambria" pitchFamily="34" charset="-120"/>
-              </a:rPr>
-              <a:t>Recipient binding  ·  LLM06</a:t>
-            </a:r>
-            <a:endParaRPr lang="en-US" sz="1600" dirty="0"/>
-          </a:p>
-        </p:txBody>
-      </p:sp>
-      <p:sp>
-        <p:nvSpPr>
-          <p:cNvPr id="12" name="Text 10"/>
-          <p:cNvSpPr/>
-          <p:nvPr/>
-        </p:nvSpPr>
-        <p:spPr>
-          <a:xfrm>
-            <a:off x="5669280" y="2624328"/>
-            <a:ext cx="5669280" cy="1024128"/>
-          </a:xfrm>
-          <a:prstGeom prst="rect">
-            <a:avLst/>
-          </a:prstGeom>
-          <a:noFill/>
-          <a:ln/>
-        </p:spPr>
-        <p:txBody>
-          <a:bodyPr wrap="square" rtlCol="0" anchor="ctr"/>
-          <a:lstStyle/>
-          <a:p>
-            <a:pPr indent="0" marL="0">
-              <a:lnSpc>
-                <a:spcPct val="105000"/>
-              </a:lnSpc>
-              <a:buNone/>
-            </a:pPr>
-            <a:r>
-              <a:rPr lang="en-US" sz="1400" dirty="0">
-                <a:solidFill>
-                  <a:srgbClr val="334155"/>
-                </a:solidFill>
-                <a:latin typeface="Arial" pitchFamily="34" charset="0"/>
-                <a:ea typeface="Arial" pitchFamily="34" charset="-122"/>
-                <a:cs typeface="Arial" pitchFamily="34" charset="-120"/>
-              </a:rPr>
-              <a:t>send_email_report only reaches the authenticated requester — not a model-chosen address, even on an allowlisted domain.</a:t>
-            </a:r>
-            <a:endParaRPr lang="en-US" sz="1400" dirty="0"/>
-          </a:p>
-        </p:txBody>
-      </p:sp>
-      <p:sp>
-        <p:nvSpPr>
-          <p:cNvPr id="13" name="Shape 11"/>
-          <p:cNvSpPr/>
-          <p:nvPr/>
-        </p:nvSpPr>
-        <p:spPr>
-          <a:xfrm>
-            <a:off x="640080" y="3739896"/>
-            <a:ext cx="10908792" cy="1024128"/>
-          </a:xfrm>
-          <a:prstGeom prst="roundRect">
-            <a:avLst>
-              <a:gd name="adj" fmla="val 8929"/>
-            </a:avLst>
-          </a:prstGeom>
-          <a:solidFill>
-            <a:srgbClr val="FFFFFF"/>
-          </a:solidFill>
-          <a:ln w="12700">
-            <a:solidFill>
-              <a:srgbClr val="E2E8F0"/>
-            </a:solidFill>
-            <a:prstDash val="solid"/>
-          </a:ln>
-        </p:spPr>
-      </p:sp>
-      <p:sp>
-        <p:nvSpPr>
-          <p:cNvPr id="14" name="Shape 12"/>
-          <p:cNvSpPr/>
-          <p:nvPr/>
-        </p:nvSpPr>
-        <p:spPr>
-          <a:xfrm>
-            <a:off x="914400" y="4023360"/>
-            <a:ext cx="457200" cy="457200"/>
-          </a:xfrm>
-          <a:prstGeom prst="ellipse">
-            <a:avLst/>
-          </a:prstGeom>
-          <a:solidFill>
-            <a:srgbClr val="059669"/>
-          </a:solidFill>
-          <a:ln/>
-        </p:spPr>
-      </p:sp>
-      <p:sp>
-        <p:nvSpPr>
-          <p:cNvPr id="15" name="Text 13"/>
-          <p:cNvSpPr/>
-          <p:nvPr/>
-        </p:nvSpPr>
-        <p:spPr>
-          <a:xfrm>
-            <a:off x="914400" y="4023360"/>
-            <a:ext cx="457200" cy="457200"/>
-          </a:xfrm>
-          <a:prstGeom prst="rect">
-            <a:avLst/>
-          </a:prstGeom>
-          <a:noFill/>
-          <a:ln/>
-        </p:spPr>
-        <p:txBody>
-          <a:bodyPr wrap="square" rtlCol="0" anchor="ctr"/>
-          <a:lstStyle/>
-          <a:p>
-            <a:pPr algn="ctr" indent="0" marL="0">
-              <a:buNone/>
-            </a:pPr>
-            <a:r>
-              <a:rPr lang="en-US" sz="1800" b="1" dirty="0">
-                <a:solidFill>
-                  <a:srgbClr val="FFFFFF"/>
-                </a:solidFill>
-              </a:rPr>
-              <a:t>✓</a:t>
-            </a:r>
-            <a:endParaRPr lang="en-US" sz="1800" dirty="0"/>
-          </a:p>
-        </p:txBody>
-      </p:sp>
-      <p:sp>
-        <p:nvSpPr>
-          <p:cNvPr id="16" name="Text 14"/>
-          <p:cNvSpPr/>
-          <p:nvPr/>
-        </p:nvSpPr>
-        <p:spPr>
-          <a:xfrm>
-            <a:off x="1600200" y="3739896"/>
-            <a:ext cx="4023360" cy="1024128"/>
-          </a:xfrm>
-          <a:prstGeom prst="rect">
-            <a:avLst/>
-          </a:prstGeom>
-          <a:noFill/>
-          <a:ln/>
-        </p:spPr>
-        <p:txBody>
-          <a:bodyPr wrap="square" rtlCol="0" anchor="ctr"/>
-          <a:lstStyle/>
-          <a:p>
-            <a:pPr indent="0" marL="0">
-              <a:buNone/>
-            </a:pPr>
-            <a:r>
-              <a:rPr lang="en-US" sz="1600" b="1" dirty="0">
-                <a:solidFill>
-                  <a:srgbClr val="0F172A"/>
-                </a:solidFill>
-                <a:latin typeface="Cambria" pitchFamily="34" charset="0"/>
-                <a:ea typeface="Cambria" pitchFamily="34" charset="-122"/>
-                <a:cs typeface="Cambria" pitchFamily="34" charset="-120"/>
-              </a:rPr>
-              <a:t>Trifecta gate  ·  taint tracking</a:t>
-            </a:r>
-            <a:endParaRPr lang="en-US" sz="1600" dirty="0"/>
-          </a:p>
-        </p:txBody>
-      </p:sp>
-      <p:sp>
-        <p:nvSpPr>
-          <p:cNvPr id="17" name="Text 15"/>
-          <p:cNvSpPr/>
-          <p:nvPr/>
-        </p:nvSpPr>
-        <p:spPr>
-          <a:xfrm>
-            <a:off x="5669280" y="3739896"/>
-            <a:ext cx="5669280" cy="1024128"/>
-          </a:xfrm>
-          <a:prstGeom prst="rect">
-            <a:avLst/>
-          </a:prstGeom>
-          <a:noFill/>
-          <a:ln/>
-        </p:spPr>
-        <p:txBody>
-          <a:bodyPr wrap="square" rtlCol="0" anchor="ctr"/>
-          <a:lstStyle/>
-          <a:p>
-            <a:pPr indent="0" marL="0">
-              <a:lnSpc>
-                <a:spcPct val="105000"/>
-              </a:lnSpc>
-              <a:buNone/>
-            </a:pPr>
-            <a:r>
-              <a:rPr lang="en-US" sz="1400" dirty="0">
-                <a:solidFill>
-                  <a:srgbClr val="334155"/>
-                </a:solidFill>
-                <a:latin typeface="Arial" pitchFamily="34" charset="0"/>
-                <a:ea typeface="Arial" pitchFamily="34" charset="-122"/>
-                <a:cs typeface="Arial" pitchFamily="34" charset="-120"/>
-              </a:rPr>
-              <a:t>A run holding private + untrusted data can't reach an external sink unattended. Aggregates aren't private — the real task still works.</a:t>
-            </a:r>
-            <a:endParaRPr lang="en-US" sz="1400" dirty="0"/>
-          </a:p>
-        </p:txBody>
-      </p:sp>
-      <p:sp>
-        <p:nvSpPr>
-          <p:cNvPr id="18" name="Shape 16"/>
-          <p:cNvSpPr/>
-          <p:nvPr/>
-        </p:nvSpPr>
-        <p:spPr>
-          <a:xfrm>
-            <a:off x="640080" y="4855464"/>
-            <a:ext cx="10908792" cy="1024128"/>
-          </a:xfrm>
-          <a:prstGeom prst="roundRect">
-            <a:avLst>
-              <a:gd name="adj" fmla="val 8929"/>
-            </a:avLst>
-          </a:prstGeom>
-          <a:solidFill>
-            <a:srgbClr val="FFFFFF"/>
-          </a:solidFill>
-          <a:ln w="12700">
-            <a:solidFill>
-              <a:srgbClr val="E2E8F0"/>
-            </a:solidFill>
-            <a:prstDash val="solid"/>
-          </a:ln>
-        </p:spPr>
-      </p:sp>
-      <p:sp>
-        <p:nvSpPr>
-          <p:cNvPr id="19" name="Shape 17"/>
-          <p:cNvSpPr/>
-          <p:nvPr/>
-        </p:nvSpPr>
-        <p:spPr>
-          <a:xfrm>
-            <a:off x="914400" y="5138928"/>
-            <a:ext cx="457200" cy="457200"/>
-          </a:xfrm>
-          <a:prstGeom prst="ellipse">
-            <a:avLst/>
-          </a:prstGeom>
-          <a:solidFill>
-            <a:srgbClr val="059669"/>
-          </a:solidFill>
-          <a:ln/>
-        </p:spPr>
-      </p:sp>
-      <p:sp>
-        <p:nvSpPr>
-          <p:cNvPr id="20" name="Text 18"/>
-          <p:cNvSpPr/>
-          <p:nvPr/>
-        </p:nvSpPr>
-        <p:spPr>
-          <a:xfrm>
-            <a:off x="914400" y="5138928"/>
-            <a:ext cx="457200" cy="457200"/>
-          </a:xfrm>
-          <a:prstGeom prst="rect">
-            <a:avLst/>
-          </a:prstGeom>
-          <a:noFill/>
-          <a:ln/>
-        </p:spPr>
-        <p:txBody>
-          <a:bodyPr wrap="square" rtlCol="0" anchor="ctr"/>
-          <a:lstStyle/>
-          <a:p>
-            <a:pPr algn="ctr" indent="0" marL="0">
-              <a:buNone/>
-            </a:pPr>
-            <a:r>
-              <a:rPr lang="en-US" sz="1800" b="1" dirty="0">
-                <a:solidFill>
-                  <a:srgbClr val="FFFFFF"/>
-                </a:solidFill>
-              </a:rPr>
-              <a:t>✓</a:t>
-            </a:r>
-            <a:endParaRPr lang="en-US" sz="1800" dirty="0"/>
-          </a:p>
-        </p:txBody>
-      </p:sp>
-      <p:sp>
-        <p:nvSpPr>
-          <p:cNvPr id="21" name="Text 19"/>
-          <p:cNvSpPr/>
-          <p:nvPr/>
-        </p:nvSpPr>
-        <p:spPr>
-          <a:xfrm>
-            <a:off x="1600200" y="4855464"/>
-            <a:ext cx="4023360" cy="1024128"/>
-          </a:xfrm>
-          <a:prstGeom prst="rect">
-            <a:avLst/>
-          </a:prstGeom>
-          <a:noFill/>
-          <a:ln/>
-        </p:spPr>
-        <p:txBody>
-          <a:bodyPr wrap="square" rtlCol="0" anchor="ctr"/>
-          <a:lstStyle/>
-          <a:p>
-            <a:pPr indent="0" marL="0">
-              <a:buNone/>
-            </a:pPr>
-            <a:r>
-              <a:rPr lang="en-US" sz="1600" b="1" dirty="0">
-                <a:solidFill>
-                  <a:srgbClr val="0F172A"/>
-                </a:solidFill>
-                <a:latin typeface="Cambria" pitchFamily="34" charset="0"/>
-                <a:ea typeface="Cambria" pitchFamily="34" charset="-122"/>
-                <a:cs typeface="Cambria" pitchFamily="34" charset="-120"/>
-              </a:rPr>
-              <a:t>Re-scan in CI  ·  ziran ci</a:t>
-            </a:r>
-            <a:endParaRPr lang="en-US" sz="1600" dirty="0"/>
-          </a:p>
-        </p:txBody>
-      </p:sp>
-      <p:sp>
-        <p:nvSpPr>
-          <p:cNvPr id="22" name="Text 20"/>
-          <p:cNvSpPr/>
-          <p:nvPr/>
-        </p:nvSpPr>
-        <p:spPr>
-          <a:xfrm>
-            <a:off x="5669280" y="4855464"/>
-            <a:ext cx="5669280" cy="1024128"/>
-          </a:xfrm>
-          <a:prstGeom prst="rect">
-            <a:avLst/>
-          </a:prstGeom>
-          <a:noFill/>
-          <a:ln/>
-        </p:spPr>
-        <p:txBody>
-          <a:bodyPr wrap="square" rtlCol="0" anchor="ctr"/>
-          <a:lstStyle/>
-          <a:p>
-            <a:pPr indent="0" marL="0">
-              <a:lnSpc>
-                <a:spcPct val="105000"/>
-              </a:lnSpc>
-              <a:buNone/>
-            </a:pPr>
-            <a:r>
-              <a:rPr lang="en-US" sz="1400" dirty="0">
-                <a:solidFill>
-                  <a:srgbClr val="334155"/>
-                </a:solidFill>
-                <a:latin typeface="Arial" pitchFamily="34" charset="0"/>
-                <a:ea typeface="Arial" pitchFamily="34" charset="-122"/>
-                <a:cs typeface="Arial" pitchFamily="34" charset="-120"/>
-              </a:rPr>
-              <a:t>Fail the build when a newly-added tool completes a trifecta. Composition as a reviewable artifact.</a:t>
-            </a:r>
-            <a:endParaRPr lang="en-US" sz="1400" dirty="0"/>
+              <a:t>One injected security policy. Injection refused as data; model-chosen recipient denied; the analyst's summary still goes out. Same agent, same payload.</a:t>
+            </a:r>
+            <a:endParaRPr lang="en-US" sz="1500" dirty="0"/>
           </a:p>
         </p:txBody>
       </p:sp>
@@ -8593,6 +8104,733 @@
 <file path=ppt/slides/slide24.xml><?xml version="1.0" encoding="utf-8"?>
 <p:sld xmlns:a="http://schemas.openxmlformats.org/drawingml/2006/main" xmlns:r="http://schemas.openxmlformats.org/officeDocument/2006/relationships" xmlns:p="http://schemas.openxmlformats.org/presentationml/2006/main">
   <p:cSld name="Slide 24">
+    <p:bg>
+      <p:bgPr>
+        <a:solidFill>
+          <a:srgbClr val="F8FAFC"/>
+        </a:solidFill>
+      </p:bgPr>
+    </p:bg>
+    <p:spTree>
+      <p:nvGrpSpPr>
+        <p:cNvPr id="1" name=""/>
+        <p:cNvGrpSpPr/>
+        <p:nvPr/>
+      </p:nvGrpSpPr>
+      <p:grpSpPr>
+        <a:xfrm>
+          <a:off x="0" y="0"/>
+          <a:ext cx="0" cy="0"/>
+          <a:chOff x="0" y="0"/>
+          <a:chExt cx="0" cy="0"/>
+        </a:xfrm>
+      </p:grpSpPr>
+      <p:sp>
+        <p:nvSpPr>
+          <p:cNvPr id="2" name="Text 0"/>
+          <p:cNvSpPr/>
+          <p:nvPr/>
+        </p:nvSpPr>
+        <p:spPr>
+          <a:xfrm>
+            <a:off x="640080" y="457200"/>
+            <a:ext cx="10972800" cy="822960"/>
+          </a:xfrm>
+          <a:prstGeom prst="rect">
+            <a:avLst/>
+          </a:prstGeom>
+          <a:noFill/>
+          <a:ln/>
+        </p:spPr>
+        <p:txBody>
+          <a:bodyPr wrap="square" rtlCol="0" anchor="ctr"/>
+          <a:lstStyle/>
+          <a:p>
+            <a:pPr indent="0" marL="0">
+              <a:buNone/>
+            </a:pPr>
+            <a:r>
+              <a:rPr lang="en-US" sz="3200" b="1" dirty="0">
+                <a:solidFill>
+                  <a:srgbClr val="0F172A"/>
+                </a:solidFill>
+                <a:latin typeface="Cambria" pitchFamily="34" charset="0"/>
+                <a:ea typeface="Cambria" pitchFamily="34" charset="-122"/>
+                <a:cs typeface="Cambria" pitchFamily="34" charset="-120"/>
+              </a:rPr>
+              <a:t>The fix isn't 'remove a tool'. Break the graph.</a:t>
+            </a:r>
+            <a:endParaRPr lang="en-US" sz="3200" dirty="0"/>
+          </a:p>
+        </p:txBody>
+      </p:sp>
+      <p:sp>
+        <p:nvSpPr>
+          <p:cNvPr id="3" name="Shape 1"/>
+          <p:cNvSpPr/>
+          <p:nvPr/>
+        </p:nvSpPr>
+        <p:spPr>
+          <a:xfrm>
+            <a:off x="640080" y="1508760"/>
+            <a:ext cx="10908792" cy="1024128"/>
+          </a:xfrm>
+          <a:prstGeom prst="roundRect">
+            <a:avLst>
+              <a:gd name="adj" fmla="val 8929"/>
+            </a:avLst>
+          </a:prstGeom>
+          <a:solidFill>
+            <a:srgbClr val="FFFFFF"/>
+          </a:solidFill>
+          <a:ln w="12700">
+            <a:solidFill>
+              <a:srgbClr val="E2E8F0"/>
+            </a:solidFill>
+            <a:prstDash val="solid"/>
+          </a:ln>
+        </p:spPr>
+      </p:sp>
+      <p:sp>
+        <p:nvSpPr>
+          <p:cNvPr id="4" name="Shape 2"/>
+          <p:cNvSpPr/>
+          <p:nvPr/>
+        </p:nvSpPr>
+        <p:spPr>
+          <a:xfrm>
+            <a:off x="914400" y="1792224"/>
+            <a:ext cx="457200" cy="457200"/>
+          </a:xfrm>
+          <a:prstGeom prst="ellipse">
+            <a:avLst/>
+          </a:prstGeom>
+          <a:solidFill>
+            <a:srgbClr val="059669"/>
+          </a:solidFill>
+          <a:ln/>
+        </p:spPr>
+      </p:sp>
+      <p:sp>
+        <p:nvSpPr>
+          <p:cNvPr id="5" name="Text 3"/>
+          <p:cNvSpPr/>
+          <p:nvPr/>
+        </p:nvSpPr>
+        <p:spPr>
+          <a:xfrm>
+            <a:off x="914400" y="1792224"/>
+            <a:ext cx="457200" cy="457200"/>
+          </a:xfrm>
+          <a:prstGeom prst="rect">
+            <a:avLst/>
+          </a:prstGeom>
+          <a:noFill/>
+          <a:ln/>
+        </p:spPr>
+        <p:txBody>
+          <a:bodyPr wrap="square" rtlCol="0" anchor="ctr"/>
+          <a:lstStyle/>
+          <a:p>
+            <a:pPr algn="ctr" indent="0" marL="0">
+              <a:buNone/>
+            </a:pPr>
+            <a:r>
+              <a:rPr lang="en-US" sz="1800" b="1" dirty="0">
+                <a:solidFill>
+                  <a:srgbClr val="FFFFFF"/>
+                </a:solidFill>
+              </a:rPr>
+              <a:t>✓</a:t>
+            </a:r>
+            <a:endParaRPr lang="en-US" sz="1800" dirty="0"/>
+          </a:p>
+        </p:txBody>
+      </p:sp>
+      <p:sp>
+        <p:nvSpPr>
+          <p:cNvPr id="6" name="Text 4"/>
+          <p:cNvSpPr/>
+          <p:nvPr/>
+        </p:nvSpPr>
+        <p:spPr>
+          <a:xfrm>
+            <a:off x="1600200" y="1508760"/>
+            <a:ext cx="4023360" cy="1024128"/>
+          </a:xfrm>
+          <a:prstGeom prst="rect">
+            <a:avLst/>
+          </a:prstGeom>
+          <a:noFill/>
+          <a:ln/>
+        </p:spPr>
+        <p:txBody>
+          <a:bodyPr wrap="square" rtlCol="0" anchor="ctr"/>
+          <a:lstStyle/>
+          <a:p>
+            <a:pPr indent="0" marL="0">
+              <a:buNone/>
+            </a:pPr>
+            <a:r>
+              <a:rPr lang="en-US" sz="1600" b="1" dirty="0">
+                <a:solidFill>
+                  <a:srgbClr val="0F172A"/>
+                </a:solidFill>
+                <a:latin typeface="Cambria" pitchFamily="34" charset="0"/>
+                <a:ea typeface="Cambria" pitchFamily="34" charset="-122"/>
+                <a:cs typeface="Cambria" pitchFamily="34" charset="-120"/>
+              </a:rPr>
+              <a:t>No instructions from data  ·  LLM01</a:t>
+            </a:r>
+            <a:endParaRPr lang="en-US" sz="1600" dirty="0"/>
+          </a:p>
+        </p:txBody>
+      </p:sp>
+      <p:sp>
+        <p:nvSpPr>
+          <p:cNvPr id="7" name="Text 5"/>
+          <p:cNvSpPr/>
+          <p:nvPr/>
+        </p:nvSpPr>
+        <p:spPr>
+          <a:xfrm>
+            <a:off x="5669280" y="1508760"/>
+            <a:ext cx="5669280" cy="1024128"/>
+          </a:xfrm>
+          <a:prstGeom prst="rect">
+            <a:avLst/>
+          </a:prstGeom>
+          <a:noFill/>
+          <a:ln/>
+        </p:spPr>
+        <p:txBody>
+          <a:bodyPr wrap="square" rtlCol="0" anchor="ctr"/>
+          <a:lstStyle/>
+          <a:p>
+            <a:pPr indent="0" marL="0">
+              <a:lnSpc>
+                <a:spcPct val="105000"/>
+              </a:lnSpc>
+              <a:buNone/>
+            </a:pPr>
+            <a:r>
+              <a:rPr lang="en-US" sz="1400" dirty="0">
+                <a:solidFill>
+                  <a:srgbClr val="334155"/>
+                </a:solidFill>
+                <a:latin typeface="Arial" pitchFamily="34" charset="0"/>
+                <a:ea typeface="Arial" pitchFamily="34" charset="-122"/>
+                <a:cs typeface="Arial" pitchFamily="34" charset="-120"/>
+              </a:rPr>
+              <a:t>Content from fetch_reference is data, never commands — the injected step never runs.</a:t>
+            </a:r>
+            <a:endParaRPr lang="en-US" sz="1400" dirty="0"/>
+          </a:p>
+        </p:txBody>
+      </p:sp>
+      <p:sp>
+        <p:nvSpPr>
+          <p:cNvPr id="8" name="Shape 6"/>
+          <p:cNvSpPr/>
+          <p:nvPr/>
+        </p:nvSpPr>
+        <p:spPr>
+          <a:xfrm>
+            <a:off x="640080" y="2624328"/>
+            <a:ext cx="10908792" cy="1024128"/>
+          </a:xfrm>
+          <a:prstGeom prst="roundRect">
+            <a:avLst>
+              <a:gd name="adj" fmla="val 8929"/>
+            </a:avLst>
+          </a:prstGeom>
+          <a:solidFill>
+            <a:srgbClr val="FFFFFF"/>
+          </a:solidFill>
+          <a:ln w="12700">
+            <a:solidFill>
+              <a:srgbClr val="E2E8F0"/>
+            </a:solidFill>
+            <a:prstDash val="solid"/>
+          </a:ln>
+        </p:spPr>
+      </p:sp>
+      <p:sp>
+        <p:nvSpPr>
+          <p:cNvPr id="9" name="Shape 7"/>
+          <p:cNvSpPr/>
+          <p:nvPr/>
+        </p:nvSpPr>
+        <p:spPr>
+          <a:xfrm>
+            <a:off x="914400" y="2907792"/>
+            <a:ext cx="457200" cy="457200"/>
+          </a:xfrm>
+          <a:prstGeom prst="ellipse">
+            <a:avLst/>
+          </a:prstGeom>
+          <a:solidFill>
+            <a:srgbClr val="059669"/>
+          </a:solidFill>
+          <a:ln/>
+        </p:spPr>
+      </p:sp>
+      <p:sp>
+        <p:nvSpPr>
+          <p:cNvPr id="10" name="Text 8"/>
+          <p:cNvSpPr/>
+          <p:nvPr/>
+        </p:nvSpPr>
+        <p:spPr>
+          <a:xfrm>
+            <a:off x="914400" y="2907792"/>
+            <a:ext cx="457200" cy="457200"/>
+          </a:xfrm>
+          <a:prstGeom prst="rect">
+            <a:avLst/>
+          </a:prstGeom>
+          <a:noFill/>
+          <a:ln/>
+        </p:spPr>
+        <p:txBody>
+          <a:bodyPr wrap="square" rtlCol="0" anchor="ctr"/>
+          <a:lstStyle/>
+          <a:p>
+            <a:pPr algn="ctr" indent="0" marL="0">
+              <a:buNone/>
+            </a:pPr>
+            <a:r>
+              <a:rPr lang="en-US" sz="1800" b="1" dirty="0">
+                <a:solidFill>
+                  <a:srgbClr val="FFFFFF"/>
+                </a:solidFill>
+              </a:rPr>
+              <a:t>✓</a:t>
+            </a:r>
+            <a:endParaRPr lang="en-US" sz="1800" dirty="0"/>
+          </a:p>
+        </p:txBody>
+      </p:sp>
+      <p:sp>
+        <p:nvSpPr>
+          <p:cNvPr id="11" name="Text 9"/>
+          <p:cNvSpPr/>
+          <p:nvPr/>
+        </p:nvSpPr>
+        <p:spPr>
+          <a:xfrm>
+            <a:off x="1600200" y="2624328"/>
+            <a:ext cx="4023360" cy="1024128"/>
+          </a:xfrm>
+          <a:prstGeom prst="rect">
+            <a:avLst/>
+          </a:prstGeom>
+          <a:noFill/>
+          <a:ln/>
+        </p:spPr>
+        <p:txBody>
+          <a:bodyPr wrap="square" rtlCol="0" anchor="ctr"/>
+          <a:lstStyle/>
+          <a:p>
+            <a:pPr indent="0" marL="0">
+              <a:buNone/>
+            </a:pPr>
+            <a:r>
+              <a:rPr lang="en-US" sz="1600" b="1" dirty="0">
+                <a:solidFill>
+                  <a:srgbClr val="0F172A"/>
+                </a:solidFill>
+                <a:latin typeface="Cambria" pitchFamily="34" charset="0"/>
+                <a:ea typeface="Cambria" pitchFamily="34" charset="-122"/>
+                <a:cs typeface="Cambria" pitchFamily="34" charset="-120"/>
+              </a:rPr>
+              <a:t>Recipient binding  ·  LLM06</a:t>
+            </a:r>
+            <a:endParaRPr lang="en-US" sz="1600" dirty="0"/>
+          </a:p>
+        </p:txBody>
+      </p:sp>
+      <p:sp>
+        <p:nvSpPr>
+          <p:cNvPr id="12" name="Text 10"/>
+          <p:cNvSpPr/>
+          <p:nvPr/>
+        </p:nvSpPr>
+        <p:spPr>
+          <a:xfrm>
+            <a:off x="5669280" y="2624328"/>
+            <a:ext cx="5669280" cy="1024128"/>
+          </a:xfrm>
+          <a:prstGeom prst="rect">
+            <a:avLst/>
+          </a:prstGeom>
+          <a:noFill/>
+          <a:ln/>
+        </p:spPr>
+        <p:txBody>
+          <a:bodyPr wrap="square" rtlCol="0" anchor="ctr"/>
+          <a:lstStyle/>
+          <a:p>
+            <a:pPr indent="0" marL="0">
+              <a:lnSpc>
+                <a:spcPct val="105000"/>
+              </a:lnSpc>
+              <a:buNone/>
+            </a:pPr>
+            <a:r>
+              <a:rPr lang="en-US" sz="1400" dirty="0">
+                <a:solidFill>
+                  <a:srgbClr val="334155"/>
+                </a:solidFill>
+                <a:latin typeface="Arial" pitchFamily="34" charset="0"/>
+                <a:ea typeface="Arial" pitchFamily="34" charset="-122"/>
+                <a:cs typeface="Arial" pitchFamily="34" charset="-120"/>
+              </a:rPr>
+              <a:t>send_email_report only reaches the authenticated requester — not a model-chosen address, even on an allowlisted domain.</a:t>
+            </a:r>
+            <a:endParaRPr lang="en-US" sz="1400" dirty="0"/>
+          </a:p>
+        </p:txBody>
+      </p:sp>
+      <p:sp>
+        <p:nvSpPr>
+          <p:cNvPr id="13" name="Shape 11"/>
+          <p:cNvSpPr/>
+          <p:nvPr/>
+        </p:nvSpPr>
+        <p:spPr>
+          <a:xfrm>
+            <a:off x="640080" y="3739896"/>
+            <a:ext cx="10908792" cy="1024128"/>
+          </a:xfrm>
+          <a:prstGeom prst="roundRect">
+            <a:avLst>
+              <a:gd name="adj" fmla="val 8929"/>
+            </a:avLst>
+          </a:prstGeom>
+          <a:solidFill>
+            <a:srgbClr val="FFFFFF"/>
+          </a:solidFill>
+          <a:ln w="12700">
+            <a:solidFill>
+              <a:srgbClr val="E2E8F0"/>
+            </a:solidFill>
+            <a:prstDash val="solid"/>
+          </a:ln>
+        </p:spPr>
+      </p:sp>
+      <p:sp>
+        <p:nvSpPr>
+          <p:cNvPr id="14" name="Shape 12"/>
+          <p:cNvSpPr/>
+          <p:nvPr/>
+        </p:nvSpPr>
+        <p:spPr>
+          <a:xfrm>
+            <a:off x="914400" y="4023360"/>
+            <a:ext cx="457200" cy="457200"/>
+          </a:xfrm>
+          <a:prstGeom prst="ellipse">
+            <a:avLst/>
+          </a:prstGeom>
+          <a:solidFill>
+            <a:srgbClr val="059669"/>
+          </a:solidFill>
+          <a:ln/>
+        </p:spPr>
+      </p:sp>
+      <p:sp>
+        <p:nvSpPr>
+          <p:cNvPr id="15" name="Text 13"/>
+          <p:cNvSpPr/>
+          <p:nvPr/>
+        </p:nvSpPr>
+        <p:spPr>
+          <a:xfrm>
+            <a:off x="914400" y="4023360"/>
+            <a:ext cx="457200" cy="457200"/>
+          </a:xfrm>
+          <a:prstGeom prst="rect">
+            <a:avLst/>
+          </a:prstGeom>
+          <a:noFill/>
+          <a:ln/>
+        </p:spPr>
+        <p:txBody>
+          <a:bodyPr wrap="square" rtlCol="0" anchor="ctr"/>
+          <a:lstStyle/>
+          <a:p>
+            <a:pPr algn="ctr" indent="0" marL="0">
+              <a:buNone/>
+            </a:pPr>
+            <a:r>
+              <a:rPr lang="en-US" sz="1800" b="1" dirty="0">
+                <a:solidFill>
+                  <a:srgbClr val="FFFFFF"/>
+                </a:solidFill>
+              </a:rPr>
+              <a:t>✓</a:t>
+            </a:r>
+            <a:endParaRPr lang="en-US" sz="1800" dirty="0"/>
+          </a:p>
+        </p:txBody>
+      </p:sp>
+      <p:sp>
+        <p:nvSpPr>
+          <p:cNvPr id="16" name="Text 14"/>
+          <p:cNvSpPr/>
+          <p:nvPr/>
+        </p:nvSpPr>
+        <p:spPr>
+          <a:xfrm>
+            <a:off x="1600200" y="3739896"/>
+            <a:ext cx="4023360" cy="1024128"/>
+          </a:xfrm>
+          <a:prstGeom prst="rect">
+            <a:avLst/>
+          </a:prstGeom>
+          <a:noFill/>
+          <a:ln/>
+        </p:spPr>
+        <p:txBody>
+          <a:bodyPr wrap="square" rtlCol="0" anchor="ctr"/>
+          <a:lstStyle/>
+          <a:p>
+            <a:pPr indent="0" marL="0">
+              <a:buNone/>
+            </a:pPr>
+            <a:r>
+              <a:rPr lang="en-US" sz="1600" b="1" dirty="0">
+                <a:solidFill>
+                  <a:srgbClr val="0F172A"/>
+                </a:solidFill>
+                <a:latin typeface="Cambria" pitchFamily="34" charset="0"/>
+                <a:ea typeface="Cambria" pitchFamily="34" charset="-122"/>
+                <a:cs typeface="Cambria" pitchFamily="34" charset="-120"/>
+              </a:rPr>
+              <a:t>Trifecta gate  ·  taint tracking</a:t>
+            </a:r>
+            <a:endParaRPr lang="en-US" sz="1600" dirty="0"/>
+          </a:p>
+        </p:txBody>
+      </p:sp>
+      <p:sp>
+        <p:nvSpPr>
+          <p:cNvPr id="17" name="Text 15"/>
+          <p:cNvSpPr/>
+          <p:nvPr/>
+        </p:nvSpPr>
+        <p:spPr>
+          <a:xfrm>
+            <a:off x="5669280" y="3739896"/>
+            <a:ext cx="5669280" cy="1024128"/>
+          </a:xfrm>
+          <a:prstGeom prst="rect">
+            <a:avLst/>
+          </a:prstGeom>
+          <a:noFill/>
+          <a:ln/>
+        </p:spPr>
+        <p:txBody>
+          <a:bodyPr wrap="square" rtlCol="0" anchor="ctr"/>
+          <a:lstStyle/>
+          <a:p>
+            <a:pPr indent="0" marL="0">
+              <a:lnSpc>
+                <a:spcPct val="105000"/>
+              </a:lnSpc>
+              <a:buNone/>
+            </a:pPr>
+            <a:r>
+              <a:rPr lang="en-US" sz="1400" dirty="0">
+                <a:solidFill>
+                  <a:srgbClr val="334155"/>
+                </a:solidFill>
+                <a:latin typeface="Arial" pitchFamily="34" charset="0"/>
+                <a:ea typeface="Arial" pitchFamily="34" charset="-122"/>
+                <a:cs typeface="Arial" pitchFamily="34" charset="-120"/>
+              </a:rPr>
+              <a:t>A run holding private + untrusted data can't reach an external sink unattended. Aggregates aren't private — the real task still works.</a:t>
+            </a:r>
+            <a:endParaRPr lang="en-US" sz="1400" dirty="0"/>
+          </a:p>
+        </p:txBody>
+      </p:sp>
+      <p:sp>
+        <p:nvSpPr>
+          <p:cNvPr id="18" name="Shape 16"/>
+          <p:cNvSpPr/>
+          <p:nvPr/>
+        </p:nvSpPr>
+        <p:spPr>
+          <a:xfrm>
+            <a:off x="640080" y="4855464"/>
+            <a:ext cx="10908792" cy="1024128"/>
+          </a:xfrm>
+          <a:prstGeom prst="roundRect">
+            <a:avLst>
+              <a:gd name="adj" fmla="val 8929"/>
+            </a:avLst>
+          </a:prstGeom>
+          <a:solidFill>
+            <a:srgbClr val="FFFFFF"/>
+          </a:solidFill>
+          <a:ln w="12700">
+            <a:solidFill>
+              <a:srgbClr val="E2E8F0"/>
+            </a:solidFill>
+            <a:prstDash val="solid"/>
+          </a:ln>
+        </p:spPr>
+      </p:sp>
+      <p:sp>
+        <p:nvSpPr>
+          <p:cNvPr id="19" name="Shape 17"/>
+          <p:cNvSpPr/>
+          <p:nvPr/>
+        </p:nvSpPr>
+        <p:spPr>
+          <a:xfrm>
+            <a:off x="914400" y="5138928"/>
+            <a:ext cx="457200" cy="457200"/>
+          </a:xfrm>
+          <a:prstGeom prst="ellipse">
+            <a:avLst/>
+          </a:prstGeom>
+          <a:solidFill>
+            <a:srgbClr val="059669"/>
+          </a:solidFill>
+          <a:ln/>
+        </p:spPr>
+      </p:sp>
+      <p:sp>
+        <p:nvSpPr>
+          <p:cNvPr id="20" name="Text 18"/>
+          <p:cNvSpPr/>
+          <p:nvPr/>
+        </p:nvSpPr>
+        <p:spPr>
+          <a:xfrm>
+            <a:off x="914400" y="5138928"/>
+            <a:ext cx="457200" cy="457200"/>
+          </a:xfrm>
+          <a:prstGeom prst="rect">
+            <a:avLst/>
+          </a:prstGeom>
+          <a:noFill/>
+          <a:ln/>
+        </p:spPr>
+        <p:txBody>
+          <a:bodyPr wrap="square" rtlCol="0" anchor="ctr"/>
+          <a:lstStyle/>
+          <a:p>
+            <a:pPr algn="ctr" indent="0" marL="0">
+              <a:buNone/>
+            </a:pPr>
+            <a:r>
+              <a:rPr lang="en-US" sz="1800" b="1" dirty="0">
+                <a:solidFill>
+                  <a:srgbClr val="FFFFFF"/>
+                </a:solidFill>
+              </a:rPr>
+              <a:t>✓</a:t>
+            </a:r>
+            <a:endParaRPr lang="en-US" sz="1800" dirty="0"/>
+          </a:p>
+        </p:txBody>
+      </p:sp>
+      <p:sp>
+        <p:nvSpPr>
+          <p:cNvPr id="21" name="Text 19"/>
+          <p:cNvSpPr/>
+          <p:nvPr/>
+        </p:nvSpPr>
+        <p:spPr>
+          <a:xfrm>
+            <a:off x="1600200" y="4855464"/>
+            <a:ext cx="4023360" cy="1024128"/>
+          </a:xfrm>
+          <a:prstGeom prst="rect">
+            <a:avLst/>
+          </a:prstGeom>
+          <a:noFill/>
+          <a:ln/>
+        </p:spPr>
+        <p:txBody>
+          <a:bodyPr wrap="square" rtlCol="0" anchor="ctr"/>
+          <a:lstStyle/>
+          <a:p>
+            <a:pPr indent="0" marL="0">
+              <a:buNone/>
+            </a:pPr>
+            <a:r>
+              <a:rPr lang="en-US" sz="1600" b="1" dirty="0">
+                <a:solidFill>
+                  <a:srgbClr val="0F172A"/>
+                </a:solidFill>
+                <a:latin typeface="Cambria" pitchFamily="34" charset="0"/>
+                <a:ea typeface="Cambria" pitchFamily="34" charset="-122"/>
+                <a:cs typeface="Cambria" pitchFamily="34" charset="-120"/>
+              </a:rPr>
+              <a:t>Re-scan in CI  ·  ziran ci</a:t>
+            </a:r>
+            <a:endParaRPr lang="en-US" sz="1600" dirty="0"/>
+          </a:p>
+        </p:txBody>
+      </p:sp>
+      <p:sp>
+        <p:nvSpPr>
+          <p:cNvPr id="22" name="Text 20"/>
+          <p:cNvSpPr/>
+          <p:nvPr/>
+        </p:nvSpPr>
+        <p:spPr>
+          <a:xfrm>
+            <a:off x="5669280" y="4855464"/>
+            <a:ext cx="5669280" cy="1024128"/>
+          </a:xfrm>
+          <a:prstGeom prst="rect">
+            <a:avLst/>
+          </a:prstGeom>
+          <a:noFill/>
+          <a:ln/>
+        </p:spPr>
+        <p:txBody>
+          <a:bodyPr wrap="square" rtlCol="0" anchor="ctr"/>
+          <a:lstStyle/>
+          <a:p>
+            <a:pPr indent="0" marL="0">
+              <a:lnSpc>
+                <a:spcPct val="105000"/>
+              </a:lnSpc>
+              <a:buNone/>
+            </a:pPr>
+            <a:r>
+              <a:rPr lang="en-US" sz="1400" dirty="0">
+                <a:solidFill>
+                  <a:srgbClr val="334155"/>
+                </a:solidFill>
+                <a:latin typeface="Arial" pitchFamily="34" charset="0"/>
+                <a:ea typeface="Arial" pitchFamily="34" charset="-122"/>
+                <a:cs typeface="Arial" pitchFamily="34" charset="-120"/>
+              </a:rPr>
+              <a:t>Fail the build when a newly-added tool completes a trifecta. Composition as a reviewable artifact.</a:t>
+            </a:r>
+            <a:endParaRPr lang="en-US" sz="1400" dirty="0"/>
+          </a:p>
+        </p:txBody>
+      </p:sp>
+    </p:spTree>
+  </p:cSld>
+  <p:clrMapOvr>
+    <a:masterClrMapping/>
+  </p:clrMapOvr>
+</p:sld>
+</file>
+
+<file path=ppt/slides/slide25.xml><?xml version="1.0" encoding="utf-8"?>
+<p:sld xmlns:a="http://schemas.openxmlformats.org/drawingml/2006/main" xmlns:r="http://schemas.openxmlformats.org/officeDocument/2006/relationships" xmlns:p="http://schemas.openxmlformats.org/presentationml/2006/main">
+  <p:cSld name="Slide 25">
     <p:bg>
       <p:bgPr>
         <a:solidFill>
@@ -8726,9 +8964,9 @@
 </p:sld>
 </file>
 
-<file path=ppt/slides/slide25.xml><?xml version="1.0" encoding="utf-8"?>
+<file path=ppt/slides/slide26.xml><?xml version="1.0" encoding="utf-8"?>
 <p:sld xmlns:a="http://schemas.openxmlformats.org/drawingml/2006/main" xmlns:r="http://schemas.openxmlformats.org/officeDocument/2006/relationships" xmlns:p="http://schemas.openxmlformats.org/presentationml/2006/main">
-  <p:cSld name="Slide 25">
+  <p:cSld name="Slide 26">
     <p:bg>
       <p:bgPr>
         <a:solidFill>
@@ -8888,7 +9126,7 @@
                 <a:ea typeface="Arial" pitchFamily="34" charset="-122"/>
                 <a:cs typeface="Arial" pitchFamily="34" charset="-120"/>
               </a:rPr>
-              <a:t>The demo agent — defensible architecture, one composition finding.</a:t>
+              <a:t>The demo agent — defensible architecture, one composition finding. Run scripts/exploit_demo.py yourself.</a:t>
             </a:r>
             <a:endParaRPr lang="en-US" sz="2000" dirty="0"/>
           </a:p>
@@ -10161,8 +10399,8 @@
         </p:blipFill>
         <p:spPr>
           <a:xfrm>
-            <a:off x="2407379" y="1417320"/>
-            <a:ext cx="7374194" cy="4572000"/>
+            <a:off x="2630840" y="1417320"/>
+            <a:ext cx="6927273" cy="4572000"/>
           </a:xfrm>
           <a:prstGeom prst="rect">
             <a:avLst/>

</xml_diff>

<commit_message>
fix(talk): redraw C4 diagram top-down with straight orthogonal connectors
Agent loop now sits above the four tools; person -> agent -> comb-bus -> tools
-> external systems are all straight/orthogonal (no crossing fan-out), with a
single clean elbow to the external Bedrock model. Easier to read.
</commit_message>
<xml_diff>
--- a/talk/quanta-talk.pptx
+++ b/talk/quanta-talk.pptx
@@ -3342,8 +3342,8 @@
         </p:blipFill>
         <p:spPr>
           <a:xfrm>
-            <a:off x="2531879" y="1417320"/>
-            <a:ext cx="7125195" cy="4572000"/>
+            <a:off x="2722626" y="1417320"/>
+            <a:ext cx="6743700" cy="4572000"/>
           </a:xfrm>
           <a:prstGeom prst="rect">
             <a:avLst/>

</xml_diff>

<commit_message>
refactor(demo): single Python driver, drop the shell scripts
The demo was a confusing mix of shell + python. Consolidate to one Python entry
point, scripts/demo.py, with subcommands ask / scan / exploit / deploy (default
runs all three). It auto-installs ZIRAN before scanning (per request) and falls
back to the bundled report with --no-install. Remove demo_live.sh, invoke_demo.sh,
deploy.sh and run_local.py; update README, docs/deployment.md, the deck notes and
SPEAKER_NOTES to the new commands.
</commit_message>
<xml_diff>
--- a/talk/quanta-talk.pptx
+++ b/talk/quanta-talk.pptx
@@ -792,12 +792,10 @@
             <a:r>
               <a:rPr lang="en-US" dirty="0"/>
               <a:t>*** LIVE DEMO — Part 1: it's a real agent ***
-Run:  ./scripts/demo_live.sh            (auto cloud/local; PAUSE=1 to step)
-  or, manually, three real questions:
-  agentcore invoke '{"prompt": "What was our revenue by country? Top 5."}'
-  agentcore invoke '{"prompt": "How many orders per country?"}'
-  agentcore invoke '{"prompt": "Who are our top customers by orders?"}'
-Offline fallback (no AWS):  QUANTA_STUB=1 python scripts/run_local.py "revenue by country, top 5"
+Run:  python scripts/demo.py --pause          (whole demo: ask -&gt; scan -&gt; exploit)
+  or just this part:  python scripts/demo.py ask              (offline stub)
+  on the deployed agent:  python scripts/demo.py ask --cloud  (real AgentCore)
+It asks three real questions (revenue by country top 5 / orders per country / top customers).
 Real numbers from UCI Online Retail II. Then say: 'Real agent, real data, genuinely useful. Now — is it safe?'</a:t>
             </a:r>
             <a:endParaRPr lang="en-US" dirty="0"/>
@@ -1327,8 +1325,8 @@
             <a:r>
               <a:rPr lang="en-US" dirty="0"/>
               <a:t>*** LIVE DEMO — find the composition ***
-Run:  QUANTA_STUB=1 python scripts/scan_quanta.py --out reports   (offline, in-process)
-Then: open reports/*_report.html   — pan the graph, click the red node.
+Run:  python scripts/demo.py scan   (installs ZIRAN if needed, then opens the report)
+It scans in-process and opens reports/*_report.html — pan the graph, click the red node.
 (This slide embeds the real interactive graph as a looping GIF — it plays in Presenter/slideshow, and is the fallback if the live open stalls.)
 One critical finding: search_database → send_email_report, data_exfiltration. Say: 'I didn't tell ZIRAN this was dangerous — that verdict is from its built-in patterns. I gave it a graph; it gave me the exit. But a finding on a slide is easy to wave away — so let me show you the exit actually being used.'</a:t>
             </a:r>
@@ -1595,7 +1593,7 @@
             <a:r>
               <a:rPr lang="en-US" dirty="0"/>
               <a:t>*** LIVE DEMO — the breach ***
-Run:  python scripts/exploit_demo.py            (offline, deterministic; --vulnerable-only for just this)
+Run:  python scripts/demo.py exploit            (offline, deterministic — prints both runs)
 Walk the table: a benign request → fetch_reference returns an allowlisted page whose CONTENT carries a hidden instruction (indirect prompt injection, LLM01). The agent obeys → search_database reads 900 customer-level rows → watch the taint go red: PRIVATE+UNTRUSTED, the lethal trifecta in one run → send_email_report ships 16,741 bytes of PII to ops-archive@reports.acme-analytics.example. That mailbox is on the ALLOWLISTED domain — the domain check PASSED. Model-chosen recipient = excessive agency / confused deputy (LLM06). Say slowly: 'No control was bypassed. The data left through fully authorised actions.'</a:t>
             </a:r>
             <a:endParaRPr lang="en-US" dirty="0"/>
@@ -1861,7 +1859,7 @@
             <a:r>
               <a:rPr lang="en-US" dirty="0"/>
               <a:t>*** LIVE DEMO — the fix ***
-Same script printed both runs — scroll to the second (or: python scripts/exploit_demo.py --hardened-only).
+`python scripts/demo.py exploit` already printed both runs — scroll to the second.
 Same agent, same payload, opposite outcome: the injected instruction is REFUSED as data (LLM01); the model-chosen recipient is DENIED by recipient-binding (LLM06); the trifecta gate stops a private+untrusted run reaching an external sink. Crucially the analyst's legitimate summary STILL goes out. Say: 'The fix didn't break the product. We broke the path, not the agent.'</a:t>
             </a:r>
             <a:endParaRPr lang="en-US" dirty="0"/>
@@ -9126,7 +9124,7 @@
                 <a:ea typeface="Arial" pitchFamily="34" charset="-122"/>
                 <a:cs typeface="Arial" pitchFamily="34" charset="-120"/>
               </a:rPr>
-              <a:t>The demo agent — defensible architecture, one composition finding. Run scripts/exploit_demo.py yourself.</a:t>
+              <a:t>The demo agent — defensible architecture, one composition finding. Run python scripts/demo.py yourself.</a:t>
             </a:r>
             <a:endParaRPr lang="en-US" sz="2000" dirty="0"/>
           </a:p>

</xml_diff>

<commit_message>
talk: mirror deck changes (Ziran casing, tone-down, better GIF, multi-agent)
- 'ZIRAN' -> 'Ziran' in the deck + speaker notes.
- reduce the sales tone: cut the stats/credibility slide, rename
  'What Ziran does differently' -> 'What Ziran does', factual resources card.
- replace the zoom GIF with the highlight tour (full graph in frame, each
  attack path lights up red); update slide image dims.
- add the multi-agent section: distributed-trifecta diagram + system-level
  remediation, with the clearer kicker. 27 slides; speaker-notes arc updated.
- rewritten talk/record_graph_gif.py (highlightPath tour).
</commit_message>
<xml_diff>
--- a/talk/quanta-talk.pptx
+++ b/talk/quanta-talk.pptx
@@ -31,9 +31,10 @@
     <p:sldId id="279" r:id="rId25"/>
     <p:sldId id="280" r:id="rId26"/>
     <p:sldId id="281" r:id="rId27"/>
+    <p:sldId id="282" r:id="rId28"/>
   </p:sldIdLst>
   <p:notesMasterIdLst>
-    <p:notesMasterId r:id="rId28"/>
+    <p:notesMasterId r:id="rId29"/>
   </p:notesMasterIdLst>
   <p:sldSz cx="12191695" cy="6858000"/>
   <p:notesSz cx="6858000" cy="12191695"/>
@@ -1060,7 +1061,7 @@
           <a:p>
             <a:r>
               <a:rPr lang="en-US" dirty="0"/>
-              <a:t>ZIRAN builds the agent's capability graph and checks it against a library of known dangerous compositions — direct (A→B), indirect (A→…→B), and cycles. Say: 'It's not testing prompts here. It's reasoning about structure.'</a:t>
+              <a:t>Ziran builds the agent's capability graph and checks it against a library of known dangerous compositions — direct (A→B), indirect (A→…→B), and cycles. Say: 'It's not testing prompts here. It's reasoning about structure.'</a:t>
             </a:r>
             <a:endParaRPr lang="en-US" dirty="0"/>
           </a:p>
@@ -1325,10 +1326,10 @@
             <a:r>
               <a:rPr lang="en-US" dirty="0"/>
               <a:t>*** LIVE DEMO — find the composition ***
-Run:  python scripts/demo.py scan   (installs ZIRAN if needed, then opens the report)
+Run:  python scripts/demo.py scan   (installs Ziran if needed, then opens the report)
 It scans in-process and opens reports/*_report.html — pan the graph, click the red node.
 (This slide embeds the real interactive graph as a looping GIF — it plays in Presenter/slideshow, and is the fallback if the live open stalls.)
-One critical finding: search_database → send_email_report, data_exfiltration. Say: 'I didn't tell ZIRAN this was dangerous — that verdict is from its built-in patterns. I gave it a graph; it gave me the exit. But a finding on a slide is easy to wave away — so let me show you the exit actually being used.'</a:t>
+One critical finding: search_database → send_email_report, data_exfiltration. Say: 'I didn't tell Ziran this was dangerous — that verdict is from its built-in patterns. I gave it a graph; it gave me the exit. But a finding on a slide is easy to wave away — so let me show you the exit actually being used.'</a:t>
             </a:r>
             <a:endParaRPr lang="en-US" dirty="0"/>
           </a:p>
@@ -1416,7 +1417,7 @@
           <a:p>
             <a:r>
               <a:rPr lang="en-US" dirty="0"/>
-              <a:t>Divider. 'ZIRAN found the path statically, before anyone attacked. Now let's walk it like an attacker — then close it.'</a:t>
+              <a:t>Divider. 'Ziran found the path statically, before anyone attacked. Now let's walk it like an attacker — then close it.'</a:t>
             </a:r>
             <a:endParaRPr lang="en-US" dirty="0"/>
           </a:p>
@@ -1682,7 +1683,7 @@
           <a:p>
             <a:r>
               <a:rPr lang="en-US" dirty="0"/>
-              <a:t>Name what we just saw. One innocuous agent, three stacked classes: the composition (structural — ZIRAN finds it pre-attack), indirect prompt injection (LLM01 — the trigger), excessive agency / confused deputy (LLM06 — the missing control). None is a bug in a single tool.</a:t>
+              <a:t>Name what we just saw. One innocuous agent, three stacked classes: the composition (structural — Ziran finds it pre-attack), indirect prompt injection (LLM01 — the trigger), excessive agency / confused deputy (LLM06 — the missing control). None is a bug in a single tool.</a:t>
             </a:r>
             <a:endParaRPr lang="en-US" dirty="0"/>
           </a:p>
@@ -1770,7 +1771,9 @@
           <a:p>
             <a:r>
               <a:rPr lang="en-US" dirty="0"/>
-              <a:t>Quick credibility beat: 639 vectors, 11 categories, 100% OWASP LLM Top-10 — but the differentiator is composition reasoning. Don't dwell; 30 seconds. (Cut this slide first if running long.)</a:t>
+              <a:t>*** LIVE DEMO — the fix ***
+`python scripts/demo.py exploit` already printed both runs — scroll to the second.
+Same agent, same payload, opposite outcome: the injected instruction is REFUSED as data (LLM01); the model-chosen recipient is DENIED by recipient-binding (LLM06); the trifecta gate stops a private+untrusted run reaching an external sink. Crucially the analyst's legitimate summary STILL goes out. Say: 'The fix didn't break the product. We broke the path, not the agent.'</a:t>
             </a:r>
             <a:endParaRPr lang="en-US" dirty="0"/>
           </a:p>
@@ -1858,9 +1861,7 @@
           <a:p>
             <a:r>
               <a:rPr lang="en-US" dirty="0"/>
-              <a:t>*** LIVE DEMO — the fix ***
-`python scripts/demo.py exploit` already printed both runs — scroll to the second.
-Same agent, same payload, opposite outcome: the injected instruction is REFUSED as data (LLM01); the model-chosen recipient is DENIED by recipient-binding (LLM06); the trifecta gate stops a private+untrusted run reaching an external sink. Crucially the analyst's legitimate summary STILL goes out. Say: 'The fix didn't break the product. We broke the path, not the agent.'</a:t>
+              <a:t>The fix is NOT 'remove a tool' — each is justified. Break the graph: no-instructions-from-data (LLM01), recipient binding (LLM06), trifecta gate via taint (the composition), and re-scan in CI (ziran ci fails the build when a new tool completes a trifecta). Three are runtime guardrails; the last is the design-time one that matches the thesis. It's all real, tested code in quanta/security/.</a:t>
             </a:r>
             <a:endParaRPr lang="en-US" dirty="0"/>
           </a:p>
@@ -1948,7 +1949,7 @@
           <a:p>
             <a:r>
               <a:rPr lang="en-US" dirty="0"/>
-              <a:t>The fix is NOT 'remove a tool' — each is justified. Break the graph: no-instructions-from-data (LLM01), recipient binding (LLM06), trifecta gate via taint (the composition), and re-scan in CI (ziran ci fails the build when a new tool completes a trifecta). Three are runtime guardrails; the last is the design-time one that matches the thesis. It's all real, tested code in quanta/security/.</a:t>
+              <a:t>The natural question: doesn't splitting into specialised, least-privileged agents fix this? It's necessary but NOT sufficient. Walk the red path: a poisoned doc hits the Research agent (untrusted); the injected instruction rides the shared memory / message bus to the Analytics agent (reads PII), which hands off to the Comms agent (sends out). No single agent holds all three legs — the SYSTEM does. The graph didn't shrink; it got bigger and harder to see: nodes are now (agent, tool) pairs; edges are agent-to-agent messages, delegation, and shared memory. Ziran scans multi-agent topologies (router/RAG, supervisor) too.</a:t>
             </a:r>
             <a:endParaRPr lang="en-US" dirty="0"/>
           </a:p>
@@ -2036,7 +2037,7 @@
           <a:p>
             <a:r>
               <a:rPr lang="en-US" dirty="0"/>
-              <a:t>Say: 'If you're building, reviewing, or signing off on agents: stop asking only whether each tool is safe. Ask what they're capable of together — and put that question in your pipeline, not in an attacker's hands.' Restate the thesis: the vulnerability lives in the graph, not in any node.</a:t>
+              <a:t>This is the remediation, lifted to the system level. Constrain the topology (allowlist agent-to-agent edges — not a mesh). Carry taint/provenance across the message bus and enforce at boundaries — the trifecta gate moves up to the orchestrator. Quarantine the untrusted-facing agent (dual-LLM: structured output only, never instructions to privileged agents). One human/deterministic gate at the closure point. Re-scan the whole system graph in CI. Land the kicker: no single tool was dangerous, and no single agent is either — the risk lives in how they connect.</a:t>
             </a:r>
             <a:endParaRPr lang="en-US" dirty="0"/>
           </a:p>
@@ -2124,7 +2125,7 @@
           <a:p>
             <a:r>
               <a:rPr lang="en-US" dirty="0"/>
-              <a:t>Links: github.com/taoq-ai/quanta (the demo agent — education only, intentionally composable; run scripts/exploit_demo.py), github.com/taoq-ai/ziran (the finder). Note Quanta is deliberately vulnerable by design; don't deploy it for real. Take Q&amp;A.</a:t>
+              <a:t>Say: 'If you're building, reviewing, or signing off on agents: stop asking only whether each tool is safe. Ask what they're capable of together — and put that question in your pipeline, not in an attacker's hands.' Restate the thesis: the vulnerability lives in the graph, not in any node.</a:t>
             </a:r>
             <a:endParaRPr lang="en-US" dirty="0"/>
           </a:p>
@@ -2148,6 +2149,94 @@
             <a:fld id="{F7021451-1387-4CA6-816F-3879F97B5CBC}" type="slidenum">
               <a:rPr lang="en-US"/>
               <a:t>26</a:t>
+            </a:fld>
+            <a:endParaRPr lang="en-US"/>
+          </a:p>
+        </p:txBody>
+      </p:sp>
+    </p:spTree>
+    <p:extLst>
+      <p:ext uri="{BB962C8B-B14F-4D97-AF65-F5344CB8AC3E}">
+        <p14:creationId xmlns:p14="http://schemas.microsoft.com/office/powerpoint/2010/main" val="1024086991"/>
+      </p:ext>
+    </p:extLst>
+  </p:cSld>
+  <p:clrMapOvr>
+    <a:masterClrMapping/>
+  </p:clrMapOvr>
+</p:notes>
+</file>
+
+<file path=ppt/notesSlides/notesSlide27.xml><?xml version="1.0" encoding="utf-8"?>
+<p:notes xmlns:a="http://schemas.openxmlformats.org/drawingml/2006/main" xmlns:r="http://schemas.openxmlformats.org/officeDocument/2006/relationships" xmlns:p="http://schemas.openxmlformats.org/presentationml/2006/main">
+  <p:cSld>
+    <p:spTree>
+      <p:nvGrpSpPr>
+        <p:cNvPr id="1" name=""/>
+        <p:cNvGrpSpPr/>
+        <p:nvPr/>
+      </p:nvGrpSpPr>
+      <p:grpSpPr>
+        <a:xfrm>
+          <a:off x="0" y="0"/>
+          <a:ext cx="0" cy="0"/>
+          <a:chOff x="0" y="0"/>
+          <a:chExt cx="0" cy="0"/>
+        </a:xfrm>
+      </p:grpSpPr>
+      <p:sp>
+        <p:nvSpPr>
+          <p:cNvPr id="2" name="Slide Image Placeholder 1"/>
+          <p:cNvSpPr>
+            <a:spLocks noGrp="1" noRot="1" noChangeAspect="1"/>
+          </p:cNvSpPr>
+          <p:nvPr>
+            <p:ph type="sldImg"/>
+          </p:nvPr>
+        </p:nvSpPr>
+        <p:spPr/>
+      </p:sp>
+      <p:sp>
+        <p:nvSpPr>
+          <p:cNvPr id="3" name="Notes Placeholder 2"/>
+          <p:cNvSpPr>
+            <a:spLocks noGrp="1"/>
+          </p:cNvSpPr>
+          <p:nvPr>
+            <p:ph type="body" idx="1"/>
+          </p:nvPr>
+        </p:nvSpPr>
+        <p:spPr/>
+        <p:txBody>
+          <a:bodyPr/>
+          <a:lstStyle/>
+          <a:p>
+            <a:r>
+              <a:rPr lang="en-US" dirty="0"/>
+              <a:t>Links: github.com/taoq-ai/quanta (the demo agent — education only, intentionally composable; run scripts/exploit_demo.py), github.com/taoq-ai/ziran (the finder). Note Quanta is deliberately vulnerable by design; don't deploy it for real. Take Q&amp;A.</a:t>
+            </a:r>
+            <a:endParaRPr lang="en-US" dirty="0"/>
+          </a:p>
+        </p:txBody>
+      </p:sp>
+      <p:sp>
+        <p:nvSpPr>
+          <p:cNvPr id="4" name="Slide Number Placeholder 3"/>
+          <p:cNvSpPr>
+            <a:spLocks noGrp="1"/>
+          </p:cNvSpPr>
+          <p:nvPr>
+            <p:ph type="sldNum" sz="quarter" idx="10"/>
+          </p:nvPr>
+        </p:nvSpPr>
+        <p:spPr/>
+        <p:txBody>
+          <a:bodyPr/>
+          <a:lstStyle/>
+          <a:p>
+            <a:fld id="{F7021451-1387-4CA6-816F-3879F97B5CBC}" type="slidenum">
+              <a:rPr lang="en-US"/>
+              <a:t>27</a:t>
             </a:fld>
             <a:endParaRPr lang="en-US"/>
           </a:p>
@@ -3247,7 +3336,7 @@
                 <a:ea typeface="Arial" pitchFamily="34" charset="-122"/>
                 <a:cs typeface="Arial" pitchFamily="34" charset="-120"/>
               </a:rPr>
-              <a:t>Live demo: a real Amazon Bedrock AgentCore agent, found with ZIRAN</a:t>
+              <a:t>Live demo: a real Amazon Bedrock AgentCore agent, found with Ziran</a:t>
             </a:r>
             <a:endParaRPr lang="en-US" sz="1600" dirty="0"/>
           </a:p>
@@ -5299,7 +5388,7 @@
                 <a:ea typeface="Cambria" pitchFamily="34" charset="-122"/>
                 <a:cs typeface="Cambria" pitchFamily="34" charset="-120"/>
               </a:rPr>
-              <a:t>What ZIRAN does differently</a:t>
+              <a:t>What Ziran does</a:t>
             </a:r>
             <a:endParaRPr lang="en-US" sz="3200" dirty="0"/>
           </a:p>
@@ -6092,8 +6181,8 @@
         </p:blipFill>
         <p:spPr>
           <a:xfrm>
-            <a:off x="3490172" y="1417320"/>
-            <a:ext cx="5208608" cy="4572000"/>
+            <a:off x="3489821" y="1417320"/>
+            <a:ext cx="5209309" cy="4572000"/>
           </a:xfrm>
           <a:prstGeom prst="rect">
             <a:avLst/>
@@ -6133,7 +6222,7 @@
                 <a:ea typeface="Arial" pitchFamily="34" charset="-122"/>
                 <a:cs typeface="Arial" pitchFamily="34" charset="-120"/>
               </a:rPr>
-              <a:t>The real ZIRAN interactive graph. One critical finding: search_database → send_email_report, data_exfiltration.</a:t>
+              <a:t>The real Ziran interactive graph. One critical finding: search_database → send_email_report, data_exfiltration.</a:t>
             </a:r>
             <a:endParaRPr lang="en-US" sz="1500" dirty="0"/>
           </a:p>
@@ -6302,7 +6391,7 @@
                 <a:ea typeface="Arial" pitchFamily="34" charset="-122"/>
                 <a:cs typeface="Arial" pitchFamily="34" charset="-120"/>
               </a:rPr>
-              <a:t>ZIRAN found the path. Now watch an attacker walk it — then watch us close it.</a:t>
+              <a:t>Ziran found the path. Now watch an attacker walk it — then watch us close it.</a:t>
             </a:r>
             <a:endParaRPr lang="en-US" sz="1800" dirty="0"/>
           </a:p>
@@ -7189,7 +7278,7 @@
                           <a:ea typeface="Arial" pitchFamily="34" charset="-122"/>
                           <a:cs typeface="Arial" pitchFamily="34" charset="-120"/>
                         </a:rPr>
-                        <a:t>ZIRAN — static, pre-attack</a:t>
+                        <a:t>Ziran — static, pre-attack</a:t>
                       </a:r>
                       <a:endParaRPr lang="en-US" sz="1350" dirty="0">
                         <a:latin typeface="Arial" charset="0"/>
@@ -7856,7 +7945,7 @@
                 <a:ea typeface="Cambria" pitchFamily="34" charset="-122"/>
                 <a:cs typeface="Cambria" pitchFamily="34" charset="-120"/>
               </a:rPr>
-              <a:t>The composition is the precondition — ZIRAN finds it before anyone is attacked. The injection is the trigger; the model-chosen recipient is the missing control. All three live on four review-passing tools.</a:t>
+              <a:t>The composition is the precondition — Ziran finds it before anyone is attacked. The injection is the trigger; the model-chosen recipient is the missing control. All three live on four review-passing tools.</a:t>
             </a:r>
             <a:endParaRPr lang="en-US" sz="1700" dirty="0"/>
           </a:p>
@@ -7927,7 +8016,7 @@
                 <a:ea typeface="Cambria" pitchFamily="34" charset="-122"/>
                 <a:cs typeface="Cambria" pitchFamily="34" charset="-120"/>
               </a:rPr>
-              <a:t>What's behind the scan</a:t>
+              <a:t>Break the graph: the same attack, blocked</a:t>
             </a:r>
             <a:endParaRPr lang="en-US" sz="3200" dirty="0"/>
           </a:p>
@@ -7935,7 +8024,7 @@
       </p:sp>
       <p:pic>
         <p:nvPicPr>
-          <p:cNvPr id="3" name="Image 0" descr="/Users/leone.lage.perdigao/github/quanta/talk/assets/credibility.png">    </p:cNvPr>
+          <p:cNvPr id="3" name="Image 0" descr="/Users/leone.lage.perdigao/github/quanta/talk/assets/exploit_hardened.png">    </p:cNvPr>
           <p:cNvPicPr>
             <a:picLocks noChangeAspect="1"/>
           </p:cNvPicPr>
@@ -7949,14 +8038,53 @@
         </p:blipFill>
         <p:spPr>
           <a:xfrm>
-            <a:off x="1244890" y="1417320"/>
-            <a:ext cx="9699171" cy="4937760"/>
+            <a:off x="640080" y="2249662"/>
+            <a:ext cx="10908792" cy="2907316"/>
           </a:xfrm>
           <a:prstGeom prst="rect">
             <a:avLst/>
           </a:prstGeom>
         </p:spPr>
       </p:pic>
+      <p:sp>
+        <p:nvSpPr>
+          <p:cNvPr id="4" name="Text 1"/>
+          <p:cNvSpPr/>
+          <p:nvPr/>
+        </p:nvSpPr>
+        <p:spPr>
+          <a:xfrm>
+            <a:off x="640080" y="6126480"/>
+            <a:ext cx="10908792" cy="457200"/>
+          </a:xfrm>
+          <a:prstGeom prst="rect">
+            <a:avLst/>
+          </a:prstGeom>
+          <a:noFill/>
+          <a:ln/>
+        </p:spPr>
+        <p:txBody>
+          <a:bodyPr wrap="square" rtlCol="0" anchor="ctr"/>
+          <a:lstStyle/>
+          <a:p>
+            <a:pPr algn="ctr" indent="0" marL="0">
+              <a:buNone/>
+            </a:pPr>
+            <a:r>
+              <a:rPr lang="en-US" sz="1500" i="1" dirty="0">
+                <a:solidFill>
+                  <a:srgbClr val="64748B"/>
+                </a:solidFill>
+                <a:latin typeface="Arial" pitchFamily="34" charset="0"/>
+                <a:ea typeface="Arial" pitchFamily="34" charset="-122"/>
+                <a:cs typeface="Arial" pitchFamily="34" charset="-120"/>
+              </a:rPr>
+              <a:t>One injected security policy. Injection refused as data; model-chosen recipient denied; the analyst's summary still goes out. Same agent, same payload.</a:t>
+            </a:r>
+            <a:endParaRPr lang="en-US" sz="1500" dirty="0"/>
+          </a:p>
+        </p:txBody>
+      </p:sp>
     </p:spTree>
   </p:cSld>
   <p:clrMapOvr>
@@ -8022,46 +8150,69 @@
                 <a:ea typeface="Cambria" pitchFamily="34" charset="-122"/>
                 <a:cs typeface="Cambria" pitchFamily="34" charset="-120"/>
               </a:rPr>
-              <a:t>Break the graph: the same attack, blocked</a:t>
+              <a:t>The fix isn't 'remove a tool'. Break the graph.</a:t>
             </a:r>
             <a:endParaRPr lang="en-US" sz="3200" dirty="0"/>
           </a:p>
         </p:txBody>
       </p:sp>
-      <p:pic>
-        <p:nvPicPr>
-          <p:cNvPr id="3" name="Image 0" descr="/Users/leone.lage.perdigao/github/quanta/talk/assets/exploit_hardened.png">    </p:cNvPr>
-          <p:cNvPicPr>
-            <a:picLocks noChangeAspect="1"/>
-          </p:cNvPicPr>
-          <p:nvPr/>
-        </p:nvPicPr>
-        <p:blipFill>
-          <a:blip r:embed="rId1"/>
-          <a:stretch>
-            <a:fillRect/>
-          </a:stretch>
-        </p:blipFill>
-        <p:spPr>
-          <a:xfrm>
-            <a:off x="640080" y="2249662"/>
-            <a:ext cx="10908792" cy="2907316"/>
-          </a:xfrm>
-          <a:prstGeom prst="rect">
-            <a:avLst/>
-          </a:prstGeom>
-        </p:spPr>
-      </p:pic>
-      <p:sp>
-        <p:nvSpPr>
-          <p:cNvPr id="4" name="Text 1"/>
-          <p:cNvSpPr/>
-          <p:nvPr/>
-        </p:nvSpPr>
-        <p:spPr>
-          <a:xfrm>
-            <a:off x="640080" y="6126480"/>
-            <a:ext cx="10908792" cy="457200"/>
+      <p:sp>
+        <p:nvSpPr>
+          <p:cNvPr id="3" name="Shape 1"/>
+          <p:cNvSpPr/>
+          <p:nvPr/>
+        </p:nvSpPr>
+        <p:spPr>
+          <a:xfrm>
+            <a:off x="640080" y="1508760"/>
+            <a:ext cx="10908792" cy="1024128"/>
+          </a:xfrm>
+          <a:prstGeom prst="roundRect">
+            <a:avLst>
+              <a:gd name="adj" fmla="val 8929"/>
+            </a:avLst>
+          </a:prstGeom>
+          <a:solidFill>
+            <a:srgbClr val="FFFFFF"/>
+          </a:solidFill>
+          <a:ln w="12700">
+            <a:solidFill>
+              <a:srgbClr val="E2E8F0"/>
+            </a:solidFill>
+            <a:prstDash val="solid"/>
+          </a:ln>
+        </p:spPr>
+      </p:sp>
+      <p:sp>
+        <p:nvSpPr>
+          <p:cNvPr id="4" name="Shape 2"/>
+          <p:cNvSpPr/>
+          <p:nvPr/>
+        </p:nvSpPr>
+        <p:spPr>
+          <a:xfrm>
+            <a:off x="914400" y="1792224"/>
+            <a:ext cx="457200" cy="457200"/>
+          </a:xfrm>
+          <a:prstGeom prst="ellipse">
+            <a:avLst/>
+          </a:prstGeom>
+          <a:solidFill>
+            <a:srgbClr val="059669"/>
+          </a:solidFill>
+          <a:ln/>
+        </p:spPr>
+      </p:sp>
+      <p:sp>
+        <p:nvSpPr>
+          <p:cNvPr id="5" name="Text 3"/>
+          <p:cNvSpPr/>
+          <p:nvPr/>
+        </p:nvSpPr>
+        <p:spPr>
+          <a:xfrm>
+            <a:off x="914400" y="1792224"/>
+            <a:ext cx="457200" cy="457200"/>
           </a:xfrm>
           <a:prstGeom prst="rect">
             <a:avLst/>
@@ -8077,17 +8228,587 @@
               <a:buNone/>
             </a:pPr>
             <a:r>
-              <a:rPr lang="en-US" sz="1500" i="1" dirty="0">
-                <a:solidFill>
-                  <a:srgbClr val="64748B"/>
+              <a:rPr lang="en-US" sz="1800" b="1" dirty="0">
+                <a:solidFill>
+                  <a:srgbClr val="FFFFFF"/>
+                </a:solidFill>
+              </a:rPr>
+              <a:t>✓</a:t>
+            </a:r>
+            <a:endParaRPr lang="en-US" sz="1800" dirty="0"/>
+          </a:p>
+        </p:txBody>
+      </p:sp>
+      <p:sp>
+        <p:nvSpPr>
+          <p:cNvPr id="6" name="Text 4"/>
+          <p:cNvSpPr/>
+          <p:nvPr/>
+        </p:nvSpPr>
+        <p:spPr>
+          <a:xfrm>
+            <a:off x="1600200" y="1508760"/>
+            <a:ext cx="4023360" cy="1024128"/>
+          </a:xfrm>
+          <a:prstGeom prst="rect">
+            <a:avLst/>
+          </a:prstGeom>
+          <a:noFill/>
+          <a:ln/>
+        </p:spPr>
+        <p:txBody>
+          <a:bodyPr wrap="square" rtlCol="0" anchor="ctr"/>
+          <a:lstStyle/>
+          <a:p>
+            <a:pPr indent="0" marL="0">
+              <a:buNone/>
+            </a:pPr>
+            <a:r>
+              <a:rPr lang="en-US" sz="1600" b="1" dirty="0">
+                <a:solidFill>
+                  <a:srgbClr val="0F172A"/>
+                </a:solidFill>
+                <a:latin typeface="Cambria" pitchFamily="34" charset="0"/>
+                <a:ea typeface="Cambria" pitchFamily="34" charset="-122"/>
+                <a:cs typeface="Cambria" pitchFamily="34" charset="-120"/>
+              </a:rPr>
+              <a:t>No instructions from data  ·  LLM01</a:t>
+            </a:r>
+            <a:endParaRPr lang="en-US" sz="1600" dirty="0"/>
+          </a:p>
+        </p:txBody>
+      </p:sp>
+      <p:sp>
+        <p:nvSpPr>
+          <p:cNvPr id="7" name="Text 5"/>
+          <p:cNvSpPr/>
+          <p:nvPr/>
+        </p:nvSpPr>
+        <p:spPr>
+          <a:xfrm>
+            <a:off x="5669280" y="1508760"/>
+            <a:ext cx="5669280" cy="1024128"/>
+          </a:xfrm>
+          <a:prstGeom prst="rect">
+            <a:avLst/>
+          </a:prstGeom>
+          <a:noFill/>
+          <a:ln/>
+        </p:spPr>
+        <p:txBody>
+          <a:bodyPr wrap="square" rtlCol="0" anchor="ctr"/>
+          <a:lstStyle/>
+          <a:p>
+            <a:pPr indent="0" marL="0">
+              <a:lnSpc>
+                <a:spcPct val="105000"/>
+              </a:lnSpc>
+              <a:buNone/>
+            </a:pPr>
+            <a:r>
+              <a:rPr lang="en-US" sz="1400" dirty="0">
+                <a:solidFill>
+                  <a:srgbClr val="334155"/>
                 </a:solidFill>
                 <a:latin typeface="Arial" pitchFamily="34" charset="0"/>
                 <a:ea typeface="Arial" pitchFamily="34" charset="-122"/>
                 <a:cs typeface="Arial" pitchFamily="34" charset="-120"/>
               </a:rPr>
-              <a:t>One injected security policy. Injection refused as data; model-chosen recipient denied; the analyst's summary still goes out. Same agent, same payload.</a:t>
-            </a:r>
-            <a:endParaRPr lang="en-US" sz="1500" dirty="0"/>
+              <a:t>Content from fetch_reference is data, never commands — the injected step never runs.</a:t>
+            </a:r>
+            <a:endParaRPr lang="en-US" sz="1400" dirty="0"/>
+          </a:p>
+        </p:txBody>
+      </p:sp>
+      <p:sp>
+        <p:nvSpPr>
+          <p:cNvPr id="8" name="Shape 6"/>
+          <p:cNvSpPr/>
+          <p:nvPr/>
+        </p:nvSpPr>
+        <p:spPr>
+          <a:xfrm>
+            <a:off x="640080" y="2624328"/>
+            <a:ext cx="10908792" cy="1024128"/>
+          </a:xfrm>
+          <a:prstGeom prst="roundRect">
+            <a:avLst>
+              <a:gd name="adj" fmla="val 8929"/>
+            </a:avLst>
+          </a:prstGeom>
+          <a:solidFill>
+            <a:srgbClr val="FFFFFF"/>
+          </a:solidFill>
+          <a:ln w="12700">
+            <a:solidFill>
+              <a:srgbClr val="E2E8F0"/>
+            </a:solidFill>
+            <a:prstDash val="solid"/>
+          </a:ln>
+        </p:spPr>
+      </p:sp>
+      <p:sp>
+        <p:nvSpPr>
+          <p:cNvPr id="9" name="Shape 7"/>
+          <p:cNvSpPr/>
+          <p:nvPr/>
+        </p:nvSpPr>
+        <p:spPr>
+          <a:xfrm>
+            <a:off x="914400" y="2907792"/>
+            <a:ext cx="457200" cy="457200"/>
+          </a:xfrm>
+          <a:prstGeom prst="ellipse">
+            <a:avLst/>
+          </a:prstGeom>
+          <a:solidFill>
+            <a:srgbClr val="059669"/>
+          </a:solidFill>
+          <a:ln/>
+        </p:spPr>
+      </p:sp>
+      <p:sp>
+        <p:nvSpPr>
+          <p:cNvPr id="10" name="Text 8"/>
+          <p:cNvSpPr/>
+          <p:nvPr/>
+        </p:nvSpPr>
+        <p:spPr>
+          <a:xfrm>
+            <a:off x="914400" y="2907792"/>
+            <a:ext cx="457200" cy="457200"/>
+          </a:xfrm>
+          <a:prstGeom prst="rect">
+            <a:avLst/>
+          </a:prstGeom>
+          <a:noFill/>
+          <a:ln/>
+        </p:spPr>
+        <p:txBody>
+          <a:bodyPr wrap="square" rtlCol="0" anchor="ctr"/>
+          <a:lstStyle/>
+          <a:p>
+            <a:pPr algn="ctr" indent="0" marL="0">
+              <a:buNone/>
+            </a:pPr>
+            <a:r>
+              <a:rPr lang="en-US" sz="1800" b="1" dirty="0">
+                <a:solidFill>
+                  <a:srgbClr val="FFFFFF"/>
+                </a:solidFill>
+              </a:rPr>
+              <a:t>✓</a:t>
+            </a:r>
+            <a:endParaRPr lang="en-US" sz="1800" dirty="0"/>
+          </a:p>
+        </p:txBody>
+      </p:sp>
+      <p:sp>
+        <p:nvSpPr>
+          <p:cNvPr id="11" name="Text 9"/>
+          <p:cNvSpPr/>
+          <p:nvPr/>
+        </p:nvSpPr>
+        <p:spPr>
+          <a:xfrm>
+            <a:off x="1600200" y="2624328"/>
+            <a:ext cx="4023360" cy="1024128"/>
+          </a:xfrm>
+          <a:prstGeom prst="rect">
+            <a:avLst/>
+          </a:prstGeom>
+          <a:noFill/>
+          <a:ln/>
+        </p:spPr>
+        <p:txBody>
+          <a:bodyPr wrap="square" rtlCol="0" anchor="ctr"/>
+          <a:lstStyle/>
+          <a:p>
+            <a:pPr indent="0" marL="0">
+              <a:buNone/>
+            </a:pPr>
+            <a:r>
+              <a:rPr lang="en-US" sz="1600" b="1" dirty="0">
+                <a:solidFill>
+                  <a:srgbClr val="0F172A"/>
+                </a:solidFill>
+                <a:latin typeface="Cambria" pitchFamily="34" charset="0"/>
+                <a:ea typeface="Cambria" pitchFamily="34" charset="-122"/>
+                <a:cs typeface="Cambria" pitchFamily="34" charset="-120"/>
+              </a:rPr>
+              <a:t>Recipient binding  ·  LLM06</a:t>
+            </a:r>
+            <a:endParaRPr lang="en-US" sz="1600" dirty="0"/>
+          </a:p>
+        </p:txBody>
+      </p:sp>
+      <p:sp>
+        <p:nvSpPr>
+          <p:cNvPr id="12" name="Text 10"/>
+          <p:cNvSpPr/>
+          <p:nvPr/>
+        </p:nvSpPr>
+        <p:spPr>
+          <a:xfrm>
+            <a:off x="5669280" y="2624328"/>
+            <a:ext cx="5669280" cy="1024128"/>
+          </a:xfrm>
+          <a:prstGeom prst="rect">
+            <a:avLst/>
+          </a:prstGeom>
+          <a:noFill/>
+          <a:ln/>
+        </p:spPr>
+        <p:txBody>
+          <a:bodyPr wrap="square" rtlCol="0" anchor="ctr"/>
+          <a:lstStyle/>
+          <a:p>
+            <a:pPr indent="0" marL="0">
+              <a:lnSpc>
+                <a:spcPct val="105000"/>
+              </a:lnSpc>
+              <a:buNone/>
+            </a:pPr>
+            <a:r>
+              <a:rPr lang="en-US" sz="1400" dirty="0">
+                <a:solidFill>
+                  <a:srgbClr val="334155"/>
+                </a:solidFill>
+                <a:latin typeface="Arial" pitchFamily="34" charset="0"/>
+                <a:ea typeface="Arial" pitchFamily="34" charset="-122"/>
+                <a:cs typeface="Arial" pitchFamily="34" charset="-120"/>
+              </a:rPr>
+              <a:t>send_email_report only reaches the authenticated requester — not a model-chosen address, even on an allowlisted domain.</a:t>
+            </a:r>
+            <a:endParaRPr lang="en-US" sz="1400" dirty="0"/>
+          </a:p>
+        </p:txBody>
+      </p:sp>
+      <p:sp>
+        <p:nvSpPr>
+          <p:cNvPr id="13" name="Shape 11"/>
+          <p:cNvSpPr/>
+          <p:nvPr/>
+        </p:nvSpPr>
+        <p:spPr>
+          <a:xfrm>
+            <a:off x="640080" y="3739896"/>
+            <a:ext cx="10908792" cy="1024128"/>
+          </a:xfrm>
+          <a:prstGeom prst="roundRect">
+            <a:avLst>
+              <a:gd name="adj" fmla="val 8929"/>
+            </a:avLst>
+          </a:prstGeom>
+          <a:solidFill>
+            <a:srgbClr val="FFFFFF"/>
+          </a:solidFill>
+          <a:ln w="12700">
+            <a:solidFill>
+              <a:srgbClr val="E2E8F0"/>
+            </a:solidFill>
+            <a:prstDash val="solid"/>
+          </a:ln>
+        </p:spPr>
+      </p:sp>
+      <p:sp>
+        <p:nvSpPr>
+          <p:cNvPr id="14" name="Shape 12"/>
+          <p:cNvSpPr/>
+          <p:nvPr/>
+        </p:nvSpPr>
+        <p:spPr>
+          <a:xfrm>
+            <a:off x="914400" y="4023360"/>
+            <a:ext cx="457200" cy="457200"/>
+          </a:xfrm>
+          <a:prstGeom prst="ellipse">
+            <a:avLst/>
+          </a:prstGeom>
+          <a:solidFill>
+            <a:srgbClr val="059669"/>
+          </a:solidFill>
+          <a:ln/>
+        </p:spPr>
+      </p:sp>
+      <p:sp>
+        <p:nvSpPr>
+          <p:cNvPr id="15" name="Text 13"/>
+          <p:cNvSpPr/>
+          <p:nvPr/>
+        </p:nvSpPr>
+        <p:spPr>
+          <a:xfrm>
+            <a:off x="914400" y="4023360"/>
+            <a:ext cx="457200" cy="457200"/>
+          </a:xfrm>
+          <a:prstGeom prst="rect">
+            <a:avLst/>
+          </a:prstGeom>
+          <a:noFill/>
+          <a:ln/>
+        </p:spPr>
+        <p:txBody>
+          <a:bodyPr wrap="square" rtlCol="0" anchor="ctr"/>
+          <a:lstStyle/>
+          <a:p>
+            <a:pPr algn="ctr" indent="0" marL="0">
+              <a:buNone/>
+            </a:pPr>
+            <a:r>
+              <a:rPr lang="en-US" sz="1800" b="1" dirty="0">
+                <a:solidFill>
+                  <a:srgbClr val="FFFFFF"/>
+                </a:solidFill>
+              </a:rPr>
+              <a:t>✓</a:t>
+            </a:r>
+            <a:endParaRPr lang="en-US" sz="1800" dirty="0"/>
+          </a:p>
+        </p:txBody>
+      </p:sp>
+      <p:sp>
+        <p:nvSpPr>
+          <p:cNvPr id="16" name="Text 14"/>
+          <p:cNvSpPr/>
+          <p:nvPr/>
+        </p:nvSpPr>
+        <p:spPr>
+          <a:xfrm>
+            <a:off x="1600200" y="3739896"/>
+            <a:ext cx="4023360" cy="1024128"/>
+          </a:xfrm>
+          <a:prstGeom prst="rect">
+            <a:avLst/>
+          </a:prstGeom>
+          <a:noFill/>
+          <a:ln/>
+        </p:spPr>
+        <p:txBody>
+          <a:bodyPr wrap="square" rtlCol="0" anchor="ctr"/>
+          <a:lstStyle/>
+          <a:p>
+            <a:pPr indent="0" marL="0">
+              <a:buNone/>
+            </a:pPr>
+            <a:r>
+              <a:rPr lang="en-US" sz="1600" b="1" dirty="0">
+                <a:solidFill>
+                  <a:srgbClr val="0F172A"/>
+                </a:solidFill>
+                <a:latin typeface="Cambria" pitchFamily="34" charset="0"/>
+                <a:ea typeface="Cambria" pitchFamily="34" charset="-122"/>
+                <a:cs typeface="Cambria" pitchFamily="34" charset="-120"/>
+              </a:rPr>
+              <a:t>Trifecta gate  ·  taint tracking</a:t>
+            </a:r>
+            <a:endParaRPr lang="en-US" sz="1600" dirty="0"/>
+          </a:p>
+        </p:txBody>
+      </p:sp>
+      <p:sp>
+        <p:nvSpPr>
+          <p:cNvPr id="17" name="Text 15"/>
+          <p:cNvSpPr/>
+          <p:nvPr/>
+        </p:nvSpPr>
+        <p:spPr>
+          <a:xfrm>
+            <a:off x="5669280" y="3739896"/>
+            <a:ext cx="5669280" cy="1024128"/>
+          </a:xfrm>
+          <a:prstGeom prst="rect">
+            <a:avLst/>
+          </a:prstGeom>
+          <a:noFill/>
+          <a:ln/>
+        </p:spPr>
+        <p:txBody>
+          <a:bodyPr wrap="square" rtlCol="0" anchor="ctr"/>
+          <a:lstStyle/>
+          <a:p>
+            <a:pPr indent="0" marL="0">
+              <a:lnSpc>
+                <a:spcPct val="105000"/>
+              </a:lnSpc>
+              <a:buNone/>
+            </a:pPr>
+            <a:r>
+              <a:rPr lang="en-US" sz="1400" dirty="0">
+                <a:solidFill>
+                  <a:srgbClr val="334155"/>
+                </a:solidFill>
+                <a:latin typeface="Arial" pitchFamily="34" charset="0"/>
+                <a:ea typeface="Arial" pitchFamily="34" charset="-122"/>
+                <a:cs typeface="Arial" pitchFamily="34" charset="-120"/>
+              </a:rPr>
+              <a:t>A run holding private + untrusted data can't reach an external sink unattended. Aggregates aren't private — the real task still works.</a:t>
+            </a:r>
+            <a:endParaRPr lang="en-US" sz="1400" dirty="0"/>
+          </a:p>
+        </p:txBody>
+      </p:sp>
+      <p:sp>
+        <p:nvSpPr>
+          <p:cNvPr id="18" name="Shape 16"/>
+          <p:cNvSpPr/>
+          <p:nvPr/>
+        </p:nvSpPr>
+        <p:spPr>
+          <a:xfrm>
+            <a:off x="640080" y="4855464"/>
+            <a:ext cx="10908792" cy="1024128"/>
+          </a:xfrm>
+          <a:prstGeom prst="roundRect">
+            <a:avLst>
+              <a:gd name="adj" fmla="val 8929"/>
+            </a:avLst>
+          </a:prstGeom>
+          <a:solidFill>
+            <a:srgbClr val="FFFFFF"/>
+          </a:solidFill>
+          <a:ln w="12700">
+            <a:solidFill>
+              <a:srgbClr val="E2E8F0"/>
+            </a:solidFill>
+            <a:prstDash val="solid"/>
+          </a:ln>
+        </p:spPr>
+      </p:sp>
+      <p:sp>
+        <p:nvSpPr>
+          <p:cNvPr id="19" name="Shape 17"/>
+          <p:cNvSpPr/>
+          <p:nvPr/>
+        </p:nvSpPr>
+        <p:spPr>
+          <a:xfrm>
+            <a:off x="914400" y="5138928"/>
+            <a:ext cx="457200" cy="457200"/>
+          </a:xfrm>
+          <a:prstGeom prst="ellipse">
+            <a:avLst/>
+          </a:prstGeom>
+          <a:solidFill>
+            <a:srgbClr val="059669"/>
+          </a:solidFill>
+          <a:ln/>
+        </p:spPr>
+      </p:sp>
+      <p:sp>
+        <p:nvSpPr>
+          <p:cNvPr id="20" name="Text 18"/>
+          <p:cNvSpPr/>
+          <p:nvPr/>
+        </p:nvSpPr>
+        <p:spPr>
+          <a:xfrm>
+            <a:off x="914400" y="5138928"/>
+            <a:ext cx="457200" cy="457200"/>
+          </a:xfrm>
+          <a:prstGeom prst="rect">
+            <a:avLst/>
+          </a:prstGeom>
+          <a:noFill/>
+          <a:ln/>
+        </p:spPr>
+        <p:txBody>
+          <a:bodyPr wrap="square" rtlCol="0" anchor="ctr"/>
+          <a:lstStyle/>
+          <a:p>
+            <a:pPr algn="ctr" indent="0" marL="0">
+              <a:buNone/>
+            </a:pPr>
+            <a:r>
+              <a:rPr lang="en-US" sz="1800" b="1" dirty="0">
+                <a:solidFill>
+                  <a:srgbClr val="FFFFFF"/>
+                </a:solidFill>
+              </a:rPr>
+              <a:t>✓</a:t>
+            </a:r>
+            <a:endParaRPr lang="en-US" sz="1800" dirty="0"/>
+          </a:p>
+        </p:txBody>
+      </p:sp>
+      <p:sp>
+        <p:nvSpPr>
+          <p:cNvPr id="21" name="Text 19"/>
+          <p:cNvSpPr/>
+          <p:nvPr/>
+        </p:nvSpPr>
+        <p:spPr>
+          <a:xfrm>
+            <a:off x="1600200" y="4855464"/>
+            <a:ext cx="4023360" cy="1024128"/>
+          </a:xfrm>
+          <a:prstGeom prst="rect">
+            <a:avLst/>
+          </a:prstGeom>
+          <a:noFill/>
+          <a:ln/>
+        </p:spPr>
+        <p:txBody>
+          <a:bodyPr wrap="square" rtlCol="0" anchor="ctr"/>
+          <a:lstStyle/>
+          <a:p>
+            <a:pPr indent="0" marL="0">
+              <a:buNone/>
+            </a:pPr>
+            <a:r>
+              <a:rPr lang="en-US" sz="1600" b="1" dirty="0">
+                <a:solidFill>
+                  <a:srgbClr val="0F172A"/>
+                </a:solidFill>
+                <a:latin typeface="Cambria" pitchFamily="34" charset="0"/>
+                <a:ea typeface="Cambria" pitchFamily="34" charset="-122"/>
+                <a:cs typeface="Cambria" pitchFamily="34" charset="-120"/>
+              </a:rPr>
+              <a:t>Re-scan in CI  ·  ziran ci</a:t>
+            </a:r>
+            <a:endParaRPr lang="en-US" sz="1600" dirty="0"/>
+          </a:p>
+        </p:txBody>
+      </p:sp>
+      <p:sp>
+        <p:nvSpPr>
+          <p:cNvPr id="22" name="Text 20"/>
+          <p:cNvSpPr/>
+          <p:nvPr/>
+        </p:nvSpPr>
+        <p:spPr>
+          <a:xfrm>
+            <a:off x="5669280" y="4855464"/>
+            <a:ext cx="5669280" cy="1024128"/>
+          </a:xfrm>
+          <a:prstGeom prst="rect">
+            <a:avLst/>
+          </a:prstGeom>
+          <a:noFill/>
+          <a:ln/>
+        </p:spPr>
+        <p:txBody>
+          <a:bodyPr wrap="square" rtlCol="0" anchor="ctr"/>
+          <a:lstStyle/>
+          <a:p>
+            <a:pPr indent="0" marL="0">
+              <a:lnSpc>
+                <a:spcPct val="105000"/>
+              </a:lnSpc>
+              <a:buNone/>
+            </a:pPr>
+            <a:r>
+              <a:rPr lang="en-US" sz="1400" dirty="0">
+                <a:solidFill>
+                  <a:srgbClr val="334155"/>
+                </a:solidFill>
+                <a:latin typeface="Arial" pitchFamily="34" charset="0"/>
+                <a:ea typeface="Arial" pitchFamily="34" charset="-122"/>
+                <a:cs typeface="Arial" pitchFamily="34" charset="-120"/>
+              </a:rPr>
+              <a:t>Fail the build when a newly-added tool completes a trifecta. Composition as a reviewable artifact.</a:t>
+            </a:r>
+            <a:endParaRPr lang="en-US" sz="1400" dirty="0"/>
           </a:p>
         </p:txBody>
       </p:sp>
@@ -8156,69 +8877,46 @@
                 <a:ea typeface="Cambria" pitchFamily="34" charset="-122"/>
                 <a:cs typeface="Cambria" pitchFamily="34" charset="-120"/>
               </a:rPr>
-              <a:t>The fix isn't 'remove a tool'. Break the graph.</a:t>
+              <a:t>What about multi-agent systems?</a:t>
             </a:r>
             <a:endParaRPr lang="en-US" sz="3200" dirty="0"/>
           </a:p>
         </p:txBody>
       </p:sp>
-      <p:sp>
-        <p:nvSpPr>
-          <p:cNvPr id="3" name="Shape 1"/>
-          <p:cNvSpPr/>
-          <p:nvPr/>
-        </p:nvSpPr>
-        <p:spPr>
-          <a:xfrm>
-            <a:off x="640080" y="1508760"/>
-            <a:ext cx="10908792" cy="1024128"/>
-          </a:xfrm>
-          <a:prstGeom prst="roundRect">
-            <a:avLst>
-              <a:gd name="adj" fmla="val 8929"/>
-            </a:avLst>
-          </a:prstGeom>
-          <a:solidFill>
-            <a:srgbClr val="FFFFFF"/>
-          </a:solidFill>
-          <a:ln w="12700">
-            <a:solidFill>
-              <a:srgbClr val="E2E8F0"/>
-            </a:solidFill>
-            <a:prstDash val="solid"/>
-          </a:ln>
-        </p:spPr>
-      </p:sp>
-      <p:sp>
-        <p:nvSpPr>
-          <p:cNvPr id="4" name="Shape 2"/>
-          <p:cNvSpPr/>
-          <p:nvPr/>
-        </p:nvSpPr>
-        <p:spPr>
-          <a:xfrm>
-            <a:off x="914400" y="1792224"/>
-            <a:ext cx="457200" cy="457200"/>
-          </a:xfrm>
-          <a:prstGeom prst="ellipse">
-            <a:avLst/>
-          </a:prstGeom>
-          <a:solidFill>
-            <a:srgbClr val="059669"/>
-          </a:solidFill>
-          <a:ln/>
-        </p:spPr>
-      </p:sp>
-      <p:sp>
-        <p:nvSpPr>
-          <p:cNvPr id="5" name="Text 3"/>
-          <p:cNvSpPr/>
-          <p:nvPr/>
-        </p:nvSpPr>
-        <p:spPr>
-          <a:xfrm>
-            <a:off x="914400" y="1792224"/>
-            <a:ext cx="457200" cy="457200"/>
+      <p:pic>
+        <p:nvPicPr>
+          <p:cNvPr id="3" name="Image 0" descr="/Users/leone.lage.perdigao/github/quanta/talk/assets/multi-agent-trifecta.png">    </p:cNvPr>
+          <p:cNvPicPr>
+            <a:picLocks noChangeAspect="1"/>
+          </p:cNvPicPr>
+          <p:nvPr/>
+        </p:nvPicPr>
+        <p:blipFill>
+          <a:blip r:embed="rId1"/>
+          <a:stretch>
+            <a:fillRect/>
+          </a:stretch>
+        </p:blipFill>
+        <p:spPr>
+          <a:xfrm>
+            <a:off x="2449233" y="1417320"/>
+            <a:ext cx="7290486" cy="4572000"/>
+          </a:xfrm>
+          <a:prstGeom prst="rect">
+            <a:avLst/>
+          </a:prstGeom>
+        </p:spPr>
+      </p:pic>
+      <p:sp>
+        <p:nvSpPr>
+          <p:cNvPr id="4" name="Text 1"/>
+          <p:cNvSpPr/>
+          <p:nvPr/>
+        </p:nvSpPr>
+        <p:spPr>
+          <a:xfrm>
+            <a:off x="640080" y="6126480"/>
+            <a:ext cx="10908792" cy="457200"/>
           </a:xfrm>
           <a:prstGeom prst="rect">
             <a:avLst/>
@@ -8234,587 +8932,17 @@
               <a:buNone/>
             </a:pPr>
             <a:r>
-              <a:rPr lang="en-US" sz="1800" b="1" dirty="0">
-                <a:solidFill>
-                  <a:srgbClr val="FFFFFF"/>
-                </a:solidFill>
-              </a:rPr>
-              <a:t>✓</a:t>
-            </a:r>
-            <a:endParaRPr lang="en-US" sz="1800" dirty="0"/>
-          </a:p>
-        </p:txBody>
-      </p:sp>
-      <p:sp>
-        <p:nvSpPr>
-          <p:cNvPr id="6" name="Text 4"/>
-          <p:cNvSpPr/>
-          <p:nvPr/>
-        </p:nvSpPr>
-        <p:spPr>
-          <a:xfrm>
-            <a:off x="1600200" y="1508760"/>
-            <a:ext cx="4023360" cy="1024128"/>
-          </a:xfrm>
-          <a:prstGeom prst="rect">
-            <a:avLst/>
-          </a:prstGeom>
-          <a:noFill/>
-          <a:ln/>
-        </p:spPr>
-        <p:txBody>
-          <a:bodyPr wrap="square" rtlCol="0" anchor="ctr"/>
-          <a:lstStyle/>
-          <a:p>
-            <a:pPr indent="0" marL="0">
-              <a:buNone/>
-            </a:pPr>
-            <a:r>
-              <a:rPr lang="en-US" sz="1600" b="1" dirty="0">
-                <a:solidFill>
-                  <a:srgbClr val="0F172A"/>
-                </a:solidFill>
-                <a:latin typeface="Cambria" pitchFamily="34" charset="0"/>
-                <a:ea typeface="Cambria" pitchFamily="34" charset="-122"/>
-                <a:cs typeface="Cambria" pitchFamily="34" charset="-120"/>
-              </a:rPr>
-              <a:t>No instructions from data  ·  LLM01</a:t>
-            </a:r>
-            <a:endParaRPr lang="en-US" sz="1600" dirty="0"/>
-          </a:p>
-        </p:txBody>
-      </p:sp>
-      <p:sp>
-        <p:nvSpPr>
-          <p:cNvPr id="7" name="Text 5"/>
-          <p:cNvSpPr/>
-          <p:nvPr/>
-        </p:nvSpPr>
-        <p:spPr>
-          <a:xfrm>
-            <a:off x="5669280" y="1508760"/>
-            <a:ext cx="5669280" cy="1024128"/>
-          </a:xfrm>
-          <a:prstGeom prst="rect">
-            <a:avLst/>
-          </a:prstGeom>
-          <a:noFill/>
-          <a:ln/>
-        </p:spPr>
-        <p:txBody>
-          <a:bodyPr wrap="square" rtlCol="0" anchor="ctr"/>
-          <a:lstStyle/>
-          <a:p>
-            <a:pPr indent="0" marL="0">
-              <a:lnSpc>
-                <a:spcPct val="105000"/>
-              </a:lnSpc>
-              <a:buNone/>
-            </a:pPr>
-            <a:r>
-              <a:rPr lang="en-US" sz="1400" dirty="0">
-                <a:solidFill>
-                  <a:srgbClr val="334155"/>
+              <a:rPr lang="en-US" sz="1500" i="1" dirty="0">
+                <a:solidFill>
+                  <a:srgbClr val="64748B"/>
                 </a:solidFill>
                 <a:latin typeface="Arial" pitchFamily="34" charset="0"/>
                 <a:ea typeface="Arial" pitchFamily="34" charset="-122"/>
                 <a:cs typeface="Arial" pitchFamily="34" charset="-120"/>
               </a:rPr>
-              <a:t>Content from fetch_reference is data, never commands — the injected step never runs.</a:t>
-            </a:r>
-            <a:endParaRPr lang="en-US" sz="1400" dirty="0"/>
-          </a:p>
-        </p:txBody>
-      </p:sp>
-      <p:sp>
-        <p:nvSpPr>
-          <p:cNvPr id="8" name="Shape 6"/>
-          <p:cNvSpPr/>
-          <p:nvPr/>
-        </p:nvSpPr>
-        <p:spPr>
-          <a:xfrm>
-            <a:off x="640080" y="2624328"/>
-            <a:ext cx="10908792" cy="1024128"/>
-          </a:xfrm>
-          <a:prstGeom prst="roundRect">
-            <a:avLst>
-              <a:gd name="adj" fmla="val 8929"/>
-            </a:avLst>
-          </a:prstGeom>
-          <a:solidFill>
-            <a:srgbClr val="FFFFFF"/>
-          </a:solidFill>
-          <a:ln w="12700">
-            <a:solidFill>
-              <a:srgbClr val="E2E8F0"/>
-            </a:solidFill>
-            <a:prstDash val="solid"/>
-          </a:ln>
-        </p:spPr>
-      </p:sp>
-      <p:sp>
-        <p:nvSpPr>
-          <p:cNvPr id="9" name="Shape 7"/>
-          <p:cNvSpPr/>
-          <p:nvPr/>
-        </p:nvSpPr>
-        <p:spPr>
-          <a:xfrm>
-            <a:off x="914400" y="2907792"/>
-            <a:ext cx="457200" cy="457200"/>
-          </a:xfrm>
-          <a:prstGeom prst="ellipse">
-            <a:avLst/>
-          </a:prstGeom>
-          <a:solidFill>
-            <a:srgbClr val="059669"/>
-          </a:solidFill>
-          <a:ln/>
-        </p:spPr>
-      </p:sp>
-      <p:sp>
-        <p:nvSpPr>
-          <p:cNvPr id="10" name="Text 8"/>
-          <p:cNvSpPr/>
-          <p:nvPr/>
-        </p:nvSpPr>
-        <p:spPr>
-          <a:xfrm>
-            <a:off x="914400" y="2907792"/>
-            <a:ext cx="457200" cy="457200"/>
-          </a:xfrm>
-          <a:prstGeom prst="rect">
-            <a:avLst/>
-          </a:prstGeom>
-          <a:noFill/>
-          <a:ln/>
-        </p:spPr>
-        <p:txBody>
-          <a:bodyPr wrap="square" rtlCol="0" anchor="ctr"/>
-          <a:lstStyle/>
-          <a:p>
-            <a:pPr algn="ctr" indent="0" marL="0">
-              <a:buNone/>
-            </a:pPr>
-            <a:r>
-              <a:rPr lang="en-US" sz="1800" b="1" dirty="0">
-                <a:solidFill>
-                  <a:srgbClr val="FFFFFF"/>
-                </a:solidFill>
-              </a:rPr>
-              <a:t>✓</a:t>
-            </a:r>
-            <a:endParaRPr lang="en-US" sz="1800" dirty="0"/>
-          </a:p>
-        </p:txBody>
-      </p:sp>
-      <p:sp>
-        <p:nvSpPr>
-          <p:cNvPr id="11" name="Text 9"/>
-          <p:cNvSpPr/>
-          <p:nvPr/>
-        </p:nvSpPr>
-        <p:spPr>
-          <a:xfrm>
-            <a:off x="1600200" y="2624328"/>
-            <a:ext cx="4023360" cy="1024128"/>
-          </a:xfrm>
-          <a:prstGeom prst="rect">
-            <a:avLst/>
-          </a:prstGeom>
-          <a:noFill/>
-          <a:ln/>
-        </p:spPr>
-        <p:txBody>
-          <a:bodyPr wrap="square" rtlCol="0" anchor="ctr"/>
-          <a:lstStyle/>
-          <a:p>
-            <a:pPr indent="0" marL="0">
-              <a:buNone/>
-            </a:pPr>
-            <a:r>
-              <a:rPr lang="en-US" sz="1600" b="1" dirty="0">
-                <a:solidFill>
-                  <a:srgbClr val="0F172A"/>
-                </a:solidFill>
-                <a:latin typeface="Cambria" pitchFamily="34" charset="0"/>
-                <a:ea typeface="Cambria" pitchFamily="34" charset="-122"/>
-                <a:cs typeface="Cambria" pitchFamily="34" charset="-120"/>
-              </a:rPr>
-              <a:t>Recipient binding  ·  LLM06</a:t>
-            </a:r>
-            <a:endParaRPr lang="en-US" sz="1600" dirty="0"/>
-          </a:p>
-        </p:txBody>
-      </p:sp>
-      <p:sp>
-        <p:nvSpPr>
-          <p:cNvPr id="12" name="Text 10"/>
-          <p:cNvSpPr/>
-          <p:nvPr/>
-        </p:nvSpPr>
-        <p:spPr>
-          <a:xfrm>
-            <a:off x="5669280" y="2624328"/>
-            <a:ext cx="5669280" cy="1024128"/>
-          </a:xfrm>
-          <a:prstGeom prst="rect">
-            <a:avLst/>
-          </a:prstGeom>
-          <a:noFill/>
-          <a:ln/>
-        </p:spPr>
-        <p:txBody>
-          <a:bodyPr wrap="square" rtlCol="0" anchor="ctr"/>
-          <a:lstStyle/>
-          <a:p>
-            <a:pPr indent="0" marL="0">
-              <a:lnSpc>
-                <a:spcPct val="105000"/>
-              </a:lnSpc>
-              <a:buNone/>
-            </a:pPr>
-            <a:r>
-              <a:rPr lang="en-US" sz="1400" dirty="0">
-                <a:solidFill>
-                  <a:srgbClr val="334155"/>
-                </a:solidFill>
-                <a:latin typeface="Arial" pitchFamily="34" charset="0"/>
-                <a:ea typeface="Arial" pitchFamily="34" charset="-122"/>
-                <a:cs typeface="Arial" pitchFamily="34" charset="-120"/>
-              </a:rPr>
-              <a:t>send_email_report only reaches the authenticated requester — not a model-chosen address, even on an allowlisted domain.</a:t>
-            </a:r>
-            <a:endParaRPr lang="en-US" sz="1400" dirty="0"/>
-          </a:p>
-        </p:txBody>
-      </p:sp>
-      <p:sp>
-        <p:nvSpPr>
-          <p:cNvPr id="13" name="Shape 11"/>
-          <p:cNvSpPr/>
-          <p:nvPr/>
-        </p:nvSpPr>
-        <p:spPr>
-          <a:xfrm>
-            <a:off x="640080" y="3739896"/>
-            <a:ext cx="10908792" cy="1024128"/>
-          </a:xfrm>
-          <a:prstGeom prst="roundRect">
-            <a:avLst>
-              <a:gd name="adj" fmla="val 8929"/>
-            </a:avLst>
-          </a:prstGeom>
-          <a:solidFill>
-            <a:srgbClr val="FFFFFF"/>
-          </a:solidFill>
-          <a:ln w="12700">
-            <a:solidFill>
-              <a:srgbClr val="E2E8F0"/>
-            </a:solidFill>
-            <a:prstDash val="solid"/>
-          </a:ln>
-        </p:spPr>
-      </p:sp>
-      <p:sp>
-        <p:nvSpPr>
-          <p:cNvPr id="14" name="Shape 12"/>
-          <p:cNvSpPr/>
-          <p:nvPr/>
-        </p:nvSpPr>
-        <p:spPr>
-          <a:xfrm>
-            <a:off x="914400" y="4023360"/>
-            <a:ext cx="457200" cy="457200"/>
-          </a:xfrm>
-          <a:prstGeom prst="ellipse">
-            <a:avLst/>
-          </a:prstGeom>
-          <a:solidFill>
-            <a:srgbClr val="059669"/>
-          </a:solidFill>
-          <a:ln/>
-        </p:spPr>
-      </p:sp>
-      <p:sp>
-        <p:nvSpPr>
-          <p:cNvPr id="15" name="Text 13"/>
-          <p:cNvSpPr/>
-          <p:nvPr/>
-        </p:nvSpPr>
-        <p:spPr>
-          <a:xfrm>
-            <a:off x="914400" y="4023360"/>
-            <a:ext cx="457200" cy="457200"/>
-          </a:xfrm>
-          <a:prstGeom prst="rect">
-            <a:avLst/>
-          </a:prstGeom>
-          <a:noFill/>
-          <a:ln/>
-        </p:spPr>
-        <p:txBody>
-          <a:bodyPr wrap="square" rtlCol="0" anchor="ctr"/>
-          <a:lstStyle/>
-          <a:p>
-            <a:pPr algn="ctr" indent="0" marL="0">
-              <a:buNone/>
-            </a:pPr>
-            <a:r>
-              <a:rPr lang="en-US" sz="1800" b="1" dirty="0">
-                <a:solidFill>
-                  <a:srgbClr val="FFFFFF"/>
-                </a:solidFill>
-              </a:rPr>
-              <a:t>✓</a:t>
-            </a:r>
-            <a:endParaRPr lang="en-US" sz="1800" dirty="0"/>
-          </a:p>
-        </p:txBody>
-      </p:sp>
-      <p:sp>
-        <p:nvSpPr>
-          <p:cNvPr id="16" name="Text 14"/>
-          <p:cNvSpPr/>
-          <p:nvPr/>
-        </p:nvSpPr>
-        <p:spPr>
-          <a:xfrm>
-            <a:off x="1600200" y="3739896"/>
-            <a:ext cx="4023360" cy="1024128"/>
-          </a:xfrm>
-          <a:prstGeom prst="rect">
-            <a:avLst/>
-          </a:prstGeom>
-          <a:noFill/>
-          <a:ln/>
-        </p:spPr>
-        <p:txBody>
-          <a:bodyPr wrap="square" rtlCol="0" anchor="ctr"/>
-          <a:lstStyle/>
-          <a:p>
-            <a:pPr indent="0" marL="0">
-              <a:buNone/>
-            </a:pPr>
-            <a:r>
-              <a:rPr lang="en-US" sz="1600" b="1" dirty="0">
-                <a:solidFill>
-                  <a:srgbClr val="0F172A"/>
-                </a:solidFill>
-                <a:latin typeface="Cambria" pitchFamily="34" charset="0"/>
-                <a:ea typeface="Cambria" pitchFamily="34" charset="-122"/>
-                <a:cs typeface="Cambria" pitchFamily="34" charset="-120"/>
-              </a:rPr>
-              <a:t>Trifecta gate  ·  taint tracking</a:t>
-            </a:r>
-            <a:endParaRPr lang="en-US" sz="1600" dirty="0"/>
-          </a:p>
-        </p:txBody>
-      </p:sp>
-      <p:sp>
-        <p:nvSpPr>
-          <p:cNvPr id="17" name="Text 15"/>
-          <p:cNvSpPr/>
-          <p:nvPr/>
-        </p:nvSpPr>
-        <p:spPr>
-          <a:xfrm>
-            <a:off x="5669280" y="3739896"/>
-            <a:ext cx="5669280" cy="1024128"/>
-          </a:xfrm>
-          <a:prstGeom prst="rect">
-            <a:avLst/>
-          </a:prstGeom>
-          <a:noFill/>
-          <a:ln/>
-        </p:spPr>
-        <p:txBody>
-          <a:bodyPr wrap="square" rtlCol="0" anchor="ctr"/>
-          <a:lstStyle/>
-          <a:p>
-            <a:pPr indent="0" marL="0">
-              <a:lnSpc>
-                <a:spcPct val="105000"/>
-              </a:lnSpc>
-              <a:buNone/>
-            </a:pPr>
-            <a:r>
-              <a:rPr lang="en-US" sz="1400" dirty="0">
-                <a:solidFill>
-                  <a:srgbClr val="334155"/>
-                </a:solidFill>
-                <a:latin typeface="Arial" pitchFamily="34" charset="0"/>
-                <a:ea typeface="Arial" pitchFamily="34" charset="-122"/>
-                <a:cs typeface="Arial" pitchFamily="34" charset="-120"/>
-              </a:rPr>
-              <a:t>A run holding private + untrusted data can't reach an external sink unattended. Aggregates aren't private — the real task still works.</a:t>
-            </a:r>
-            <a:endParaRPr lang="en-US" sz="1400" dirty="0"/>
-          </a:p>
-        </p:txBody>
-      </p:sp>
-      <p:sp>
-        <p:nvSpPr>
-          <p:cNvPr id="18" name="Shape 16"/>
-          <p:cNvSpPr/>
-          <p:nvPr/>
-        </p:nvSpPr>
-        <p:spPr>
-          <a:xfrm>
-            <a:off x="640080" y="4855464"/>
-            <a:ext cx="10908792" cy="1024128"/>
-          </a:xfrm>
-          <a:prstGeom prst="roundRect">
-            <a:avLst>
-              <a:gd name="adj" fmla="val 8929"/>
-            </a:avLst>
-          </a:prstGeom>
-          <a:solidFill>
-            <a:srgbClr val="FFFFFF"/>
-          </a:solidFill>
-          <a:ln w="12700">
-            <a:solidFill>
-              <a:srgbClr val="E2E8F0"/>
-            </a:solidFill>
-            <a:prstDash val="solid"/>
-          </a:ln>
-        </p:spPr>
-      </p:sp>
-      <p:sp>
-        <p:nvSpPr>
-          <p:cNvPr id="19" name="Shape 17"/>
-          <p:cNvSpPr/>
-          <p:nvPr/>
-        </p:nvSpPr>
-        <p:spPr>
-          <a:xfrm>
-            <a:off x="914400" y="5138928"/>
-            <a:ext cx="457200" cy="457200"/>
-          </a:xfrm>
-          <a:prstGeom prst="ellipse">
-            <a:avLst/>
-          </a:prstGeom>
-          <a:solidFill>
-            <a:srgbClr val="059669"/>
-          </a:solidFill>
-          <a:ln/>
-        </p:spPr>
-      </p:sp>
-      <p:sp>
-        <p:nvSpPr>
-          <p:cNvPr id="20" name="Text 18"/>
-          <p:cNvSpPr/>
-          <p:nvPr/>
-        </p:nvSpPr>
-        <p:spPr>
-          <a:xfrm>
-            <a:off x="914400" y="5138928"/>
-            <a:ext cx="457200" cy="457200"/>
-          </a:xfrm>
-          <a:prstGeom prst="rect">
-            <a:avLst/>
-          </a:prstGeom>
-          <a:noFill/>
-          <a:ln/>
-        </p:spPr>
-        <p:txBody>
-          <a:bodyPr wrap="square" rtlCol="0" anchor="ctr"/>
-          <a:lstStyle/>
-          <a:p>
-            <a:pPr algn="ctr" indent="0" marL="0">
-              <a:buNone/>
-            </a:pPr>
-            <a:r>
-              <a:rPr lang="en-US" sz="1800" b="1" dirty="0">
-                <a:solidFill>
-                  <a:srgbClr val="FFFFFF"/>
-                </a:solidFill>
-              </a:rPr>
-              <a:t>✓</a:t>
-            </a:r>
-            <a:endParaRPr lang="en-US" sz="1800" dirty="0"/>
-          </a:p>
-        </p:txBody>
-      </p:sp>
-      <p:sp>
-        <p:nvSpPr>
-          <p:cNvPr id="21" name="Text 19"/>
-          <p:cNvSpPr/>
-          <p:nvPr/>
-        </p:nvSpPr>
-        <p:spPr>
-          <a:xfrm>
-            <a:off x="1600200" y="4855464"/>
-            <a:ext cx="4023360" cy="1024128"/>
-          </a:xfrm>
-          <a:prstGeom prst="rect">
-            <a:avLst/>
-          </a:prstGeom>
-          <a:noFill/>
-          <a:ln/>
-        </p:spPr>
-        <p:txBody>
-          <a:bodyPr wrap="square" rtlCol="0" anchor="ctr"/>
-          <a:lstStyle/>
-          <a:p>
-            <a:pPr indent="0" marL="0">
-              <a:buNone/>
-            </a:pPr>
-            <a:r>
-              <a:rPr lang="en-US" sz="1600" b="1" dirty="0">
-                <a:solidFill>
-                  <a:srgbClr val="0F172A"/>
-                </a:solidFill>
-                <a:latin typeface="Cambria" pitchFamily="34" charset="0"/>
-                <a:ea typeface="Cambria" pitchFamily="34" charset="-122"/>
-                <a:cs typeface="Cambria" pitchFamily="34" charset="-120"/>
-              </a:rPr>
-              <a:t>Re-scan in CI  ·  ziran ci</a:t>
-            </a:r>
-            <a:endParaRPr lang="en-US" sz="1600" dirty="0"/>
-          </a:p>
-        </p:txBody>
-      </p:sp>
-      <p:sp>
-        <p:nvSpPr>
-          <p:cNvPr id="22" name="Text 20"/>
-          <p:cNvSpPr/>
-          <p:nvPr/>
-        </p:nvSpPr>
-        <p:spPr>
-          <a:xfrm>
-            <a:off x="5669280" y="4855464"/>
-            <a:ext cx="5669280" cy="1024128"/>
-          </a:xfrm>
-          <a:prstGeom prst="rect">
-            <a:avLst/>
-          </a:prstGeom>
-          <a:noFill/>
-          <a:ln/>
-        </p:spPr>
-        <p:txBody>
-          <a:bodyPr wrap="square" rtlCol="0" anchor="ctr"/>
-          <a:lstStyle/>
-          <a:p>
-            <a:pPr indent="0" marL="0">
-              <a:lnSpc>
-                <a:spcPct val="105000"/>
-              </a:lnSpc>
-              <a:buNone/>
-            </a:pPr>
-            <a:r>
-              <a:rPr lang="en-US" sz="1400" dirty="0">
-                <a:solidFill>
-                  <a:srgbClr val="334155"/>
-                </a:solidFill>
-                <a:latin typeface="Arial" pitchFamily="34" charset="0"/>
-                <a:ea typeface="Arial" pitchFamily="34" charset="-122"/>
-                <a:cs typeface="Arial" pitchFamily="34" charset="-120"/>
-              </a:rPr>
-              <a:t>Fail the build when a newly-added tool completes a trifecta. Composition as a reviewable artifact.</a:t>
-            </a:r>
-            <a:endParaRPr lang="en-US" sz="1400" dirty="0"/>
+              <a:t>Split into least-privileged agents and the trifecta reassembles across them — via messages and shared memory.</a:t>
+            </a:r>
+            <a:endParaRPr lang="en-US" sz="1500" dirty="0"/>
           </a:p>
         </p:txBody>
       </p:sp>
@@ -8829,6 +8957,963 @@
 <file path=ppt/slides/slide25.xml><?xml version="1.0" encoding="utf-8"?>
 <p:sld xmlns:a="http://schemas.openxmlformats.org/drawingml/2006/main" xmlns:r="http://schemas.openxmlformats.org/officeDocument/2006/relationships" xmlns:p="http://schemas.openxmlformats.org/presentationml/2006/main">
   <p:cSld name="Slide 25">
+    <p:bg>
+      <p:bgPr>
+        <a:solidFill>
+          <a:srgbClr val="F8FAFC"/>
+        </a:solidFill>
+      </p:bgPr>
+    </p:bg>
+    <p:spTree>
+      <p:nvGrpSpPr>
+        <p:cNvPr id="1" name=""/>
+        <p:cNvGrpSpPr/>
+        <p:nvPr/>
+      </p:nvGrpSpPr>
+      <p:grpSpPr>
+        <a:xfrm>
+          <a:off x="0" y="0"/>
+          <a:ext cx="0" cy="0"/>
+          <a:chOff x="0" y="0"/>
+          <a:chExt cx="0" cy="0"/>
+        </a:xfrm>
+      </p:grpSpPr>
+      <p:sp>
+        <p:nvSpPr>
+          <p:cNvPr id="2" name="Text 0"/>
+          <p:cNvSpPr/>
+          <p:nvPr/>
+        </p:nvSpPr>
+        <p:spPr>
+          <a:xfrm>
+            <a:off x="640080" y="457200"/>
+            <a:ext cx="10972800" cy="822960"/>
+          </a:xfrm>
+          <a:prstGeom prst="rect">
+            <a:avLst/>
+          </a:prstGeom>
+          <a:noFill/>
+          <a:ln/>
+        </p:spPr>
+        <p:txBody>
+          <a:bodyPr wrap="square" rtlCol="0" anchor="ctr"/>
+          <a:lstStyle/>
+          <a:p>
+            <a:pPr indent="0" marL="0">
+              <a:buNone/>
+            </a:pPr>
+            <a:r>
+              <a:rPr lang="en-US" sz="3200" b="1" dirty="0">
+                <a:solidFill>
+                  <a:srgbClr val="0F172A"/>
+                </a:solidFill>
+                <a:latin typeface="Cambria" pitchFamily="34" charset="0"/>
+                <a:ea typeface="Cambria" pitchFamily="34" charset="-122"/>
+                <a:cs typeface="Cambria" pitchFamily="34" charset="-120"/>
+              </a:rPr>
+              <a:t>Breaking the graph — across agents</a:t>
+            </a:r>
+            <a:endParaRPr lang="en-US" sz="3200" dirty="0"/>
+          </a:p>
+        </p:txBody>
+      </p:sp>
+      <p:sp>
+        <p:nvSpPr>
+          <p:cNvPr id="3" name="Shape 1"/>
+          <p:cNvSpPr/>
+          <p:nvPr/>
+        </p:nvSpPr>
+        <p:spPr>
+          <a:xfrm>
+            <a:off x="640080" y="1371600"/>
+            <a:ext cx="10908792" cy="786384"/>
+          </a:xfrm>
+          <a:prstGeom prst="roundRect">
+            <a:avLst>
+              <a:gd name="adj" fmla="val 11628"/>
+            </a:avLst>
+          </a:prstGeom>
+          <a:solidFill>
+            <a:srgbClr val="FFFFFF"/>
+          </a:solidFill>
+          <a:ln w="12700">
+            <a:solidFill>
+              <a:srgbClr val="E2E8F0"/>
+            </a:solidFill>
+            <a:prstDash val="solid"/>
+          </a:ln>
+        </p:spPr>
+      </p:sp>
+      <p:sp>
+        <p:nvSpPr>
+          <p:cNvPr id="4" name="Shape 2"/>
+          <p:cNvSpPr/>
+          <p:nvPr/>
+        </p:nvSpPr>
+        <p:spPr>
+          <a:xfrm>
+            <a:off x="914400" y="1554480"/>
+            <a:ext cx="420624" cy="420624"/>
+          </a:xfrm>
+          <a:prstGeom prst="ellipse">
+            <a:avLst/>
+          </a:prstGeom>
+          <a:solidFill>
+            <a:srgbClr val="059669"/>
+          </a:solidFill>
+          <a:ln/>
+        </p:spPr>
+      </p:sp>
+      <p:sp>
+        <p:nvSpPr>
+          <p:cNvPr id="5" name="Text 3"/>
+          <p:cNvSpPr/>
+          <p:nvPr/>
+        </p:nvSpPr>
+        <p:spPr>
+          <a:xfrm>
+            <a:off x="914400" y="1554480"/>
+            <a:ext cx="420624" cy="420624"/>
+          </a:xfrm>
+          <a:prstGeom prst="rect">
+            <a:avLst/>
+          </a:prstGeom>
+          <a:noFill/>
+          <a:ln/>
+        </p:spPr>
+        <p:txBody>
+          <a:bodyPr wrap="square" rtlCol="0" anchor="ctr"/>
+          <a:lstStyle/>
+          <a:p>
+            <a:pPr algn="ctr" indent="0" marL="0">
+              <a:buNone/>
+            </a:pPr>
+            <a:r>
+              <a:rPr lang="en-US" sz="1700" b="1" dirty="0">
+                <a:solidFill>
+                  <a:srgbClr val="FFFFFF"/>
+                </a:solidFill>
+              </a:rPr>
+              <a:t>✓</a:t>
+            </a:r>
+            <a:endParaRPr lang="en-US" sz="1700" dirty="0"/>
+          </a:p>
+        </p:txBody>
+      </p:sp>
+      <p:sp>
+        <p:nvSpPr>
+          <p:cNvPr id="6" name="Text 4"/>
+          <p:cNvSpPr/>
+          <p:nvPr/>
+        </p:nvSpPr>
+        <p:spPr>
+          <a:xfrm>
+            <a:off x="1554480" y="1371600"/>
+            <a:ext cx="3931920" cy="786384"/>
+          </a:xfrm>
+          <a:prstGeom prst="rect">
+            <a:avLst/>
+          </a:prstGeom>
+          <a:noFill/>
+          <a:ln/>
+        </p:spPr>
+        <p:txBody>
+          <a:bodyPr wrap="square" rtlCol="0" anchor="ctr"/>
+          <a:lstStyle/>
+          <a:p>
+            <a:pPr indent="0" marL="0">
+              <a:buNone/>
+            </a:pPr>
+            <a:r>
+              <a:rPr lang="en-US" sz="1550" b="1" dirty="0">
+                <a:solidFill>
+                  <a:srgbClr val="0F172A"/>
+                </a:solidFill>
+                <a:latin typeface="Cambria" pitchFamily="34" charset="0"/>
+                <a:ea typeface="Cambria" pitchFamily="34" charset="-122"/>
+                <a:cs typeface="Cambria" pitchFamily="34" charset="-120"/>
+              </a:rPr>
+              <a:t>Constrain the topology</a:t>
+            </a:r>
+            <a:endParaRPr lang="en-US" sz="1550" dirty="0"/>
+          </a:p>
+        </p:txBody>
+      </p:sp>
+      <p:sp>
+        <p:nvSpPr>
+          <p:cNvPr id="7" name="Text 5"/>
+          <p:cNvSpPr/>
+          <p:nvPr/>
+        </p:nvSpPr>
+        <p:spPr>
+          <a:xfrm>
+            <a:off x="5577840" y="1371600"/>
+            <a:ext cx="5760720" cy="786384"/>
+          </a:xfrm>
+          <a:prstGeom prst="rect">
+            <a:avLst/>
+          </a:prstGeom>
+          <a:noFill/>
+          <a:ln/>
+        </p:spPr>
+        <p:txBody>
+          <a:bodyPr wrap="square" rtlCol="0" anchor="ctr"/>
+          <a:lstStyle/>
+          <a:p>
+            <a:pPr indent="0" marL="0">
+              <a:lnSpc>
+                <a:spcPct val="103000"/>
+              </a:lnSpc>
+              <a:buNone/>
+            </a:pPr>
+            <a:r>
+              <a:rPr lang="en-US" sz="1350" dirty="0">
+                <a:solidFill>
+                  <a:srgbClr val="334155"/>
+                </a:solidFill>
+                <a:latin typeface="Arial" pitchFamily="34" charset="0"/>
+                <a:ea typeface="Arial" pitchFamily="34" charset="-122"/>
+                <a:cs typeface="Arial" pitchFamily="34" charset="-120"/>
+              </a:rPr>
+              <a:t>Allowlist which agent may talk to which — not a full mesh. A private-reading agent should have no path to an external-sending one.</a:t>
+            </a:r>
+            <a:endParaRPr lang="en-US" sz="1350" dirty="0"/>
+          </a:p>
+        </p:txBody>
+      </p:sp>
+      <p:sp>
+        <p:nvSpPr>
+          <p:cNvPr id="8" name="Shape 6"/>
+          <p:cNvSpPr/>
+          <p:nvPr/>
+        </p:nvSpPr>
+        <p:spPr>
+          <a:xfrm>
+            <a:off x="640080" y="2240280"/>
+            <a:ext cx="10908792" cy="786384"/>
+          </a:xfrm>
+          <a:prstGeom prst="roundRect">
+            <a:avLst>
+              <a:gd name="adj" fmla="val 11628"/>
+            </a:avLst>
+          </a:prstGeom>
+          <a:solidFill>
+            <a:srgbClr val="FFFFFF"/>
+          </a:solidFill>
+          <a:ln w="12700">
+            <a:solidFill>
+              <a:srgbClr val="E2E8F0"/>
+            </a:solidFill>
+            <a:prstDash val="solid"/>
+          </a:ln>
+        </p:spPr>
+      </p:sp>
+      <p:sp>
+        <p:nvSpPr>
+          <p:cNvPr id="9" name="Shape 7"/>
+          <p:cNvSpPr/>
+          <p:nvPr/>
+        </p:nvSpPr>
+        <p:spPr>
+          <a:xfrm>
+            <a:off x="914400" y="2423160"/>
+            <a:ext cx="420624" cy="420624"/>
+          </a:xfrm>
+          <a:prstGeom prst="ellipse">
+            <a:avLst/>
+          </a:prstGeom>
+          <a:solidFill>
+            <a:srgbClr val="059669"/>
+          </a:solidFill>
+          <a:ln/>
+        </p:spPr>
+      </p:sp>
+      <p:sp>
+        <p:nvSpPr>
+          <p:cNvPr id="10" name="Text 8"/>
+          <p:cNvSpPr/>
+          <p:nvPr/>
+        </p:nvSpPr>
+        <p:spPr>
+          <a:xfrm>
+            <a:off x="914400" y="2423160"/>
+            <a:ext cx="420624" cy="420624"/>
+          </a:xfrm>
+          <a:prstGeom prst="rect">
+            <a:avLst/>
+          </a:prstGeom>
+          <a:noFill/>
+          <a:ln/>
+        </p:spPr>
+        <p:txBody>
+          <a:bodyPr wrap="square" rtlCol="0" anchor="ctr"/>
+          <a:lstStyle/>
+          <a:p>
+            <a:pPr algn="ctr" indent="0" marL="0">
+              <a:buNone/>
+            </a:pPr>
+            <a:r>
+              <a:rPr lang="en-US" sz="1700" b="1" dirty="0">
+                <a:solidFill>
+                  <a:srgbClr val="FFFFFF"/>
+                </a:solidFill>
+              </a:rPr>
+              <a:t>✓</a:t>
+            </a:r>
+            <a:endParaRPr lang="en-US" sz="1700" dirty="0"/>
+          </a:p>
+        </p:txBody>
+      </p:sp>
+      <p:sp>
+        <p:nvSpPr>
+          <p:cNvPr id="11" name="Text 9"/>
+          <p:cNvSpPr/>
+          <p:nvPr/>
+        </p:nvSpPr>
+        <p:spPr>
+          <a:xfrm>
+            <a:off x="1554480" y="2240280"/>
+            <a:ext cx="3931920" cy="786384"/>
+          </a:xfrm>
+          <a:prstGeom prst="rect">
+            <a:avLst/>
+          </a:prstGeom>
+          <a:noFill/>
+          <a:ln/>
+        </p:spPr>
+        <p:txBody>
+          <a:bodyPr wrap="square" rtlCol="0" anchor="ctr"/>
+          <a:lstStyle/>
+          <a:p>
+            <a:pPr indent="0" marL="0">
+              <a:buNone/>
+            </a:pPr>
+            <a:r>
+              <a:rPr lang="en-US" sz="1550" b="1" dirty="0">
+                <a:solidFill>
+                  <a:srgbClr val="0F172A"/>
+                </a:solidFill>
+                <a:latin typeface="Cambria" pitchFamily="34" charset="0"/>
+                <a:ea typeface="Cambria" pitchFamily="34" charset="-122"/>
+                <a:cs typeface="Cambria" pitchFamily="34" charset="-120"/>
+              </a:rPr>
+              <a:t>Provenance / taint on the bus</a:t>
+            </a:r>
+            <a:endParaRPr lang="en-US" sz="1550" dirty="0"/>
+          </a:p>
+        </p:txBody>
+      </p:sp>
+      <p:sp>
+        <p:nvSpPr>
+          <p:cNvPr id="12" name="Text 10"/>
+          <p:cNvSpPr/>
+          <p:nvPr/>
+        </p:nvSpPr>
+        <p:spPr>
+          <a:xfrm>
+            <a:off x="5577840" y="2240280"/>
+            <a:ext cx="5760720" cy="786384"/>
+          </a:xfrm>
+          <a:prstGeom prst="rect">
+            <a:avLst/>
+          </a:prstGeom>
+          <a:noFill/>
+          <a:ln/>
+        </p:spPr>
+        <p:txBody>
+          <a:bodyPr wrap="square" rtlCol="0" anchor="ctr"/>
+          <a:lstStyle/>
+          <a:p>
+            <a:pPr indent="0" marL="0">
+              <a:lnSpc>
+                <a:spcPct val="103000"/>
+              </a:lnSpc>
+              <a:buNone/>
+            </a:pPr>
+            <a:r>
+              <a:rPr lang="en-US" sz="1350" dirty="0">
+                <a:solidFill>
+                  <a:srgbClr val="334155"/>
+                </a:solidFill>
+                <a:latin typeface="Arial" pitchFamily="34" charset="0"/>
+                <a:ea typeface="Arial" pitchFamily="34" charset="-122"/>
+                <a:cs typeface="Arial" pitchFamily="34" charset="-120"/>
+              </a:rPr>
+              <a:t>Carry taint across agent-to-agent messages; enforce at agent boundaries — the trifecta gate moves up to the orchestrator.</a:t>
+            </a:r>
+            <a:endParaRPr lang="en-US" sz="1350" dirty="0"/>
+          </a:p>
+        </p:txBody>
+      </p:sp>
+      <p:sp>
+        <p:nvSpPr>
+          <p:cNvPr id="13" name="Shape 11"/>
+          <p:cNvSpPr/>
+          <p:nvPr/>
+        </p:nvSpPr>
+        <p:spPr>
+          <a:xfrm>
+            <a:off x="640080" y="3108960"/>
+            <a:ext cx="10908792" cy="786384"/>
+          </a:xfrm>
+          <a:prstGeom prst="roundRect">
+            <a:avLst>
+              <a:gd name="adj" fmla="val 11628"/>
+            </a:avLst>
+          </a:prstGeom>
+          <a:solidFill>
+            <a:srgbClr val="FFFFFF"/>
+          </a:solidFill>
+          <a:ln w="12700">
+            <a:solidFill>
+              <a:srgbClr val="E2E8F0"/>
+            </a:solidFill>
+            <a:prstDash val="solid"/>
+          </a:ln>
+        </p:spPr>
+      </p:sp>
+      <p:sp>
+        <p:nvSpPr>
+          <p:cNvPr id="14" name="Shape 12"/>
+          <p:cNvSpPr/>
+          <p:nvPr/>
+        </p:nvSpPr>
+        <p:spPr>
+          <a:xfrm>
+            <a:off x="914400" y="3291840"/>
+            <a:ext cx="420624" cy="420624"/>
+          </a:xfrm>
+          <a:prstGeom prst="ellipse">
+            <a:avLst/>
+          </a:prstGeom>
+          <a:solidFill>
+            <a:srgbClr val="059669"/>
+          </a:solidFill>
+          <a:ln/>
+        </p:spPr>
+      </p:sp>
+      <p:sp>
+        <p:nvSpPr>
+          <p:cNvPr id="15" name="Text 13"/>
+          <p:cNvSpPr/>
+          <p:nvPr/>
+        </p:nvSpPr>
+        <p:spPr>
+          <a:xfrm>
+            <a:off x="914400" y="3291840"/>
+            <a:ext cx="420624" cy="420624"/>
+          </a:xfrm>
+          <a:prstGeom prst="rect">
+            <a:avLst/>
+          </a:prstGeom>
+          <a:noFill/>
+          <a:ln/>
+        </p:spPr>
+        <p:txBody>
+          <a:bodyPr wrap="square" rtlCol="0" anchor="ctr"/>
+          <a:lstStyle/>
+          <a:p>
+            <a:pPr algn="ctr" indent="0" marL="0">
+              <a:buNone/>
+            </a:pPr>
+            <a:r>
+              <a:rPr lang="en-US" sz="1700" b="1" dirty="0">
+                <a:solidFill>
+                  <a:srgbClr val="FFFFFF"/>
+                </a:solidFill>
+              </a:rPr>
+              <a:t>✓</a:t>
+            </a:r>
+            <a:endParaRPr lang="en-US" sz="1700" dirty="0"/>
+          </a:p>
+        </p:txBody>
+      </p:sp>
+      <p:sp>
+        <p:nvSpPr>
+          <p:cNvPr id="16" name="Text 14"/>
+          <p:cNvSpPr/>
+          <p:nvPr/>
+        </p:nvSpPr>
+        <p:spPr>
+          <a:xfrm>
+            <a:off x="1554480" y="3108960"/>
+            <a:ext cx="3931920" cy="786384"/>
+          </a:xfrm>
+          <a:prstGeom prst="rect">
+            <a:avLst/>
+          </a:prstGeom>
+          <a:noFill/>
+          <a:ln/>
+        </p:spPr>
+        <p:txBody>
+          <a:bodyPr wrap="square" rtlCol="0" anchor="ctr"/>
+          <a:lstStyle/>
+          <a:p>
+            <a:pPr indent="0" marL="0">
+              <a:buNone/>
+            </a:pPr>
+            <a:r>
+              <a:rPr lang="en-US" sz="1550" b="1" dirty="0">
+                <a:solidFill>
+                  <a:srgbClr val="0F172A"/>
+                </a:solidFill>
+                <a:latin typeface="Cambria" pitchFamily="34" charset="0"/>
+                <a:ea typeface="Cambria" pitchFamily="34" charset="-122"/>
+                <a:cs typeface="Cambria" pitchFamily="34" charset="-120"/>
+              </a:rPr>
+              <a:t>Quarantine untrusted-facing agents</a:t>
+            </a:r>
+            <a:endParaRPr lang="en-US" sz="1550" dirty="0"/>
+          </a:p>
+        </p:txBody>
+      </p:sp>
+      <p:sp>
+        <p:nvSpPr>
+          <p:cNvPr id="17" name="Text 15"/>
+          <p:cNvSpPr/>
+          <p:nvPr/>
+        </p:nvSpPr>
+        <p:spPr>
+          <a:xfrm>
+            <a:off x="5577840" y="3108960"/>
+            <a:ext cx="5760720" cy="786384"/>
+          </a:xfrm>
+          <a:prstGeom prst="rect">
+            <a:avLst/>
+          </a:prstGeom>
+          <a:noFill/>
+          <a:ln/>
+        </p:spPr>
+        <p:txBody>
+          <a:bodyPr wrap="square" rtlCol="0" anchor="ctr"/>
+          <a:lstStyle/>
+          <a:p>
+            <a:pPr indent="0" marL="0">
+              <a:lnSpc>
+                <a:spcPct val="103000"/>
+              </a:lnSpc>
+              <a:buNone/>
+            </a:pPr>
+            <a:r>
+              <a:rPr lang="en-US" sz="1350" dirty="0">
+                <a:solidFill>
+                  <a:srgbClr val="334155"/>
+                </a:solidFill>
+                <a:latin typeface="Arial" pitchFamily="34" charset="0"/>
+                <a:ea typeface="Arial" pitchFamily="34" charset="-122"/>
+                <a:cs typeface="Arial" pitchFamily="34" charset="-120"/>
+              </a:rPr>
+              <a:t>The agent touching untrusted content emits only structured, constrained output — never free-form instructions to privileged agents (dual-LLM).</a:t>
+            </a:r>
+            <a:endParaRPr lang="en-US" sz="1350" dirty="0"/>
+          </a:p>
+        </p:txBody>
+      </p:sp>
+      <p:sp>
+        <p:nvSpPr>
+          <p:cNvPr id="18" name="Shape 16"/>
+          <p:cNvSpPr/>
+          <p:nvPr/>
+        </p:nvSpPr>
+        <p:spPr>
+          <a:xfrm>
+            <a:off x="640080" y="3977640"/>
+            <a:ext cx="10908792" cy="786384"/>
+          </a:xfrm>
+          <a:prstGeom prst="roundRect">
+            <a:avLst>
+              <a:gd name="adj" fmla="val 11628"/>
+            </a:avLst>
+          </a:prstGeom>
+          <a:solidFill>
+            <a:srgbClr val="FFFFFF"/>
+          </a:solidFill>
+          <a:ln w="12700">
+            <a:solidFill>
+              <a:srgbClr val="E2E8F0"/>
+            </a:solidFill>
+            <a:prstDash val="solid"/>
+          </a:ln>
+        </p:spPr>
+      </p:sp>
+      <p:sp>
+        <p:nvSpPr>
+          <p:cNvPr id="19" name="Shape 17"/>
+          <p:cNvSpPr/>
+          <p:nvPr/>
+        </p:nvSpPr>
+        <p:spPr>
+          <a:xfrm>
+            <a:off x="914400" y="4160520"/>
+            <a:ext cx="420624" cy="420624"/>
+          </a:xfrm>
+          <a:prstGeom prst="ellipse">
+            <a:avLst/>
+          </a:prstGeom>
+          <a:solidFill>
+            <a:srgbClr val="059669"/>
+          </a:solidFill>
+          <a:ln/>
+        </p:spPr>
+      </p:sp>
+      <p:sp>
+        <p:nvSpPr>
+          <p:cNvPr id="20" name="Text 18"/>
+          <p:cNvSpPr/>
+          <p:nvPr/>
+        </p:nvSpPr>
+        <p:spPr>
+          <a:xfrm>
+            <a:off x="914400" y="4160520"/>
+            <a:ext cx="420624" cy="420624"/>
+          </a:xfrm>
+          <a:prstGeom prst="rect">
+            <a:avLst/>
+          </a:prstGeom>
+          <a:noFill/>
+          <a:ln/>
+        </p:spPr>
+        <p:txBody>
+          <a:bodyPr wrap="square" rtlCol="0" anchor="ctr"/>
+          <a:lstStyle/>
+          <a:p>
+            <a:pPr algn="ctr" indent="0" marL="0">
+              <a:buNone/>
+            </a:pPr>
+            <a:r>
+              <a:rPr lang="en-US" sz="1700" b="1" dirty="0">
+                <a:solidFill>
+                  <a:srgbClr val="FFFFFF"/>
+                </a:solidFill>
+              </a:rPr>
+              <a:t>✓</a:t>
+            </a:r>
+            <a:endParaRPr lang="en-US" sz="1700" dirty="0"/>
+          </a:p>
+        </p:txBody>
+      </p:sp>
+      <p:sp>
+        <p:nvSpPr>
+          <p:cNvPr id="21" name="Text 19"/>
+          <p:cNvSpPr/>
+          <p:nvPr/>
+        </p:nvSpPr>
+        <p:spPr>
+          <a:xfrm>
+            <a:off x="1554480" y="3977640"/>
+            <a:ext cx="3931920" cy="786384"/>
+          </a:xfrm>
+          <a:prstGeom prst="rect">
+            <a:avLst/>
+          </a:prstGeom>
+          <a:noFill/>
+          <a:ln/>
+        </p:spPr>
+        <p:txBody>
+          <a:bodyPr wrap="square" rtlCol="0" anchor="ctr"/>
+          <a:lstStyle/>
+          <a:p>
+            <a:pPr indent="0" marL="0">
+              <a:buNone/>
+            </a:pPr>
+            <a:r>
+              <a:rPr lang="en-US" sz="1550" b="1" dirty="0">
+                <a:solidFill>
+                  <a:srgbClr val="0F172A"/>
+                </a:solidFill>
+                <a:latin typeface="Cambria" pitchFamily="34" charset="0"/>
+                <a:ea typeface="Cambria" pitchFamily="34" charset="-122"/>
+                <a:cs typeface="Cambria" pitchFamily="34" charset="-120"/>
+              </a:rPr>
+              <a:t>One gate at the closure point</a:t>
+            </a:r>
+            <a:endParaRPr lang="en-US" sz="1550" dirty="0"/>
+          </a:p>
+        </p:txBody>
+      </p:sp>
+      <p:sp>
+        <p:nvSpPr>
+          <p:cNvPr id="22" name="Text 20"/>
+          <p:cNvSpPr/>
+          <p:nvPr/>
+        </p:nvSpPr>
+        <p:spPr>
+          <a:xfrm>
+            <a:off x="5577840" y="3977640"/>
+            <a:ext cx="5760720" cy="786384"/>
+          </a:xfrm>
+          <a:prstGeom prst="rect">
+            <a:avLst/>
+          </a:prstGeom>
+          <a:noFill/>
+          <a:ln/>
+        </p:spPr>
+        <p:txBody>
+          <a:bodyPr wrap="square" rtlCol="0" anchor="ctr"/>
+          <a:lstStyle/>
+          <a:p>
+            <a:pPr indent="0" marL="0">
+              <a:lnSpc>
+                <a:spcPct val="103000"/>
+              </a:lnSpc>
+              <a:buNone/>
+            </a:pPr>
+            <a:r>
+              <a:rPr lang="en-US" sz="1350" dirty="0">
+                <a:solidFill>
+                  <a:srgbClr val="334155"/>
+                </a:solidFill>
+                <a:latin typeface="Arial" pitchFamily="34" charset="0"/>
+                <a:ea typeface="Arial" pitchFamily="34" charset="-122"/>
+                <a:cs typeface="Arial" pitchFamily="34" charset="-120"/>
+              </a:rPr>
+              <a:t>A human or deterministic check where a private + untrusted flow could reach an external sink.</a:t>
+            </a:r>
+            <a:endParaRPr lang="en-US" sz="1350" dirty="0"/>
+          </a:p>
+        </p:txBody>
+      </p:sp>
+      <p:sp>
+        <p:nvSpPr>
+          <p:cNvPr id="23" name="Shape 21"/>
+          <p:cNvSpPr/>
+          <p:nvPr/>
+        </p:nvSpPr>
+        <p:spPr>
+          <a:xfrm>
+            <a:off x="640080" y="4846320"/>
+            <a:ext cx="10908792" cy="786384"/>
+          </a:xfrm>
+          <a:prstGeom prst="roundRect">
+            <a:avLst>
+              <a:gd name="adj" fmla="val 11628"/>
+            </a:avLst>
+          </a:prstGeom>
+          <a:solidFill>
+            <a:srgbClr val="FFFFFF"/>
+          </a:solidFill>
+          <a:ln w="12700">
+            <a:solidFill>
+              <a:srgbClr val="E2E8F0"/>
+            </a:solidFill>
+            <a:prstDash val="solid"/>
+          </a:ln>
+        </p:spPr>
+      </p:sp>
+      <p:sp>
+        <p:nvSpPr>
+          <p:cNvPr id="24" name="Shape 22"/>
+          <p:cNvSpPr/>
+          <p:nvPr/>
+        </p:nvSpPr>
+        <p:spPr>
+          <a:xfrm>
+            <a:off x="914400" y="5029200"/>
+            <a:ext cx="420624" cy="420624"/>
+          </a:xfrm>
+          <a:prstGeom prst="ellipse">
+            <a:avLst/>
+          </a:prstGeom>
+          <a:solidFill>
+            <a:srgbClr val="059669"/>
+          </a:solidFill>
+          <a:ln/>
+        </p:spPr>
+      </p:sp>
+      <p:sp>
+        <p:nvSpPr>
+          <p:cNvPr id="25" name="Text 23"/>
+          <p:cNvSpPr/>
+          <p:nvPr/>
+        </p:nvSpPr>
+        <p:spPr>
+          <a:xfrm>
+            <a:off x="914400" y="5029200"/>
+            <a:ext cx="420624" cy="420624"/>
+          </a:xfrm>
+          <a:prstGeom prst="rect">
+            <a:avLst/>
+          </a:prstGeom>
+          <a:noFill/>
+          <a:ln/>
+        </p:spPr>
+        <p:txBody>
+          <a:bodyPr wrap="square" rtlCol="0" anchor="ctr"/>
+          <a:lstStyle/>
+          <a:p>
+            <a:pPr algn="ctr" indent="0" marL="0">
+              <a:buNone/>
+            </a:pPr>
+            <a:r>
+              <a:rPr lang="en-US" sz="1700" b="1" dirty="0">
+                <a:solidFill>
+                  <a:srgbClr val="FFFFFF"/>
+                </a:solidFill>
+              </a:rPr>
+              <a:t>✓</a:t>
+            </a:r>
+            <a:endParaRPr lang="en-US" sz="1700" dirty="0"/>
+          </a:p>
+        </p:txBody>
+      </p:sp>
+      <p:sp>
+        <p:nvSpPr>
+          <p:cNvPr id="26" name="Text 24"/>
+          <p:cNvSpPr/>
+          <p:nvPr/>
+        </p:nvSpPr>
+        <p:spPr>
+          <a:xfrm>
+            <a:off x="1554480" y="4846320"/>
+            <a:ext cx="3931920" cy="786384"/>
+          </a:xfrm>
+          <a:prstGeom prst="rect">
+            <a:avLst/>
+          </a:prstGeom>
+          <a:noFill/>
+          <a:ln/>
+        </p:spPr>
+        <p:txBody>
+          <a:bodyPr wrap="square" rtlCol="0" anchor="ctr"/>
+          <a:lstStyle/>
+          <a:p>
+            <a:pPr indent="0" marL="0">
+              <a:buNone/>
+            </a:pPr>
+            <a:r>
+              <a:rPr lang="en-US" sz="1550" b="1" dirty="0">
+                <a:solidFill>
+                  <a:srgbClr val="0F172A"/>
+                </a:solidFill>
+                <a:latin typeface="Cambria" pitchFamily="34" charset="0"/>
+                <a:ea typeface="Cambria" pitchFamily="34" charset="-122"/>
+                <a:cs typeface="Cambria" pitchFamily="34" charset="-120"/>
+              </a:rPr>
+              <a:t>Re-scan the whole system graph</a:t>
+            </a:r>
+            <a:endParaRPr lang="en-US" sz="1550" dirty="0"/>
+          </a:p>
+        </p:txBody>
+      </p:sp>
+      <p:sp>
+        <p:nvSpPr>
+          <p:cNvPr id="27" name="Text 25"/>
+          <p:cNvSpPr/>
+          <p:nvPr/>
+        </p:nvSpPr>
+        <p:spPr>
+          <a:xfrm>
+            <a:off x="5577840" y="4846320"/>
+            <a:ext cx="5760720" cy="786384"/>
+          </a:xfrm>
+          <a:prstGeom prst="rect">
+            <a:avLst/>
+          </a:prstGeom>
+          <a:noFill/>
+          <a:ln/>
+        </p:spPr>
+        <p:txBody>
+          <a:bodyPr wrap="square" rtlCol="0" anchor="ctr"/>
+          <a:lstStyle/>
+          <a:p>
+            <a:pPr indent="0" marL="0">
+              <a:lnSpc>
+                <a:spcPct val="103000"/>
+              </a:lnSpc>
+              <a:buNone/>
+            </a:pPr>
+            <a:r>
+              <a:rPr lang="en-US" sz="1350" dirty="0">
+                <a:solidFill>
+                  <a:srgbClr val="334155"/>
+                </a:solidFill>
+                <a:latin typeface="Arial" pitchFamily="34" charset="0"/>
+                <a:ea typeface="Arial" pitchFamily="34" charset="-122"/>
+                <a:cs typeface="Arial" pitchFamily="34" charset="-120"/>
+              </a:rPr>
+              <a:t>A new sub-agent or inter-agent edge can complete a cross-agent trifecta — Ziran in CI fails that build.</a:t>
+            </a:r>
+            <a:endParaRPr lang="en-US" sz="1350" dirty="0"/>
+          </a:p>
+        </p:txBody>
+      </p:sp>
+      <p:sp>
+        <p:nvSpPr>
+          <p:cNvPr id="28" name="Shape 26"/>
+          <p:cNvSpPr/>
+          <p:nvPr/>
+        </p:nvSpPr>
+        <p:spPr>
+          <a:xfrm>
+            <a:off x="640080" y="5724144"/>
+            <a:ext cx="10908792" cy="603504"/>
+          </a:xfrm>
+          <a:prstGeom prst="roundRect">
+            <a:avLst>
+              <a:gd name="adj" fmla="val 15152"/>
+            </a:avLst>
+          </a:prstGeom>
+          <a:solidFill>
+            <a:srgbClr val="EEF2FF"/>
+          </a:solidFill>
+          <a:ln w="12700">
+            <a:solidFill>
+              <a:srgbClr val="4338CA"/>
+            </a:solidFill>
+            <a:prstDash val="solid"/>
+          </a:ln>
+        </p:spPr>
+      </p:sp>
+      <p:sp>
+        <p:nvSpPr>
+          <p:cNvPr id="29" name="Text 27"/>
+          <p:cNvSpPr/>
+          <p:nvPr/>
+        </p:nvSpPr>
+        <p:spPr>
+          <a:xfrm>
+            <a:off x="822960" y="5724144"/>
+            <a:ext cx="10515600" cy="603504"/>
+          </a:xfrm>
+          <a:prstGeom prst="rect">
+            <a:avLst/>
+          </a:prstGeom>
+          <a:noFill/>
+          <a:ln/>
+        </p:spPr>
+        <p:txBody>
+          <a:bodyPr wrap="square" rtlCol="0" anchor="ctr"/>
+          <a:lstStyle/>
+          <a:p>
+            <a:pPr algn="ctr" indent="0" marL="0">
+              <a:buNone/>
+            </a:pPr>
+            <a:r>
+              <a:rPr lang="en-US" sz="1500" b="1" dirty="0">
+                <a:solidFill>
+                  <a:srgbClr val="4338CA"/>
+                </a:solidFill>
+                <a:latin typeface="Cambria" pitchFamily="34" charset="0"/>
+                <a:ea typeface="Cambria" pitchFamily="34" charset="-122"/>
+                <a:cs typeface="Cambria" pitchFamily="34" charset="-120"/>
+              </a:rPr>
+              <a:t>The same lesson, one level up: no single tool was dangerous — and no single agent is either. The risk lives in how they connect.</a:t>
+            </a:r>
+            <a:endParaRPr lang="en-US" sz="1500" dirty="0"/>
+          </a:p>
+        </p:txBody>
+      </p:sp>
+    </p:spTree>
+  </p:cSld>
+  <p:clrMapOvr>
+    <a:masterClrMapping/>
+  </p:clrMapOvr>
+</p:sld>
+</file>
+
+<file path=ppt/slides/slide26.xml><?xml version="1.0" encoding="utf-8"?>
+<p:sld xmlns:a="http://schemas.openxmlformats.org/drawingml/2006/main" xmlns:r="http://schemas.openxmlformats.org/officeDocument/2006/relationships" xmlns:p="http://schemas.openxmlformats.org/presentationml/2006/main">
+  <p:cSld name="Slide 26">
     <p:bg>
       <p:bgPr>
         <a:solidFill>
@@ -8962,9 +10047,9 @@
 </p:sld>
 </file>
 
-<file path=ppt/slides/slide26.xml><?xml version="1.0" encoding="utf-8"?>
+<file path=ppt/slides/slide27.xml><?xml version="1.0" encoding="utf-8"?>
 <p:sld xmlns:a="http://schemas.openxmlformats.org/drawingml/2006/main" xmlns:r="http://schemas.openxmlformats.org/officeDocument/2006/relationships" xmlns:p="http://schemas.openxmlformats.org/presentationml/2006/main">
-  <p:cSld name="Slide 26">
+  <p:cSld name="Slide 27">
     <p:bg>
       <p:bgPr>
         <a:solidFill>
@@ -9193,7 +10278,7 @@
                 <a:ea typeface="Cambria" pitchFamily="34" charset="-122"/>
                 <a:cs typeface="Cambria" pitchFamily="34" charset="-120"/>
               </a:rPr>
-              <a:t>ZIRAN
+              <a:t>Ziran
 </a:t>
             </a:r>
             <a:pPr indent="0" marL="0">
@@ -9229,7 +10314,7 @@
                 <a:ea typeface="Arial" pitchFamily="34" charset="-122"/>
                 <a:cs typeface="Arial" pitchFamily="34" charset="-120"/>
               </a:rPr>
-              <a:t>The finder — composition analysis for AI agents.</a:t>
+              <a:t>Open-source — the composition analysis used in this demo.</a:t>
             </a:r>
             <a:endParaRPr lang="en-US" sz="2000" dirty="0"/>
           </a:p>
@@ -10304,7 +11389,7 @@
                 <a:ea typeface="Arial" pitchFamily="34" charset="-122"/>
                 <a:cs typeface="Arial" pitchFamily="34" charset="-120"/>
               </a:rPr>
-              <a:t>This is graph traversal — done by hand. ZIRAN does it automatically.</a:t>
+              <a:t>This is graph traversal — done by hand. Ziran does it automatically.</a:t>
             </a:r>
             <a:endParaRPr lang="en-US" sz="1700" dirty="0"/>
           </a:p>

</xml_diff>

<commit_message>
fix(demo): detect Ziran via a fresh subprocess; add resources QR codes
- demo.py: a runtime 'pip install ziran' is invisible to the already-running
  process, so 'scan' reported Ziran missing right after installing it. Probe
  with a child interpreter (reads site-packages fresh) instead of importing
  in-process. Also 'ZIRAN' -> 'Ziran' in CLI text.
- talk: add scan-able QR codes (segno) for the Quanta and Ziran repos on the
  'Try it yourself' slide so people don't have to type the URLs.
</commit_message>
<xml_diff>
--- a/talk/quanta-talk.pptx
+++ b/talk/quanta-talk.pptx
@@ -2213,7 +2213,7 @@
           <a:p>
             <a:r>
               <a:rPr lang="en-US" dirty="0"/>
-              <a:t>Links: github.com/taoq-ai/quanta (the demo agent — education only, intentionally composable; run scripts/exploit_demo.py), github.com/taoq-ai/ziran (the finder). Note Quanta is deliberately vulnerable by design; don't deploy it for real. Take Q&amp;A.</a:t>
+              <a:t>Two repos, two QR codes — scan instead of typing: github.com/taoq-ai/quanta (the demo agent — education only, intentionally composable; run python scripts/demo.py) and github.com/taoq-ai/ziran (the open-source composition analysis). Note Quanta is deliberately vulnerable by design; don't deploy it for real. Take Q&amp;A.</a:t>
             </a:r>
             <a:endParaRPr lang="en-US" dirty="0"/>
           </a:p>
@@ -10146,7 +10146,7 @@
         <p:spPr>
           <a:xfrm>
             <a:off x="960120" y="1783080"/>
-            <a:ext cx="4754880" cy="1645920"/>
+            <a:ext cx="3246120" cy="1737360"/>
           </a:xfrm>
           <a:prstGeom prst="rect">
             <a:avLst/>
@@ -10183,7 +10183,7 @@
               <a:buNone/>
             </a:pPr>
             <a:r>
-              <a:rPr lang="en-US" sz="1500" dirty="0">
+              <a:rPr lang="en-US" sz="1300" dirty="0">
                 <a:solidFill>
                   <a:srgbClr val="334155"/>
                 </a:solidFill>
@@ -10201,7 +10201,7 @@
               <a:buNone/>
             </a:pPr>
             <a:r>
-              <a:rPr lang="en-US" sz="1500" dirty="0">
+              <a:rPr lang="en-US" sz="1400" dirty="0">
                 <a:solidFill>
                   <a:srgbClr val="334155"/>
                 </a:solidFill>
@@ -10209,7 +10209,7 @@
                 <a:ea typeface="Arial" pitchFamily="34" charset="-122"/>
                 <a:cs typeface="Arial" pitchFamily="34" charset="-120"/>
               </a:rPr>
-              <a:t>The demo agent — defensible architecture, one composition finding. Run python scripts/demo.py yourself.</a:t>
+              <a:t>The demo agent — defensible architecture, one composition finding.</a:t>
             </a:r>
             <a:endParaRPr lang="en-US" sz="2000" dirty="0"/>
           </a:p>
@@ -10218,6 +10218,91 @@
       <p:sp>
         <p:nvSpPr>
           <p:cNvPr id="5" name="Shape 3"/>
+          <p:cNvSpPr/>
+          <p:nvPr/>
+        </p:nvSpPr>
+        <p:spPr>
+          <a:xfrm>
+            <a:off x="4370832" y="1783080"/>
+            <a:ext cx="1463040" cy="1463040"/>
+          </a:xfrm>
+          <a:prstGeom prst="roundRect">
+            <a:avLst>
+              <a:gd name="adj" fmla="val 3750"/>
+            </a:avLst>
+          </a:prstGeom>
+          <a:solidFill>
+            <a:srgbClr val="FFFFFF"/>
+          </a:solidFill>
+          <a:ln/>
+        </p:spPr>
+      </p:sp>
+      <p:pic>
+        <p:nvPicPr>
+          <p:cNvPr id="6" name="Image 0" descr="/Users/leone.lage.perdigao/github/quanta/talk/assets/qr_quanta.png">    </p:cNvPr>
+          <p:cNvPicPr>
+            <a:picLocks noChangeAspect="1"/>
+          </p:cNvPicPr>
+          <p:nvPr/>
+        </p:nvPicPr>
+        <p:blipFill>
+          <a:blip r:embed="rId1"/>
+          <a:stretch>
+            <a:fillRect/>
+          </a:stretch>
+        </p:blipFill>
+        <p:spPr>
+          <a:xfrm>
+            <a:off x="4462272" y="1874520"/>
+            <a:ext cx="1280160" cy="1280160"/>
+          </a:xfrm>
+          <a:prstGeom prst="rect">
+            <a:avLst/>
+          </a:prstGeom>
+        </p:spPr>
+      </p:pic>
+      <p:sp>
+        <p:nvSpPr>
+          <p:cNvPr id="7" name="Text 4"/>
+          <p:cNvSpPr/>
+          <p:nvPr/>
+        </p:nvSpPr>
+        <p:spPr>
+          <a:xfrm>
+            <a:off x="4370832" y="3246120"/>
+            <a:ext cx="1463040" cy="274320"/>
+          </a:xfrm>
+          <a:prstGeom prst="rect">
+            <a:avLst/>
+          </a:prstGeom>
+          <a:noFill/>
+          <a:ln/>
+        </p:spPr>
+        <p:txBody>
+          <a:bodyPr wrap="square" rtlCol="0" anchor="ctr"/>
+          <a:lstStyle/>
+          <a:p>
+            <a:pPr algn="ctr" indent="0" marL="0">
+              <a:buNone/>
+            </a:pPr>
+            <a:r>
+              <a:rPr lang="en-US" sz="1000" dirty="0">
+                <a:solidFill>
+                  <a:srgbClr val="64748B"/>
+                </a:solidFill>
+                <a:latin typeface="Arial" pitchFamily="34" charset="0"/>
+                <a:ea typeface="Arial" pitchFamily="34" charset="-122"/>
+                <a:cs typeface="Arial" pitchFamily="34" charset="-120"/>
+              </a:rPr>
+              <a:t>scan to open</a:t>
+            </a:r>
+            <a:endParaRPr lang="en-US" sz="1000" dirty="0"/>
+          </a:p>
+        </p:txBody>
+      </p:sp>
+      <p:sp>
+        <p:nvSpPr>
+          <p:cNvPr id="8" name="Shape 5"/>
           <p:cNvSpPr/>
           <p:nvPr/>
         </p:nvSpPr>
@@ -10244,14 +10329,14 @@
       </p:sp>
       <p:sp>
         <p:nvSpPr>
-          <p:cNvPr id="6" name="Text 4"/>
+          <p:cNvPr id="9" name="Text 6"/>
           <p:cNvSpPr/>
           <p:nvPr/>
         </p:nvSpPr>
         <p:spPr>
           <a:xfrm>
             <a:off x="6519672" y="1783080"/>
-            <a:ext cx="4754880" cy="1645920"/>
+            <a:ext cx="3246120" cy="1737360"/>
           </a:xfrm>
           <a:prstGeom prst="rect">
             <a:avLst/>
@@ -10288,7 +10373,7 @@
               <a:buNone/>
             </a:pPr>
             <a:r>
-              <a:rPr lang="en-US" sz="1500" dirty="0">
+              <a:rPr lang="en-US" sz="1300" dirty="0">
                 <a:solidFill>
                   <a:srgbClr val="334155"/>
                 </a:solidFill>
@@ -10306,7 +10391,7 @@
               <a:buNone/>
             </a:pPr>
             <a:r>
-              <a:rPr lang="en-US" sz="1500" dirty="0">
+              <a:rPr lang="en-US" sz="1400" dirty="0">
                 <a:solidFill>
                   <a:srgbClr val="334155"/>
                 </a:solidFill>
@@ -10314,7 +10399,7 @@
                 <a:ea typeface="Arial" pitchFamily="34" charset="-122"/>
                 <a:cs typeface="Arial" pitchFamily="34" charset="-120"/>
               </a:rPr>
-              <a:t>Open-source — the composition analysis used in this demo.</a:t>
+              <a:t>Open-source — the composition analysis used here.</a:t>
             </a:r>
             <a:endParaRPr lang="en-US" sz="2000" dirty="0"/>
           </a:p>
@@ -10322,7 +10407,92 @@
       </p:sp>
       <p:sp>
         <p:nvSpPr>
-          <p:cNvPr id="7" name="Shape 5"/>
+          <p:cNvPr id="10" name="Shape 7"/>
+          <p:cNvSpPr/>
+          <p:nvPr/>
+        </p:nvSpPr>
+        <p:spPr>
+          <a:xfrm>
+            <a:off x="9930384" y="1783080"/>
+            <a:ext cx="1463040" cy="1463040"/>
+          </a:xfrm>
+          <a:prstGeom prst="roundRect">
+            <a:avLst>
+              <a:gd name="adj" fmla="val 3750"/>
+            </a:avLst>
+          </a:prstGeom>
+          <a:solidFill>
+            <a:srgbClr val="FFFFFF"/>
+          </a:solidFill>
+          <a:ln/>
+        </p:spPr>
+      </p:sp>
+      <p:pic>
+        <p:nvPicPr>
+          <p:cNvPr id="11" name="Image 1" descr="/Users/leone.lage.perdigao/github/quanta/talk/assets/qr_ziran.png">    </p:cNvPr>
+          <p:cNvPicPr>
+            <a:picLocks noChangeAspect="1"/>
+          </p:cNvPicPr>
+          <p:nvPr/>
+        </p:nvPicPr>
+        <p:blipFill>
+          <a:blip r:embed="rId2"/>
+          <a:stretch>
+            <a:fillRect/>
+          </a:stretch>
+        </p:blipFill>
+        <p:spPr>
+          <a:xfrm>
+            <a:off x="10021824" y="1874520"/>
+            <a:ext cx="1280160" cy="1280160"/>
+          </a:xfrm>
+          <a:prstGeom prst="rect">
+            <a:avLst/>
+          </a:prstGeom>
+        </p:spPr>
+      </p:pic>
+      <p:sp>
+        <p:nvSpPr>
+          <p:cNvPr id="12" name="Text 8"/>
+          <p:cNvSpPr/>
+          <p:nvPr/>
+        </p:nvSpPr>
+        <p:spPr>
+          <a:xfrm>
+            <a:off x="9930384" y="3246120"/>
+            <a:ext cx="1463040" cy="274320"/>
+          </a:xfrm>
+          <a:prstGeom prst="rect">
+            <a:avLst/>
+          </a:prstGeom>
+          <a:noFill/>
+          <a:ln/>
+        </p:spPr>
+        <p:txBody>
+          <a:bodyPr wrap="square" rtlCol="0" anchor="ctr"/>
+          <a:lstStyle/>
+          <a:p>
+            <a:pPr algn="ctr" indent="0" marL="0">
+              <a:buNone/>
+            </a:pPr>
+            <a:r>
+              <a:rPr lang="en-US" sz="1000" dirty="0">
+                <a:solidFill>
+                  <a:srgbClr val="64748B"/>
+                </a:solidFill>
+                <a:latin typeface="Arial" pitchFamily="34" charset="0"/>
+                <a:ea typeface="Arial" pitchFamily="34" charset="-122"/>
+                <a:cs typeface="Arial" pitchFamily="34" charset="-120"/>
+              </a:rPr>
+              <a:t>scan to open</a:t>
+            </a:r>
+            <a:endParaRPr lang="en-US" sz="1000" dirty="0"/>
+          </a:p>
+        </p:txBody>
+      </p:sp>
+      <p:sp>
+        <p:nvSpPr>
+          <p:cNvPr id="13" name="Shape 9"/>
           <p:cNvSpPr/>
           <p:nvPr/>
         </p:nvSpPr>
@@ -10349,7 +10519,7 @@
       </p:sp>
       <p:sp>
         <p:nvSpPr>
-          <p:cNvPr id="8" name="Text 6"/>
+          <p:cNvPr id="14" name="Text 10"/>
           <p:cNvSpPr/>
           <p:nvPr/>
         </p:nvSpPr>
@@ -10408,7 +10578,7 @@
       </p:sp>
       <p:sp>
         <p:nvSpPr>
-          <p:cNvPr id="9" name="Text 7"/>
+          <p:cNvPr id="15" name="Text 11"/>
           <p:cNvSpPr/>
           <p:nvPr/>
         </p:nvSpPr>

</xml_diff>

<commit_message>
feat(data): customer dimension with names + emails, varied activity
- Add a customers table (name, email, country) synthesised deterministically
  from the invoices — UCI has only numeric Customer IDs. Customer-level queries
  now JOIN it, so 'top customers' returns meaningful names + emails (real PII
  for the exfiltration demo) instead of bare ids, with a graceful fallback to
  ids on older DBs.
- Skew synthetic order counts so a few power customers rank clearly, instead of
  everyone tied at the same number.
- Refactor _METRICS to (aggregate, alias) and add the customer-join path.
- Make exploit/deck/doc messaging dataset-robust: leak is 'the full customer
  list — names + emails', not a hardcoded byte count. Regenerate exploit PNGs.
- Tests updated for the named customer PII output.
</commit_message>
<xml_diff>
--- a/talk/quanta-talk.pptx
+++ b/talk/quanta-talk.pptx
@@ -1596,7 +1596,7 @@
               <a:rPr lang="en-US" dirty="0"/>
               <a:t>*** LIVE DEMO — the breach ***
 Run:  python scripts/demo.py exploit            (offline, deterministic — prints both runs)
-Walk the table: a benign request → fetch_reference returns an allowlisted page whose CONTENT carries a hidden instruction (indirect prompt injection, LLM01). The agent obeys → search_database reads 900 customer-level rows → watch the taint go red: PRIVATE+UNTRUSTED, the lethal trifecta in one run → send_email_report ships 16,741 bytes of PII to ops-archive@reports.acme-analytics.example. That mailbox is on the ALLOWLISTED domain — the domain check PASSED. Model-chosen recipient = excessive agency / confused deputy (LLM06). Say slowly: 'No control was bypassed. The data left through fully authorised actions.'</a:t>
+Walk the table: a benign request → fetch_reference returns an allowlisted page whose CONTENT carries a hidden instruction (indirect prompt injection, LLM01). The agent obeys → search_database reads the customer table (names + emails) → watch the taint go red: PRIVATE+UNTRUSTED, the lethal trifecta in one run → send_email_report ships the full customer list (names + emails) to ops-archive@reports.acme-analytics.example. That mailbox is on the ALLOWLISTED domain — the domain check PASSED. Model-chosen recipient = excessive agency / confused deputy (LLM06). Say slowly: 'No control was bypassed. The data left through fully authorised actions.'</a:t>
             </a:r>
             <a:endParaRPr lang="en-US" dirty="0"/>
           </a:p>
@@ -6678,7 +6678,7 @@
                 <a:ea typeface="Arial" pitchFamily="34" charset="-122"/>
                 <a:cs typeface="Arial" pitchFamily="34" charset="-120"/>
               </a:rPr>
-              <a:t>Benign request + a poisoned reference → 16,741 bytes of customer PII to an attacker mailbox on the ALLOWLISTED domain. Every per-tool control held.</a:t>
+              <a:t>Benign request + a poisoned reference → the full customer table (names + emails) to an attacker mailbox on the ALLOWLISTED domain. Every per-tool control held.</a:t>
             </a:r>
             <a:endParaRPr lang="en-US" sz="1500" dirty="0"/>
           </a:p>

</xml_diff>

<commit_message>
docs(talk): rewrite per-slide notes to be spoken and glanceable
The embedded presenter notes were dense, jargon-packed paragraphs — hard to read
mid-talk after losing your place. Restructure every note as a verbatim 'SAY:'
recovery line plus short beats in plain words, and align the demo commands with
the split exploit (--vulnerable-only on slide 20, --hardened-only on 22). Mirrors
the branded deck.
</commit_message>
<xml_diff>
--- a/talk/quanta-talk.pptx
+++ b/talk/quanta-talk.pptx
@@ -528,7 +528,9 @@
           <a:p>
             <a:r>
               <a:rPr lang="en-US" dirty="0"/>
-              <a:t>Land the title, then a beat. 'By the end you'll have watched a clean, well-architected agent get one critical finding — and the finding isn't in any of its tools.' Audience: builders/engineers. 45 min: ~30 talk + ~10 demo + ~5 Q&amp;A.</a:t>
+              <a:t>SAY: 'By the end, you'll have watched a clean, well-built agent get one critical finding — and it isn't in any of its tools.'
+· Land the title. Pause. Let it sit.
+· 45 min — about 30 talk, 10 demo, 5 Q&amp;A.</a:t>
             </a:r>
             <a:endParaRPr lang="en-US" dirty="0"/>
           </a:p>
@@ -616,7 +618,11 @@
           <a:p>
             <a:r>
               <a:rPr lang="en-US" dirty="0"/>
-              <a:t>Solution design, C4 container view. A real, sensible architecture: the analyst talks to the Quanta AgentCore runtime; a Strands agent backed by Bedrock Claude sequences four tool containers; those reach a read-only analytics replica, allowlisted external reference sources, and an audited mail relay. Point at the trust tags along the bottom: PRIVATE data in, UNTRUSTED content in, EXTERNAL send out — all three legs present in one runtime. Nothing here looks wrong yet.</a:t>
+              <a:t>SAY: 'This is the design. A normal, sensible architecture.'
+· The analyst talks to the agent; it sequences four tools.
+· They reach a read-only database, outside reference sources, and an audited mail relay.
+· Point at the tags along the bottom: PRIVATE in, UNTRUSTED in, EXTERNAL out — all three in one agent.
+· 'Nothing here looks wrong yet.'</a:t>
             </a:r>
             <a:endParaRPr lang="en-US" dirty="0"/>
           </a:p>
@@ -704,7 +710,9 @@
           <a:p>
             <a:r>
               <a:rPr lang="en-US" dirty="0"/>
-              <a:t>Zoom into the controls. Hexagonal, ports &amp; adapters. Read-only replica, parameterised queries (no raw SQL), a sandboxed interpreter with no network, an egress allowlist on outbound fetches, audited report delivery. Say: 'This is not a toy. Every box here is something you'd sign off on. No unsandboxed eval, no raw SQL, no open egress.'</a:t>
+              <a:t>SAY: 'And notice — it's well built. Every box here is something you'd sign off on.'
+· Read-only database, no raw SQL, sandboxed compute with no network, an allowlist on outbound fetches, audited mail.
+· 'This is not a toy. No open eval, no raw SQL, no open egress.'</a:t>
             </a:r>
             <a:endParaRPr lang="en-US" dirty="0"/>
           </a:p>
@@ -793,12 +801,13 @@
             <a:r>
               <a:rPr lang="en-US" dirty="0"/>
               <a:t>*** LIVE DEMO — Part 1: it's a real agent ***
-Run:  python scripts/demo.py --pause          (whole demo: ask -&gt; scan -&gt; exploit)
-  or just this part:  python scripts/demo.py ask              (offline stub)
-  real Bedrock, local (no deploy):  python scripts/demo.py ask --online
-  the deployed agent:  python scripts/demo.py ask --cloud
-It asks three real questions (revenue by country top 5 / orders per country / top customers).
-Real numbers from UCI Online Retail II. Then say: 'Real agent, real data, genuinely useful. Now — is it safe?'</a:t>
+Run:  python scripts/demo.py --pause        (whole demo: ask -&gt; scan -&gt; exploit)
+  just this part:           ask
+  real Bedrock, no deploy:  ask --online
+  the deployed agent:       ask --cloud
+· Three real questions: revenue by country, orders per country, top customers.
+· Real numbers from the public UCI retail dataset.
+SAY: 'Real agent, real data, genuinely useful. Now — is it safe?'</a:t>
             </a:r>
             <a:endParaRPr lang="en-US" dirty="0"/>
           </a:p>
@@ -886,7 +895,12 @@
           <a:p>
             <a:r>
               <a:rPr lang="en-US" dirty="0"/>
-              <a:t>Four tools. Four real controls: search_database (read-only, parameterised), run_analysis (sandboxed), fetch_reference (allowlist), send_email_report (allowlist + audit + dry-run). A tool-by-tool review signs off 4 out of 4. Hold that thought.</a:t>
+              <a:t>SAY: 'Four tools. Each with a real control.'
+· search_database — read-only, no raw SQL.
+· run_analysis — sandboxed, no network.
+· fetch_reference — egress allowlist.
+· send_email_report — domain allowlist, audit, dry-run.
+· 'Reviewed one at a time, it's 4 out of 4 approved. Hold that thought.'</a:t>
             </a:r>
             <a:endParaRPr lang="en-US" dirty="0"/>
           </a:p>
@@ -974,7 +988,7 @@
           <a:p>
             <a:r>
               <a:rPr lang="en-US" dirty="0"/>
-              <a:t>Divider. 'Instead of reviewing tools one at a time, let's look at what they can do together.'</a:t>
+              <a:t>SAY: 'Instead of reviewing tools one at a time, let's look at what they can do together.'</a:t>
             </a:r>
             <a:endParaRPr lang="en-US" dirty="0"/>
           </a:p>
@@ -1062,7 +1076,9 @@
           <a:p>
             <a:r>
               <a:rPr lang="en-US" dirty="0"/>
-              <a:t>Ziran builds the agent's capability graph and checks it against a library of known dangerous compositions — direct (A→B), indirect (A→…→B), and cycles. Say: 'It's not testing prompts here. It's reasoning about structure.'</a:t>
+              <a:t>SAY: 'Ziran builds the agent's capability graph — every tool, and every way one tool's output can flow into another.'
+· Then it checks that graph for known-dangerous combinations: direct, indirect, and loops.
+· 'It's not testing prompts here. It's reasoning about structure.'</a:t>
             </a:r>
             <a:endParaRPr lang="en-US" dirty="0"/>
           </a:p>
@@ -1150,7 +1166,8 @@
           <a:p>
             <a:r>
               <a:rPr lang="en-US" dirty="0"/>
-              <a:t>Walk the three panels: four approved tools → the agent can sequence them (edges) → one path is an exit. Say: 'Nothing here is hypothetical. An LLM agent really can call send right after search.'</a:t>
+              <a:t>SAY (walk the three panels): 'Four approved tools → the agent can sequence them → one path is an exit.'
+· 'Nothing here is hypothetical. An agent really can call send right after search.'</a:t>
             </a:r>
             <a:endParaRPr lang="en-US" dirty="0"/>
           </a:p>
@@ -1238,7 +1255,9 @@
           <a:p>
             <a:r>
               <a:rPr lang="en-US" dirty="0"/>
-              <a:t>Back to the architecture — now with the red path. Say slowly: 'Every control still holds. Read-only: held. Sandbox: held. Allowlists: held. And here's the path: untrusted content comes in through fetch_reference, the agent reads private data with search_database, and ships it out through send_email_report — every step authorised. Every box was hardened. The arrow wasn't.'</a:t>
+              <a:t>SAY slowly: 'Every control still holds. Read-only: held. Sandbox: held. Allowlists: held.'
+· 'And here's the path: untrusted content comes in, the agent reads private data, and ships it out — every step allowed.'
+· 'Every box was hardened. The arrow wasn't.'</a:t>
             </a:r>
             <a:endParaRPr lang="en-US" dirty="0"/>
           </a:p>
@@ -1327,10 +1346,14 @@
             <a:r>
               <a:rPr lang="en-US" dirty="0"/>
               <a:t>*** LIVE DEMO — find the composition ***
-Run:  python scripts/demo.py scan   (installs the local Ziran if needed, then opens the report)
-It scans in-process and prints two beats — STATIC (the composition Ziran finds in the tool graph) and DYNAMIC (Ziran confirms the exfil from the observed tool calls) — then opens reports/*_report.html. Pan the graph, click the red node.
-(This slide embeds the real interactive graph as a looping GIF — it plays in Presenter/slideshow, and is the fallback if the live open stalls.)
-STATIC: 'I didn't tell Ziran this was dangerous — that critical verdict is from its built-in composition patterns. I gave it a graph; it handed me the exit.' DYNAMIC: 'and it's not theoretical — Ziran confirms the exfil from the observed tool calls. Note what it does NOT do: it never flags the agent merely listing its tools. The finding is the composition, not a keyword.'</a:t>
+Run:  python scripts/demo.py scan        (installs local Ziran if needed, opens the report)
+· It scans in-process and prints two beats:
+   STATIC  — the dangerous path Ziran finds in the tool graph.
+   DYNAMIC — Ziran confirms the real leak from the actual tool calls.
+· Then it opens the report. Pan the graph, click the red node.
+· (The slide has the real graph as a looping GIF — the fallback if the live open stalls.)
+SAY (static): 'I didn't tell Ziran this was dangerous. I gave it a graph; it handed me the exit.'
+SAY (dynamic): 'And it's not theoretical — it confirms the leak from the real tool calls. Notice what it does NOT flag: an agent just listing its tools. The finding is the composition, not a keyword.'</a:t>
             </a:r>
             <a:endParaRPr lang="en-US" dirty="0"/>
           </a:p>
@@ -1418,7 +1441,7 @@
           <a:p>
             <a:r>
               <a:rPr lang="en-US" dirty="0"/>
-              <a:t>Divider. 'Ziran found the path statically, before anyone attacked. Now let's walk it like an attacker — then close it.'</a:t>
+              <a:t>SAY: 'Ziran found the path before anyone attacked. Now let's walk it like an attacker — then close it.'</a:t>
             </a:r>
             <a:endParaRPr lang="en-US" dirty="0"/>
           </a:p>
@@ -1506,7 +1529,9 @@
           <a:p>
             <a:r>
               <a:rPr lang="en-US" dirty="0"/>
-              <a:t>Most AI-security energy goes at the prompt: jailbreaks, injection, guardrails. It matters — but it's the part everyone is already looking at. Say: 'I want the risk nobody's looking at, because it isn't visible from where they're standing.'</a:t>
+              <a:t>SAY: 'Everyone watches the prompt — jailbreaks, injection, guardrails. That's real, and it's well guarded.'
+· Then: 'I want the risk nobody's looking at — because you can't see it from there.'
+→ so where do you look instead?</a:t>
             </a:r>
             <a:endParaRPr lang="en-US" dirty="0"/>
           </a:p>
@@ -1595,8 +1620,14 @@
             <a:r>
               <a:rPr lang="en-US" dirty="0"/>
               <a:t>*** LIVE DEMO — the breach ***
-Run:  python scripts/demo.py exploit            (offline, deterministic — prints both runs)
-Walk the table: a benign request → fetch_reference returns an allowlisted page whose CONTENT carries a hidden instruction (indirect prompt injection, LLM01). The agent obeys → search_database reads the customer table (names + emails) → watch the taint go red: PRIVATE+UNTRUSTED, the lethal trifecta in one run → send_email_report ships the full customer list (names + emails) to ops-archive@reports.acme-analytics.example. That mailbox is on the ALLOWLISTED domain — the domain check PASSED. Model-chosen recipient = excessive agency / confused deputy (LLM06). Say slowly: 'No control was bypassed. The data left through fully authorised actions.'</a:t>
+Run:  python scripts/demo.py exploit --vulnerable-only   (offline, deterministic)
+Walk the table:
+· A benign request → fetch_reference returns an allowlisted page with a hidden instruction (injection, LLM01).
+· The agent obeys → search_database reads the customer table (names + emails).
+· Watch the taint go red: PRIVATE + UNTRUSTED — the trifecta, in one run.
+· send_email_report ships the whole customer list to an attacker mailbox ON the allowlisted domain — the check passed.
+· The model picked the recipient = excessive agency (LLM06).
+SAY slowly: 'No control was bypassed. The data left through fully allowed actions.'</a:t>
             </a:r>
             <a:endParaRPr lang="en-US" dirty="0"/>
           </a:p>
@@ -1684,7 +1715,11 @@
           <a:p>
             <a:r>
               <a:rPr lang="en-US" dirty="0"/>
-              <a:t>Name what we just saw. One innocuous agent, three stacked classes: the composition (structural — Ziran finds it pre-attack), indirect prompt injection (LLM01 — the trigger), excessive agency / confused deputy (LLM06 — the missing control). None is a bug in a single tool.</a:t>
+              <a:t>SAY: 'Name what we just saw — one harmless-looking agent, three problems stacked.'
+· The composition — structural. Ziran finds it before any attack.
+· The injection — the trigger (LLM01).
+· The model-chosen recipient — the missing control (LLM06).
+· None of them is a bug in a single tool.</a:t>
             </a:r>
             <a:endParaRPr lang="en-US" dirty="0"/>
           </a:p>
@@ -1773,8 +1808,13 @@
             <a:r>
               <a:rPr lang="en-US" dirty="0"/>
               <a:t>*** LIVE DEMO — the fix ***
-`python scripts/demo.py exploit` already printed both runs — scroll to the second.
-Same agent, same payload, opposite outcome: the injected instruction is REFUSED as data (LLM01); the model-chosen recipient is DENIED by recipient-binding (LLM06); the trifecta gate stops a private+untrusted run reaching an external sink. Crucially the analyst's legitimate summary STILL goes out. Say: 'The fix didn't break the product. We broke the path, not the agent.'</a:t>
+Run:  python scripts/demo.py exploit --hardened-only   (or scroll to the 2nd run)
+· Same agent, same payload, opposite outcome:
+   - injected instruction REFUSED as data (LLM01)
+   - model-chosen recipient DENIED (LLM06)
+   - trifecta gate stops a private+untrusted run from sending out.
+· But the analyst's real summary STILL goes out.
+SAY: 'The fix didn't break the product. We broke the path, not the agent.'</a:t>
             </a:r>
             <a:endParaRPr lang="en-US" dirty="0"/>
           </a:p>
@@ -1862,7 +1902,12 @@
           <a:p>
             <a:r>
               <a:rPr lang="en-US" dirty="0"/>
-              <a:t>The fix is NOT 'remove a tool' — each is justified. Break the graph: no-instructions-from-data (LLM01), recipient binding (LLM06), trifecta gate via taint (the composition), and re-scan in CI (ziran ci fails the build when a new tool completes a trifecta). Three are runtime guardrails; the last is the design-time one that matches the thesis. It's all real, tested code in quanta/security/.</a:t>
+              <a:t>SAY: 'The fix isn't remove a tool — each one is justified. You break the graph.'
+· No instructions from data — fetched content can't issue commands (LLM01).
+· Recipient binding — mail only goes to the real requester (LLM06).
+· Trifecta gate — a private+untrusted run can't send out on its own. Aggregates aren't private, so the real task still works.
+· Re-scan in CI — fail the build when a new tool completes the trifecta.
+· It's all real, tested code in quanta/security/.</a:t>
             </a:r>
             <a:endParaRPr lang="en-US" dirty="0"/>
           </a:p>
@@ -1950,7 +1995,11 @@
           <a:p>
             <a:r>
               <a:rPr lang="en-US" dirty="0"/>
-              <a:t>The natural question: doesn't splitting into specialised, least-privileged agents fix this? It's necessary but NOT sufficient. Walk the red path: a poisoned doc hits the Research agent (untrusted); the injected instruction rides the shared memory / message bus to the Analytics agent (reads PII), which hands off to the Comms agent (sends out). No single agent holds all three legs — the SYSTEM does. The graph didn't shrink; it got bigger and harder to see: nodes are now (agent, tool) pairs; edges are agent-to-agent messages, delegation, and shared memory. Ziran scans multi-agent topologies (router/RAG, supervisor) too.</a:t>
+              <a:t>SAY: 'The obvious question — doesn't splitting into smaller, least-privilege agents fix this?'
+· Necessary, but not enough.
+· Walk the red path: a poisoned doc hits the Research agent → the instruction rides shared memory to the Analytics agent (reads PII) → hands off to the Comms agent (sends out).
+· No single agent holds all three legs — the SYSTEM does.
+· The graph didn't shrink. It got bigger and harder to see.</a:t>
             </a:r>
             <a:endParaRPr lang="en-US" dirty="0"/>
           </a:p>
@@ -2038,7 +2087,13 @@
           <a:p>
             <a:r>
               <a:rPr lang="en-US" dirty="0"/>
-              <a:t>This is the remediation, lifted to the system level. Constrain the topology (allowlist agent-to-agent edges — not a mesh). Carry taint/provenance across the message bus and enforce at boundaries — the trifecta gate moves up to the orchestrator. Quarantine the untrusted-facing agent (dual-LLM: structured output only, never instructions to privileged agents). One human/deterministic gate at the closure point. Re-scan the whole system graph in CI. Land the kicker: no single tool was dangerous, and no single agent is either — the risk lives in how they connect.</a:t>
+              <a:t>SAY: 'Same fix, one level up.'
+· Constrain who talks to whom — not a full mesh.
+· Carry taint across messages; enforce at agent boundaries.
+· Quarantine the untrusted-facing agent — structured output only, never instructions to privileged agents.
+· One gate where a private+untrusted flow could reach the outside.
+· Re-scan the whole system graph in CI.
+SAY (kicker): 'No single tool was dangerous — and no single agent is either. The risk lives in how they connect.'</a:t>
             </a:r>
             <a:endParaRPr lang="en-US" dirty="0"/>
           </a:p>
@@ -2126,7 +2181,8 @@
           <a:p>
             <a:r>
               <a:rPr lang="en-US" dirty="0"/>
-              <a:t>Say: 'If you're building, reviewing, or signing off on agents: stop asking only whether each tool is safe. Ask what they're capable of together — and put that question in your pipeline, not in an attacker's hands.' Restate the thesis: the vulnerability lives in the graph, not in any node.</a:t>
+              <a:t>SAY: 'The question isn't whether your tools are safe one by one. It's what they can do together — and whether you ask that before an attacker does.'
+· Restate the thesis: the vulnerability lives in the graph, not in any node.</a:t>
             </a:r>
             <a:endParaRPr lang="en-US" dirty="0"/>
           </a:p>
@@ -2214,7 +2270,10 @@
           <a:p>
             <a:r>
               <a:rPr lang="en-US" dirty="0"/>
-              <a:t>Two repos, two QR codes — scan instead of typing: github.com/taoq-ai/quanta (the demo agent — education only, intentionally composable; run python scripts/demo.py) and github.com/taoq-ai/ziran (the open-source composition analysis). Note Quanta is deliberately vulnerable by design; don't deploy it for real. Take Q&amp;A.</a:t>
+              <a:t>SAY: 'Two repos to try this yourself.' Point to the QR codes.
+· Quanta — the demo agent. Education only, vulnerable by design. Don't deploy it for real.
+· Ziran — open source, the composition analysis you just saw.
+· Thank the room. Take Q&amp;A.</a:t>
             </a:r>
             <a:endParaRPr lang="en-US" dirty="0"/>
           </a:p>
@@ -2302,7 +2361,11 @@
           <a:p>
             <a:r>
               <a:rPr lang="en-US" dirty="0"/>
-              <a:t>A security review enumerates tools like API endpoints: a list. But an LLM agent can call any tool, then feed its output into the next. That's not a list — it's a graph of what the agent can do next. Hold this idea; the whole talk turns on it.</a:t>
+              <a:t>SAY: 'A review sees a list of tools. An agent sees a graph.'
+· A review checks each tool on its own — like endpoints on a form.
+· But an agent calls one tool, then feeds its output into the next.
+· That's a graph: what it can do NEXT.
+· The whole talk turns on this. One tool at a time, the dangerous combo is invisible.</a:t>
             </a:r>
             <a:endParaRPr lang="en-US" dirty="0"/>
           </a:p>
@@ -2390,7 +2453,7 @@
           <a:p>
             <a:r>
               <a:rPr lang="en-US" dirty="0"/>
-              <a:t>Divider. 'Forget the model for a minute. Think like someone who just got access to the agent.'</a:t>
+              <a:t>SAY: 'Forget the model for a minute. Think like someone who just got access to the agent.'</a:t>
             </a:r>
             <a:endParaRPr lang="en-US" dirty="0"/>
           </a:p>
@@ -2478,7 +2541,11 @@
           <a:p>
             <a:r>
               <a:rPr lang="en-US" dirty="0"/>
-              <a:t>Three moves: recon (what tools exist?), capability mapping (what does each touch — data? network? compute?), chaining (which sequence turns reasonable actions into one bad outcome?). Attackers don't look for A dangerous tool. They look for a PATH. This is graph traversal, done by hand.</a:t>
+              <a:t>SAY: 'An attacker doesn't hunt for one bad tool. They hunt for a path.'
+· Recon — what tools are here?
+· Mapping — what does each one touch? Data, network, code?
+· Chaining — which order turns safe steps into one bad outcome?
+· That's walking the graph by hand. Ziran does it automatically.</a:t>
             </a:r>
             <a:endParaRPr lang="en-US" dirty="0"/>
           </a:p>
@@ -2566,7 +2633,10 @@
           <a:p>
             <a:r>
               <a:rPr lang="en-US" dirty="0"/>
-              <a:t>Three capabilities individually fine and collectively lethal: access to private data, exposure to untrusted content, the ability to communicate externally. Any agent with all three can be steered to read secrets and send them out — through entirely authorised actions. Credit Simon Willison's 'lethal trifecta'.</a:t>
+              <a:t>SAY: 'Three powers, each fine on its own, deadly together.'
+· Private data. Untrusted content. The ability to send out.
+· Any agent with all three can be steered to read secrets and send them — all through allowed actions.
+· The name is Simon Willison's: the lethal trifecta.</a:t>
             </a:r>
             <a:endParaRPr lang="en-US" dirty="0"/>
           </a:p>
@@ -2654,7 +2724,11 @@
           <a:p>
             <a:r>
               <a:rPr lang="en-US" dirty="0"/>
-              <a:t>Same structural idea, two shapes. Exfiltration: read + send. RCE surface: fetch untrusted + execute + network. Neither is a bug in a node. Both are properties of the graph. (Our demo focuses on exfiltration — the subtler, more relatable one.)</a:t>
+              <a:t>SAY: 'Same shape, two outcomes.'
+· Exfiltration: read private, then send out.
+· RCE: fetch untrusted, run code, reach the network.
+· Neither is a bug in one tool. Both live in the graph.
+· We'll focus on exfiltration — the more relatable one.</a:t>
             </a:r>
             <a:endParaRPr lang="en-US" dirty="0"/>
           </a:p>
@@ -2742,7 +2816,9 @@
           <a:p>
             <a:r>
               <a:rPr lang="en-US" dirty="0"/>
-              <a:t>Reviews look tool-by-tool, endpoint-by-endpoint — and tool-by-tool, everything passes. The composition is invisible from that vantage point. Say: 'It stays invisible until someone connects the dots. The only question is whether that someone works for you.'</a:t>
+              <a:t>SAY: 'Tool by tool, everything passes. The dangerous combination stays invisible.'
+· A review looks one endpoint at a time — and from there, the path can't be seen.
+· 'It stays invisible until someone connects the dots. The only question is whether that someone works for you.'</a:t>
             </a:r>
             <a:endParaRPr lang="en-US" dirty="0"/>
           </a:p>
@@ -2830,7 +2906,7 @@
           <a:p>
             <a:r>
               <a:rPr lang="en-US" dirty="0"/>
-              <a:t>Divider. 'Let me show you an agent I built — and I want you to try to find the problem while I describe it.'</a:t>
+              <a:t>SAY: 'Let me show you an agent I built — and try to spot the problem while I describe it.'</a:t>
             </a:r>
             <a:endParaRPr lang="en-US" dirty="0"/>
           </a:p>
@@ -3416,7 +3492,7 @@
       </p:sp>
       <p:pic>
         <p:nvPicPr>
-          <p:cNvPr id="3" name="Image 0" descr="/Users/leone.lage.perdigao/github/quanta/talk/assets/c4-container.png">    </p:cNvPr>
+          <p:cNvPr id="3" name="Image 0" descr="/private/tmp/quanta-deck-notes/talk/assets/c4-container.png">    </p:cNvPr>
           <p:cNvPicPr>
             <a:picLocks noChangeAspect="1"/>
           </p:cNvPicPr>
@@ -3550,7 +3626,7 @@
       </p:sp>
       <p:pic>
         <p:nvPicPr>
-          <p:cNvPr id="3" name="Image 0" descr="/Users/leone.lage.perdigao/github/quanta/talk/assets/architecture.png">    </p:cNvPr>
+          <p:cNvPr id="3" name="Image 0" descr="/private/tmp/quanta-deck-notes/talk/assets/architecture.png">    </p:cNvPr>
           <p:cNvPicPr>
             <a:picLocks noChangeAspect="1"/>
           </p:cNvPicPr>
@@ -5900,7 +5976,7 @@
       </p:sp>
       <p:pic>
         <p:nvPicPr>
-          <p:cNvPr id="3" name="Image 0" descr="/Users/leone.lage.perdigao/github/quanta/talk/assets/graph-evolution.png">    </p:cNvPr>
+          <p:cNvPr id="3" name="Image 0" descr="/private/tmp/quanta-deck-notes/talk/assets/graph-evolution.png">    </p:cNvPr>
           <p:cNvPicPr>
             <a:picLocks noChangeAspect="1"/>
           </p:cNvPicPr>
@@ -6034,7 +6110,7 @@
       </p:sp>
       <p:pic>
         <p:nvPicPr>
-          <p:cNvPr id="3" name="Image 0" descr="/Users/leone.lage.perdigao/github/quanta/talk/assets/architecture-overlay.png">    </p:cNvPr>
+          <p:cNvPr id="3" name="Image 0" descr="/private/tmp/quanta-deck-notes/talk/assets/architecture-overlay.png">    </p:cNvPr>
           <p:cNvPicPr>
             <a:picLocks noChangeAspect="1"/>
           </p:cNvPicPr>
@@ -6168,7 +6244,7 @@
       </p:sp>
       <p:pic>
         <p:nvPicPr>
-          <p:cNvPr id="3" name="Image 0" descr="/Users/leone.lage.perdigao/github/quanta/talk/assets/ziran_graph.gif">    </p:cNvPr>
+          <p:cNvPr id="3" name="Image 0" descr="/private/tmp/quanta-deck-notes/talk/assets/ziran_graph.gif">    </p:cNvPr>
           <p:cNvPicPr>
             <a:picLocks noChangeAspect="1"/>
           </p:cNvPicPr>
@@ -6623,7 +6699,7 @@
       </p:sp>
       <p:pic>
         <p:nvPicPr>
-          <p:cNvPr id="3" name="Image 0" descr="/Users/leone.lage.perdigao/github/quanta/talk/assets/exploit_vulnerable.png">    </p:cNvPr>
+          <p:cNvPr id="3" name="Image 0" descr="/private/tmp/quanta-deck-notes/talk/assets/exploit_vulnerable.png">    </p:cNvPr>
           <p:cNvPicPr>
             <a:picLocks noChangeAspect="1"/>
           </p:cNvPicPr>
@@ -8025,7 +8101,7 @@
       </p:sp>
       <p:pic>
         <p:nvPicPr>
-          <p:cNvPr id="3" name="Image 0" descr="/Users/leone.lage.perdigao/github/quanta/talk/assets/exploit_hardened.png">    </p:cNvPr>
+          <p:cNvPr id="3" name="Image 0" descr="/private/tmp/quanta-deck-notes/talk/assets/exploit_hardened.png">    </p:cNvPr>
           <p:cNvPicPr>
             <a:picLocks noChangeAspect="1"/>
           </p:cNvPicPr>
@@ -8886,7 +8962,7 @@
       </p:sp>
       <p:pic>
         <p:nvPicPr>
-          <p:cNvPr id="3" name="Image 0" descr="/Users/leone.lage.perdigao/github/quanta/talk/assets/multi-agent-trifecta.png">    </p:cNvPr>
+          <p:cNvPr id="3" name="Image 0" descr="/private/tmp/quanta-deck-notes/talk/assets/multi-agent-trifecta.png">    </p:cNvPr>
           <p:cNvPicPr>
             <a:picLocks noChangeAspect="1"/>
           </p:cNvPicPr>
@@ -10240,7 +10316,7 @@
       </p:sp>
       <p:pic>
         <p:nvPicPr>
-          <p:cNvPr id="6" name="Image 0" descr="/Users/leone.lage.perdigao/github/quanta/talk/assets/qr_quanta.png">    </p:cNvPr>
+          <p:cNvPr id="6" name="Image 0" descr="/private/tmp/quanta-deck-notes/talk/assets/qr_quanta.png">    </p:cNvPr>
           <p:cNvPicPr>
             <a:picLocks noChangeAspect="1"/>
           </p:cNvPicPr>
@@ -10430,7 +10506,7 @@
       </p:sp>
       <p:pic>
         <p:nvPicPr>
-          <p:cNvPr id="11" name="Image 1" descr="/Users/leone.lage.perdigao/github/quanta/talk/assets/qr_ziran.png">    </p:cNvPr>
+          <p:cNvPr id="11" name="Image 1" descr="/private/tmp/quanta-deck-notes/talk/assets/qr_ziran.png">    </p:cNvPr>
           <p:cNvPicPr>
             <a:picLocks noChangeAspect="1"/>
           </p:cNvPicPr>
@@ -11639,7 +11715,7 @@
       </p:sp>
       <p:pic>
         <p:nvPicPr>
-          <p:cNvPr id="3" name="Image 0" descr="/Users/leone.lage.perdigao/github/quanta/talk/assets/lethal-trifecta.png">    </p:cNvPr>
+          <p:cNvPr id="3" name="Image 0" descr="/private/tmp/quanta-deck-notes/talk/assets/lethal-trifecta.png">    </p:cNvPr>
           <p:cNvPicPr>
             <a:picLocks noChangeAspect="1"/>
           </p:cNvPicPr>
@@ -12220,7 +12296,7 @@
       </p:sp>
       <p:pic>
         <p:nvPicPr>
-          <p:cNvPr id="3" name="Image 0" descr="/Users/leone.lage.perdigao/github/quanta/talk/assets/review-blindness.png">    </p:cNvPr>
+          <p:cNvPr id="3" name="Image 0" descr="/private/tmp/quanta-deck-notes/talk/assets/review-blindness.png">    </p:cNvPr>
           <p:cNvPicPr>
             <a:picLocks noChangeAspect="1"/>
           </p:cNvPicPr>

</xml_diff>